<commit_message>
Knowledge graph panel on the map, held out eval results, pitch updates
- Map detail for a match shows its knowledge graph neighbours (units, heads,
  colleagues, projects, facilities), linking to other matches on the map
- Selected branch drawn in red
- README and eval.md: held out split and synthetic run results
- Pitch decks refreshed

Co-Authored-By: Claude Opus 5.5 <noreply@anthropic.com>
Claude-Session: https://claude.ai/code/session_01GikmnfNnfPnkzhwdcwDfux
</commit_message>
<xml_diff>
--- a/research/Mutz_Pitch_lean_animated.pptx
+++ b/research/Mutz_Pitch_lean_animated.pptx
@@ -759,13 +759,13 @@
           <a:p/>
           <a:p>
             <a:r>
-              <a:t>"Here are our results, measured on questions we never tuned on. [XX]% of the time the right expert is in the top 10. Lay words and expert jargon find the same people [XX]% of the time. And zero facts without a source."</a:t>
+              <a:t>"Our results, on questions we never tuned on: in 21 out of 23, the right expert is in the top 10. Plain-language questions: 10 out of 11. And every one of our 19,631 facts links back to the page it came from."</a:t>
             </a:r>
           </a:p>
           <a:p/>
           <a:p>
             <a:r>
-              <a:t>Replace every [XX] with the numbers from your single held-out run. Change "0" only if your verifier really measured 0 of N. Details: backup slide "We measured it on questions we never tuned on".</a:t>
+              <a:t>Numbers from the single held-out run on 19 Oct 2026 (data/eval/latest_heldout.json, logged in data/eval/heldout_runs.jsonl). 91% = questions with at least one right expert in the top 10. Recall@10 (share of all expected groups found) is 89%. Dev split, which we tuned on: 88%. Details: backup slide "We measured it on questions we never tuned on".</a:t>
             </a:r>
           </a:p>
         </p:txBody>
@@ -1063,36 +1063,45 @@
           <a:lstStyle/>
           <a:p>
             <a:r>
-              <a:t>[3:40–4:05] Speaker B (the technical person).</a:t>
+              <a:t>[Q&amp;A] Speaker B (the technical person).</a:t>
             </a:r>
           </a:p>
           <a:p/>
           <a:p>
             <a:r>
-              <a:t>"Most teams will tell you their system works. We measured it, on questions we never tuned on.</a:t>
+              <a:t>"We measured it on questions we never tuned on. 21 of 23 held-out questions have the right expert in the top 10. Plain-language questions: 10 of 11. No fact without a source. And here's our weakest category: funding. The one held-out funding question is missed by search; in the app, funding needs are answered from a checked list of Bern programmes."</a:t>
             </a:r>
           </a:p>
           <a:p/>
           <a:p>
             <a:r>
-              <a:t>[XX]% of the time the right expert is in the top 10. Lay words and expert jargon find the same people [XX]% of the time. Zero of [N] facts without a verified quote. And here's our weakest category, because you should know where it struggles.</a:t>
+              <a:t>If asked:</a:t>
+            </a:r>
+          </a:p>
+          <a:p>
+            <a:r>
+              <a:t>- Recall@10: held-out 89%, dev 88%, synthetic 68% (47 lay queries Apertus wrote for single small units; harder, and optimistic because Apertus also expands our queries).</a:t>
+            </a:r>
+          </a:p>
+          <a:p>
+            <a:r>
+              <a:t>- Held-out misses: tc12 "AI to plan cancer radiation treatment" (those affiliated groups are only listed on an ARTORG index page that links to Insel pages we don't crawl), tc22 startup funding, tc25 contact details for the head of MSL.</a:t>
+            </a:r>
+          </a:p>
+          <a:p>
+            <a:r>
+              <a:t>- 19,631 facts: 19,630 carry a quote verified on the page; one unit name comes from the page URL. Reasons shown in results: 100% quote their page.</a:t>
+            </a:r>
+          </a:p>
+          <a:p>
+            <a:r>
+              <a:t>- Weakest sources on held-out: ARTORG and DCB, 67% each.</a:t>
             </a:r>
           </a:p>
           <a:p/>
           <a:p>
             <a:r>
-              <a:t>If you want, type your own question right now."</a:t>
-            </a:r>
-          </a:p>
-          <a:p/>
-          <a:p>
-            <a:r>
-              <a:t>Beginners: "8 times out of 10, the right person is on the first page" (adapt to your number).</a:t>
-            </a:r>
-          </a:p>
-          <a:p>
-            <a:r>
-              <a:t>Only offer the live question if the 'no match' path is solid. Replace ALL [XX] / [N] with the numbers from the single held-out run after the freeze. Never round up.</a:t>
+              <a:t>Only offer the live question if the "no match" path is solid.</a:t>
             </a:r>
           </a:p>
         </p:txBody>
@@ -1162,13 +1171,13 @@
           <a:lstStyle/>
           <a:p>
             <a:r>
-              <a:t>[4:05–4:25] Speaker A.</a:t>
+              <a:t>[Q&amp;A] Speaker A.</a:t>
             </a:r>
           </a:p>
           <a:p/>
           <a:p>
             <a:r>
-              <a:t>"Remember: 'we cannot put it onto any model.' So we drew a hard line. Anything confidential, the one-pager and the officer's notes, only ever goes to Apertus, the Swiss open model, running at CSCS in Switzerland. Partner models only ever see public web text.</a:t>
+              <a:t>"Remember: 'we cannot put it onto any model.' So we drew a hard line. Anything confidential, the one-pager and the officer's notes, only goes to Apertus, the Swiss open model, running at CSCS in Switzerland. Salaries, revenue and contact details are struck out locally before that. The other models, the embeddings and the reranker, run inside our own container: no third-party model API at all.</a:t>
             </a:r>
           </a:p>
           <a:p/>
@@ -1180,7 +1189,7 @@
           <a:p/>
           <a:p>
             <a:r>
-              <a:t>Expert note: routing rule enforced in code; gateway calls logged with model and token counts; self-hosted path = docker compose on one GPU box with vLLM.</a:t>
+              <a:t>Expert note: every gateway call is logged with model and token counts (logs/gateway.jsonl). The shared demo runs on Cloud Run in europe-west6 (Zurich); in production the agency would host the container itself.</a:t>
             </a:r>
           </a:p>
         </p:txBody>
@@ -1250,7 +1259,7 @@
           <a:lstStyle/>
           <a:p>
             <a:r>
-              <a:t>[2:50–3:20] Speaker B, live. This is the 'wow' sequence.</a:t>
+              <a:t>[Q&amp;A] Speaker B.</a:t>
             </a:r>
           </a:p>
           <a:p/>
@@ -1262,19 +1271,19 @@
           <a:p/>
           <a:p>
             <a:r>
-              <a:t>Now watch. We add a new archive, sitem-insel, with six lines of config... (run ingest, cached)... and Mutz pops up: 'New archive checked. Two open cases have new matches.' Bern's research never sits idle: when a new group or project appears, the companies waiting for it find it."</a:t>
+              <a:t>Today, when a company sends more information, Mutz re-checks only the needs that changed. The next step is the alert on the right: add a source or re-crawl, and every open case is re-checked, with a note like 'New archive checked. 2 open cases have new matches.'"</a:t>
             </a:r>
           </a:p>
           <a:p/>
           <a:p>
             <a:r>
-              <a:t>Stage tip: prepare the 4th source and one demo case that really matches it. Cap the demo source at ~30 pages or pre-run it; say "we ran the crawl earlier" if it's cached.</a:t>
+              <a:t>HONESTY: the alert is a mock-up of the next step. It is not built; don't demo it.</a:t>
             </a:r>
           </a:p>
           <a:p/>
           <a:p>
             <a:r>
-              <a:t>Expert note: after each ingest, every open case's needs are re-run; the top-10 and coverage are diffed against a stored snapshot; new entries or a coverage upgrade create an alert. In production a nightly re-crawl triggers it.</a:t>
+              <a:t>How we'd build it: after each ingest, re-run every open case's needs, diff the top 10 and coverage against a stored snapshot, and raise an alert on new entries or a coverage upgrade. In production a nightly re-crawl triggers it.</a:t>
             </a:r>
           </a:p>
         </p:txBody>
@@ -1344,7 +1353,7 @@
           <a:lstStyle/>
           <a:p>
             <a:r>
-              <a:t>[3:20–3:40] Speaker A.</a:t>
+              <a:t>[Q&amp;A] Speaker A.</a:t>
             </a:r>
           </a:p>
           <a:p/>
@@ -1356,19 +1365,19 @@
           <a:p/>
           <a:p>
             <a:r>
-              <a:t>Left: a word cloud of Bern's expertise. The bigger the word, the more verified pages back it. Useful for deciding which leads to bid on, and for the agency's own outreach abroad.</a:t>
+              <a:t>Left: a word cloud of Bern's expertise. The bigger the word, the more verified pages back it.</a:t>
             </a:r>
           </a:p>
           <a:p/>
           <a:p>
             <a:r>
-              <a:t>Right: a gap report. Every empty honey pot is a data point. 'This year, leads kept asking for battery technology and Bern had nothing.' That is information for the canton's economic strategy."</a:t>
+              <a:t>Right: a gap report. Every empty honey pot is a data point. In our test data, battery technology came up in 9 leads and every one ended in an empty pot. That is information for the canton's economic strategy."</a:t>
             </a:r>
           </a:p>
           <a:p/>
           <a:p>
             <a:r>
-              <a:t>HONESTY: the map only covers crawled archives (grey = not crawled yet). The gap bars and [XX] are placeholders: fill them from your test runs and SAY they are test data. Update the field states from your real crawl before the pitch.</a:t>
+              <a:t>HONESTY: the bars come from the Insights screen, and 62 of its 81 leads are seeded demo leads, so say it's test data. Small batch manufacturing (18 empty of 26) may be a source we haven't crawled rather than a real gap in Bern; Insights flags it that way.</a:t>
             </a:r>
           </a:p>
         </p:txBody>
@@ -1438,25 +1447,35 @@
           <a:lstStyle/>
           <a:p>
             <a:r>
-              <a:t>[4:25–4:40] Speaker B.</a:t>
+              <a:t>[Q&amp;A] Speaker B.</a:t>
             </a:r>
           </a:p>
           <a:p/>
           <a:p>
             <a:r>
-              <a:t>"Scaling to all of Bern doesn't need new code. A new archive is six lines of config. We started with life science and medtech, because that's where the agency told us Bern is strongest.</a:t>
+              <a:t>"Scaling to all of Bern doesn't need new code. A new archive is six lines of config, and the Archives screen writes them for you from a URL. We started with life science and medtech, because that's where the agency told us Bern is strongest.</a:t>
             </a:r>
           </a:p>
           <a:p/>
           <a:p>
             <a:r>
-              <a:t>The value: we measured [X] hours saved per case. Times 300 cases a year, that's [XXX] officer hours back. And it costs [XX] tokens per case."</a:t>
+              <a:t>A search for one need takes about ten seconds, and a full case costs about 35,000 Apertus tokens."</a:t>
             </a:r>
           </a:p>
           <a:p/>
           <a:p>
             <a:r>
-              <a:t>Fill [X], [XXX], [XX] with your own measurements (time a manual search vs. the tool on 3 cases). Check sitem-insel's real URL before the pitch.</a:t>
+              <a:t>Measured: ≈10 s is the mean search time per question in the held-out eval (9.7 s; dev 6.5 s), with gateway answers partly cached. ≈35k tokens is an estimate from logs/gateway.jsonl averages: needs extraction ~2.1k, ~6.4k per need (expansion plus 14 Apertus grading calls) for ~4 needs, pitch ~7.7k.</a:t>
+            </a:r>
+          </a:p>
+          <a:p>
+            <a:r>
+              <a:t>Hours saved per case are not measured. Time a manual search against the tool on 3 cases before claiming any.</a:t>
+            </a:r>
+          </a:p>
+          <a:p>
+            <a:r>
+              <a:t>www.sitem-insel.ch redirects to sitem-insel.ch, so the entry uses the bare domain.</a:t>
             </a:r>
           </a:p>
         </p:txBody>
@@ -2174,40 +2193,46 @@
           <a:p/>
           <a:p>
             <a:r>
-              <a:t>Script to be planned. Demo beats, in order:</a:t>
-            </a:r>
-          </a:p>
-          <a:p>
-            <a:r>
-              <a:t>1. Case list: the officer's Monday morning.</a:t>
-            </a:r>
-          </a:p>
-          <a:p>
-            <a:r>
-              <a:t>2. Paste the one-pager: Apertus pulls out the needs.</a:t>
-            </a:r>
-          </a:p>
-          <a:p>
-            <a:r>
-              <a:t>3. Matches with a plain reason. CLICK A REASON: the source page opens at the exact sentence. Pause.</a:t>
-            </a:r>
-          </a:p>
-          <a:p>
-            <a:r>
-              <a:t>4. Accept two, reject one. Export the CEO teaser.</a:t>
-            </a:r>
-          </a:p>
-          <a:p>
-            <a:r>
-              <a:t>5. Weak field ("battery recycling"): empty honey pot, "Kei Hung im Topf".</a:t>
-            </a:r>
-          </a:p>
-          <a:p>
-            <a:r>
-              <a:t>6. Add a source: Mutz alert, "2 open cases have new matches".</a:t>
+              <a:t>Before the demo: "Because these leads are confidential, Mutz runs on Apertus, on Swiss infrastructure. Salaries, revenue and contact details are struck out on our own machine before anything reaches Apertus at all. Let us show you."</a:t>
             </a:r>
           </a:p>
           <a:p/>
+          <a:p>
+            <a:r>
+              <a:t>1. Case list: "This is the officer's Monday morning: every open lead and where it stands."</a:t>
+            </a:r>
+          </a:p>
+          <a:p>
+            <a:r>
+              <a:t>2. Paste the one-pager: "Apertus reads the one-pager and pulls out what the company actually needs. Each need points back to the sentence it came from." (Point at the header: Apertus on CSCS, Switzerland.)</a:t>
+            </a:r>
+          </a:p>
+          <a:p>
+            <a:r>
+              <a:t>3. Matches, click a reason: "For every need, Mutz ranks people and labs in Bern, with a plain reason. Click it, and the source page opens at the exact sentence." Pause.</a:t>
+            </a:r>
+          </a:p>
+          <a:p>
+            <a:r>
+              <a:t>4. Accept two, reject one, export: "The officer decides. Accept, reject, and the pitch is ready, with every claim numbered and linked."</a:t>
+            </a:r>
+          </a:p>
+          <a:p>
+            <a:r>
+              <a:t>5. Weak field (battery recycling): "And when Bern has nothing? Kei Hung im Topf. No honey in the pot. Mutz says so, and shows everything it searched."</a:t>
+            </a:r>
+          </a:p>
+          <a:p>
+            <a:r>
+              <a:t>6. Optional, if there is time: the company sends more information, and Mutz re-checks only the needs that changed.</a:t>
+            </a:r>
+          </a:p>
+          <a:p/>
+          <a:p>
+            <a:r>
+              <a:t>Do not demo "add a source, then an alert": it is not built yet.</a:t>
+            </a:r>
+          </a:p>
           <a:p>
             <a:r>
               <a:t>Fallback: backup video in a hidden tab; backup slide "From one-pager to pitch" at the end.</a:t>
@@ -2362,10 +2387,15 @@
           <a:p/>
           <a:p>
             <a:r>
-              <a:t>"Mutz doesn't stop after one search. When new research appears, every open case is re-checked and the officer gets an alert. And every search adds up: a word cloud of what Bern is strong in, and a report of what companies ask for that Bern doesn't have yet. That's input for the canton's economic strategy."</a:t>
+              <a:t>"Bern's research should never sit idle. When a company sends more information, Mutz re-checks only what changed. Next, it'll do the same for every open case whenever new research comes in. And every search adds up: the word cloud and gap report show where Bern is strong, and where companies keep asking for something Bern doesn't have yet, so the canton can plan for it."</a:t>
             </a:r>
           </a:p>
           <a:p/>
+          <a:p>
+            <a:r>
+              <a:t>HONESTY: re-evaluation on new company information is built. Alerts on new research are the next step and not built. Don't say they work today.</a:t>
+            </a:r>
+          </a:p>
           <a:p>
             <a:r>
               <a:t>(Details for questions: backup slides "Bern's research never sits idle" and "From a search tool to an economic strategy tool".)</a:t>
@@ -9753,7 +9783,7 @@
                   <a:srgbClr val="000000"/>
                 </a:solidFill>
               </a:rPr>
-              <a:t>[XX]%</a:t>
+              <a:t>91%</a:t>
             </a:r>
           </a:p>
         </p:txBody>
@@ -9791,7 +9821,7 @@
                   <a:srgbClr val="000000"/>
                 </a:solidFill>
               </a:rPr>
-              <a:t>of held-out questions have the right expert in the top 10</a:t>
+              <a:t>of held-out questions (21 of 23) have the right expert in the top 10</a:t>
             </a:r>
           </a:p>
         </p:txBody>
@@ -9864,7 +9894,7 @@
                   <a:srgbClr val="000000"/>
                 </a:solidFill>
               </a:rPr>
-              <a:t>[XX]%</a:t>
+              <a:t>10/11</a:t>
             </a:r>
           </a:p>
         </p:txBody>
@@ -9902,7 +9932,7 @@
                   <a:srgbClr val="000000"/>
                 </a:solidFill>
               </a:rPr>
-              <a:t>overlap between lay words and expert jargon results</a:t>
+              <a:t>plain-language questions find the right expert, no jargon needed</a:t>
             </a:r>
           </a:p>
         </p:txBody>
@@ -9975,7 +10005,7 @@
                   <a:srgbClr val="EA161F"/>
                 </a:solidFill>
               </a:rPr>
-              <a:t>0 / [N]</a:t>
+              <a:t>0</a:t>
             </a:r>
           </a:p>
         </p:txBody>
@@ -10013,7 +10043,7 @@
                   <a:srgbClr val="000000"/>
                 </a:solidFill>
               </a:rPr>
-              <a:t>facts without a verified quote on the source page</a:t>
+              <a:t>of 19,631 facts without a link to their source page</a:t>
             </a:r>
           </a:p>
         </p:txBody>
@@ -10086,7 +10116,7 @@
                   <a:srgbClr val="000000"/>
                 </a:solidFill>
               </a:rPr>
-              <a:t>[XX]%</a:t>
+              <a:t>0%</a:t>
             </a:r>
           </a:p>
         </p:txBody>
@@ -10124,7 +10154,7 @@
                   <a:srgbClr val="000000"/>
                 </a:solidFill>
               </a:rPr>
-              <a:t>our weakest category: [name]. We show it.</a:t>
+              <a:t>our weakest category: funding (1 question; the app answers it from a curated list). We show it.</a:t>
             </a:r>
           </a:p>
         </p:txBody>
@@ -10205,7 +10235,7 @@
                   <a:srgbClr val="63737B"/>
                 </a:solidFill>
               </a:rPr>
-              <a:t>[N] hand-written + [N] synthetic test cases, split into tune and held-out sets. Hybrid search (BM25 + BGE-M3, fused with RRF), cross-encoder rerank, every extracted fact checked against the page text.</a:t>
+              <a:t>84 hand-written test cases (55 to tune on, 29 held out and hash-locked) plus 47 synthetic. Hybrid search (BM25 + BGE-M3, fused with RRF), cross-encoder rerank, Apertus 70B grading, every extracted fact checked against the page text.</a:t>
             </a:r>
           </a:p>
         </p:txBody>
@@ -10856,7 +10886,7 @@
                   <a:srgbClr val="000000"/>
                 </a:solidFill>
               </a:rPr>
-              <a:t>Partner models</a:t>
+              <a:t>Local models</a:t>
             </a:r>
           </a:p>
           <a:p>
@@ -10871,7 +10901,7 @@
                   <a:srgbClr val="63737B"/>
                 </a:solidFill>
               </a:rPr>
-              <a:t>Embeddings, reranker, independent judge</a:t>
+              <a:t>Embeddings and reranker, inside our container</a:t>
             </a:r>
           </a:p>
         </p:txBody>
@@ -12616,7 +12646,7 @@
                   <a:srgbClr val="000000"/>
                 </a:solidFill>
               </a:rPr>
-              <a:t>“New archive checked. 2 open cases have new matches.”</a:t>
+              <a:t>Next step: “New archive checked. 2 open cases have new matches.”</a:t>
             </a:r>
           </a:p>
         </p:txBody>
@@ -12654,7 +12684,7 @@
                   <a:srgbClr val="63737B"/>
                 </a:solidFill>
               </a:rPr>
-              <a:t>Add a source or re-crawl, and every open case is re-checked automatically.</a:t>
+              <a:t>Planned: add a source or re-crawl, and every open case is re-checked automatically.</a:t>
             </a:r>
           </a:p>
         </p:txBody>
@@ -13659,7 +13689,7 @@
                   <a:srgbClr val="63737B"/>
                 </a:solidFill>
               </a:rPr>
-              <a:t>Needs that ended in an empty pot</a:t>
+              <a:t>Needs that ended in an empty pot (test data, 81 leads)</a:t>
             </a:r>
           </a:p>
         </p:txBody>
@@ -13697,7 +13727,7 @@
                   <a:srgbClr val="000000"/>
                 </a:solidFill>
               </a:rPr>
-              <a:t>Battery technology</a:t>
+              <a:t>Small batch manufacturing</a:t>
             </a:r>
           </a:p>
         </p:txBody>
@@ -13752,7 +13782,7 @@
         </p:nvSpPr>
         <p:spPr>
           <a:xfrm>
-            <a:off x="10977372" y="2788920"/>
+            <a:off x="10977371" y="2788920"/>
             <a:ext cx="640080" cy="457200"/>
           </a:xfrm>
           <a:prstGeom prst="rect">
@@ -13777,7 +13807,7 @@
                   <a:srgbClr val="63737B"/>
                 </a:solidFill>
               </a:rPr>
-              <a:t>[XX]</a:t>
+              <a:t>18</a:t>
             </a:r>
           </a:p>
         </p:txBody>
@@ -13815,7 +13845,7 @@
                   <a:srgbClr val="000000"/>
                 </a:solidFill>
               </a:rPr>
-              <a:t>Offshore wind</a:t>
+              <a:t>Battery technology</a:t>
             </a:r>
           </a:p>
         </p:txBody>
@@ -13829,7 +13859,7 @@
         <p:spPr>
           <a:xfrm>
             <a:off x="9098280" y="3584448"/>
-            <a:ext cx="1156716" cy="237744"/>
+            <a:ext cx="893825" cy="237744"/>
           </a:xfrm>
           <a:prstGeom prst="rect">
             <a:avLst/>
@@ -13870,7 +13900,7 @@
         </p:nvSpPr>
         <p:spPr>
           <a:xfrm>
-            <a:off x="10346436" y="3474720"/>
+            <a:off x="10083545" y="3474720"/>
             <a:ext cx="640080" cy="457200"/>
           </a:xfrm>
           <a:prstGeom prst="rect">
@@ -13895,7 +13925,7 @@
                   <a:srgbClr val="63737B"/>
                 </a:solidFill>
               </a:rPr>
-              <a:t>[XX]</a:t>
+              <a:t>9</a:t>
             </a:r>
           </a:p>
         </p:txBody>
@@ -13933,7 +13963,7 @@
                   <a:srgbClr val="000000"/>
                 </a:solidFill>
               </a:rPr>
-              <a:t>Semiconductor packaging</a:t>
+              <a:t>Cosmetics and packaging</a:t>
             </a:r>
           </a:p>
         </p:txBody>
@@ -13947,7 +13977,7 @@
         <p:spPr>
           <a:xfrm>
             <a:off x="9098280" y="4270248"/>
-            <a:ext cx="736092" cy="237744"/>
+            <a:ext cx="595883" cy="237744"/>
           </a:xfrm>
           <a:prstGeom prst="rect">
             <a:avLst/>
@@ -13988,7 +14018,7 @@
         </p:nvSpPr>
         <p:spPr>
           <a:xfrm>
-            <a:off x="9925812" y="4160520"/>
+            <a:off x="9785603" y="4160520"/>
             <a:ext cx="640080" cy="457200"/>
           </a:xfrm>
           <a:prstGeom prst="rect">
@@ -14013,7 +14043,7 @@
                   <a:srgbClr val="63737B"/>
                 </a:solidFill>
               </a:rPr>
-              <a:t>[XX]</a:t>
+              <a:t>6</a:t>
             </a:r>
           </a:p>
         </p:txBody>
@@ -14270,7 +14300,7 @@
                 </a:solidFill>
                 <a:latin typeface="Courier New"/>
               </a:rPr>
-              <a:t>- id: sitem</a:t>
+              <a:t>"id": "sitem_insel",</a:t>
             </a:r>
           </a:p>
           <a:p>
@@ -14286,7 +14316,7 @@
                 </a:solidFill>
                 <a:latin typeface="Courier New"/>
               </a:rPr>
-              <a:t>  name: sitem-insel</a:t>
+              <a:t>"seeds": ["https://sitem-insel.ch/"],</a:t>
             </a:r>
           </a:p>
           <a:p>
@@ -14302,7 +14332,7 @@
                 </a:solidFill>
                 <a:latin typeface="Courier New"/>
               </a:rPr>
-              <a:t>  seeds: [https://www.sitem-insel.ch/]</a:t>
+              <a:t>"allow": ["sitem-insel.ch"],</a:t>
             </a:r>
           </a:p>
           <a:p>
@@ -14318,7 +14348,7 @@
                 </a:solidFill>
                 <a:latin typeface="Courier New"/>
               </a:rPr>
-              <a:t>  allow_domains: [www.sitem-insel.ch]</a:t>
+              <a:t>"include": [],</a:t>
             </a:r>
           </a:p>
           <a:p>
@@ -14334,7 +14364,7 @@
                 </a:solidFill>
                 <a:latin typeface="Courier New"/>
               </a:rPr>
-              <a:t>  languages: [de, en]</a:t>
+              <a:t>"exclude": ["/news/", "/search", "/print"],</a:t>
             </a:r>
           </a:p>
           <a:p>
@@ -14350,7 +14380,7 @@
                 </a:solidFill>
                 <a:latin typeface="Courier New"/>
               </a:rPr>
-              <a:t>  max_pages: 300</a:t>
+              <a:t>"max_pages": 400</a:t>
             </a:r>
           </a:p>
         </p:txBody>
@@ -14388,7 +14418,7 @@
                   <a:srgbClr val="63737B"/>
                 </a:solidFill>
               </a:rPr>
-              <a:t>No code change. Crawl, extract, verify, index, and every open case is re-checked.</a:t>
+              <a:t>No code change. Crawl, extract, verify, index. Next: every open case re-checked automatically.</a:t>
             </a:r>
           </a:p>
         </p:txBody>
@@ -14499,7 +14529,7 @@
                   <a:srgbClr val="EA161F"/>
                 </a:solidFill>
               </a:rPr>
-              <a:t>[X] h</a:t>
+              <a:t>≈ 10 s</a:t>
             </a:r>
             <a:r>
               <a:rPr sz="1600" b="0" i="0">
@@ -14507,7 +14537,7 @@
                   <a:srgbClr val="000000"/>
                 </a:solidFill>
               </a:rPr>
-              <a:t>  saved per case</a:t>
+              <a:t>  per need search</a:t>
             </a:r>
           </a:p>
           <a:p>
@@ -14522,7 +14552,7 @@
                   <a:srgbClr val="000000"/>
                 </a:solidFill>
               </a:rPr>
-              <a:t>× 300 cases a year = [XXX] officer hours</a:t>
+              <a:t>measured on our held-out questions</a:t>
             </a:r>
           </a:p>
         </p:txBody>
@@ -14595,7 +14625,7 @@
                   <a:srgbClr val="000000"/>
                 </a:solidFill>
               </a:rPr>
-              <a:t>[XX] tokens</a:t>
+              <a:t>≈ 35k tokens</a:t>
             </a:r>
             <a:r>
               <a:rPr sz="1500" b="0" i="0">
@@ -14603,7 +14633,7 @@
                   <a:srgbClr val="000000"/>
                 </a:solidFill>
               </a:rPr>
-              <a:t> per case on Apertus</a:t>
+              <a:t> per case on Apertus (estimate)</a:t>
             </a:r>
           </a:p>
           <a:p>
@@ -14618,7 +14648,7 @@
                   <a:srgbClr val="000000"/>
                 </a:solidFill>
               </a:rPr>
-              <a:t>[XX] pages</a:t>
+              <a:t>3,026 pages</a:t>
             </a:r>
             <a:r>
               <a:rPr sz="1500" b="0" i="0">
@@ -14626,7 +14656,7 @@
                   <a:srgbClr val="000000"/>
                 </a:solidFill>
               </a:rPr>
-              <a:t> crawled across 3 sources</a:t>
+              <a:t> crawled across 16 sources</a:t>
             </a:r>
           </a:p>
           <a:p>
@@ -14641,7 +14671,7 @@
                   <a:srgbClr val="000000"/>
                 </a:solidFill>
               </a:rPr>
-              <a:t>Runs on CSCS or one GPU box</a:t>
+              <a:t>Apertus on CSCS, search runs on a laptop</a:t>
             </a:r>
           </a:p>
         </p:txBody>
@@ -15662,7 +15692,7 @@
                   <a:srgbClr val="63737B"/>
                 </a:solidFill>
               </a:rPr>
-              <a:t>robots, rate limit, sources.yaml</a:t>
+              <a:t>robots, rate limit, sources.json</a:t>
             </a:r>
           </a:p>
         </p:txBody>
@@ -16372,7 +16402,7 @@
                   <a:srgbClr val="63737B"/>
                 </a:solidFill>
               </a:rPr>
-              <a:t>MeSH + rewrites, DE/FR/EN</a:t>
+              <a:t>Apertus 70B lay terms, DE/FR/EN</a:t>
             </a:r>
           </a:p>
         </p:txBody>
@@ -16657,7 +16687,7 @@
                   <a:srgbClr val="63737B"/>
                 </a:solidFill>
               </a:rPr>
-              <a:t>cross-encoder + fairness</a:t>
+              <a:t>cross-encoder, Apertus grade, fairness</a:t>
             </a:r>
           </a:p>
         </p:txBody>
@@ -17023,7 +17053,7 @@
                   <a:srgbClr val="EA161F"/>
                 </a:solidFill>
               </a:rPr>
-              <a:t>In Bärner Mutz</a:t>
+              <a:t>Our Bärner Mutz</a:t>
             </a:r>
           </a:p>
         </p:txBody>
@@ -17428,7 +17458,7 @@
                   <a:srgbClr val="000000"/>
                 </a:solidFill>
               </a:rPr>
-              <a:t>Why isn't Prof. [X] in the results?</a:t>
+              <a:t>Why isn't Prof. Brüningk in the results?</a:t>
             </a:r>
           </a:p>
         </p:txBody>
@@ -17516,7 +17546,7 @@
                   <a:srgbClr val="000000"/>
                 </a:solidFill>
               </a:rPr>
-              <a:t>Prof. [X] is rank [N] for this need.</a:t>
+              <a:t>I have no page about Prof. Brüningk in our 16 archives.</a:t>
             </a:r>
           </a:p>
           <a:p>
@@ -17531,7 +17561,7 @@
                   <a:srgbClr val="000000"/>
                 </a:solidFill>
               </a:rPr>
-              <a:t>I found [1] page about [topic] [1]. A strong match needs two independent pages, so I kept [X] below the top 10.</a:t>
+              <a:t>Their profile may be on a site we do not crawl.</a:t>
             </a:r>
           </a:p>
           <a:p>
@@ -17546,7 +17576,7 @@
                   <a:srgbClr val="EA161F"/>
                 </a:solidFill>
               </a:rPr>
-              <a:t>Show the page  ·  Add to pitch anyway</a:t>
+              <a:t>Propose their profile page as a source</a:t>
             </a:r>
           </a:p>
         </p:txBody>
@@ -19870,7 +19900,7 @@
                   <a:srgbClr val="000000"/>
                 </a:solidFill>
               </a:rPr>
-              <a:t>Alerts</a:t>
+              <a:t>Re-check, then alerts</a:t>
             </a:r>
           </a:p>
         </p:txBody>
@@ -19908,7 +19938,7 @@
                   <a:srgbClr val="63737B"/>
                 </a:solidFill>
               </a:rPr>
-              <a:t>New research appears, every open case is re-checked.</a:t>
+              <a:t>New company info re-checks what changed. Next: alerts when new research appears.</a:t>
             </a:r>
           </a:p>
         </p:txBody>
@@ -20378,7 +20408,7 @@
                   <a:srgbClr val="000000"/>
                 </a:solidFill>
               </a:rPr>
-              <a:t>[XX]%</a:t>
+              <a:t>91%</a:t>
             </a:r>
           </a:p>
         </p:txBody>
@@ -20454,7 +20484,7 @@
                   <a:srgbClr val="000000"/>
                 </a:solidFill>
               </a:rPr>
-              <a:t>[XX]%</a:t>
+              <a:t>10/11</a:t>
             </a:r>
           </a:p>
         </p:txBody>
@@ -20492,7 +20522,7 @@
                   <a:srgbClr val="000000"/>
                 </a:solidFill>
               </a:rPr>
-              <a:t>same experts for lay words and jargon</a:t>
+              <a:t>plain-language questions</a:t>
             </a:r>
           </a:p>
         </p:txBody>
@@ -20606,7 +20636,7 @@
                   <a:srgbClr val="63737B"/>
                 </a:solidFill>
               </a:rPr>
-              <a:t>On held-out questions we never tuned on.</a:t>
+              <a:t>On 23 held-out questions we never tuned on. 0 of 19,631 facts lack a source.</a:t>
             </a:r>
           </a:p>
         </p:txBody>

</xml_diff>

<commit_message>
Pitch decks: Team Ctrl+Free footer, Apertus logo on honesty slide, challenge owner logos
Reapplied on top of beSaif's latest deck updates.

Co-Authored-By: Claude Opus 5.5 <noreply@anthropic.com>
</commit_message>
<xml_diff>
--- a/research/Mutz_Pitch_lean_animated.pptx
+++ b/research/Mutz_Pitch_lean_animated.pptx
@@ -2311,7 +2311,7 @@
           <a:p/>
           <a:p>
             <a:r>
-              <a:t>"Every need gets a honey pot. Full: pitch it. Thin: check first. Empty: don't pitch. As the agency told us: 'we cannot oversell, we must sell what we have.'"</a:t>
+              <a:t>"Mutz is honest and trustworthy by design, with Apertus. Every need gets a honey pot. Full: pitch it. Thin: check first. Empty: don't pitch. As the agency told us: 'we cannot oversell, we must sell what we have.'"</a:t>
             </a:r>
           </a:p>
         </p:txBody>
@@ -6969,7 +6969,7 @@
           <a:p>
             <a:r>
               <a:rPr lang="de-CH"/>
-              <a:t>Hack Apertus Liebefeld · Prototype</a:t>
+              <a:t>Team Ctrl+Free</a:t>
             </a:r>
             <a:endParaRPr lang="de-CH" dirty="0"/>
           </a:p>
@@ -7264,7 +7264,7 @@
           <a:p>
             <a:r>
               <a:rPr lang="de-CH"/>
-              <a:t>Hack Apertus Liebefeld · Prototype</a:t>
+              <a:t>Team Ctrl+Free</a:t>
             </a:r>
             <a:endParaRPr lang="de-CH" dirty="0"/>
           </a:p>
@@ -7871,7 +7871,7 @@
           <a:p>
             <a:r>
               <a:rPr lang="de-CH"/>
-              <a:t>Hack Apertus Liebefeld · Prototype</a:t>
+              <a:t>Team Ctrl+Free</a:t>
             </a:r>
             <a:endParaRPr lang="de-CH" dirty="0"/>
           </a:p>
@@ -8001,7 +8001,7 @@
           <a:p>
             <a:r>
               <a:rPr lang="de-CH"/>
-              <a:t>Hack Apertus Liebefeld · Prototype</a:t>
+              <a:t>Team Ctrl+Free</a:t>
             </a:r>
             <a:endParaRPr lang="de-CH" dirty="0"/>
           </a:p>
@@ -9714,7 +9714,7 @@
           <a:p>
             <a:r>
               <a:rPr lang="de-CH"/>
-              <a:t>Hack Apertus Liebefeld · Prototype</a:t>
+              <a:t>Team Ctrl+Free</a:t>
             </a:r>
             <a:endParaRPr lang="de-CH" dirty="0"/>
           </a:p>
@@ -10414,7 +10414,7 @@
           <a:p>
             <a:r>
               <a:rPr lang="de-CH"/>
-              <a:t>Hack Apertus Liebefeld · Prototype</a:t>
+              <a:t>Team Ctrl+Free</a:t>
             </a:r>
             <a:endParaRPr lang="de-CH" dirty="0"/>
           </a:p>
@@ -11226,7 +11226,7 @@
           <a:p>
             <a:r>
               <a:rPr lang="de-CH"/>
-              <a:t>Hack Apertus Liebefeld · Prototype</a:t>
+              <a:t>Team Ctrl+Free</a:t>
             </a:r>
             <a:endParaRPr lang="de-CH" dirty="0"/>
           </a:p>
@@ -12863,7 +12863,7 @@
           <a:p>
             <a:r>
               <a:rPr lang="de-CH"/>
-              <a:t>Hack Apertus Liebefeld · Prototype</a:t>
+              <a:t>Team Ctrl+Free</a:t>
             </a:r>
             <a:endParaRPr lang="de-CH" dirty="0"/>
           </a:p>
@@ -14188,7 +14188,7 @@
           <a:p>
             <a:r>
               <a:rPr lang="de-CH"/>
-              <a:t>Hack Apertus Liebefeld · Prototype</a:t>
+              <a:t>Team Ctrl+Free</a:t>
             </a:r>
             <a:endParaRPr lang="de-CH" dirty="0"/>
           </a:p>
@@ -14770,7 +14770,7 @@
           <a:p>
             <a:r>
               <a:rPr lang="de-CH"/>
-              <a:t>Hack Apertus Liebefeld · Prototype</a:t>
+              <a:t>Team Ctrl+Free</a:t>
             </a:r>
             <a:endParaRPr lang="de-CH" dirty="0"/>
           </a:p>
@@ -15527,7 +15527,7 @@
           <a:p>
             <a:r>
               <a:rPr lang="de-CH"/>
-              <a:t>Hack Apertus Liebefeld · Prototype</a:t>
+              <a:t>Team Ctrl+Free</a:t>
             </a:r>
             <a:endParaRPr lang="de-CH" dirty="0"/>
           </a:p>
@@ -16908,7 +16908,7 @@
           <a:p>
             <a:r>
               <a:rPr lang="de-CH"/>
-              <a:t>Hack Apertus Liebefeld · Prototype</a:t>
+              <a:t>Team Ctrl+Free</a:t>
             </a:r>
             <a:endParaRPr lang="de-CH" dirty="0"/>
           </a:p>
@@ -17339,7 +17339,7 @@
           <a:p>
             <a:r>
               <a:rPr lang="de-CH"/>
-              <a:t>Hack Apertus Liebefeld · Prototype</a:t>
+              <a:t>Team Ctrl+Free</a:t>
             </a:r>
             <a:endParaRPr lang="de-CH" dirty="0"/>
           </a:p>
@@ -18141,7 +18141,7 @@
           <a:p>
             <a:r>
               <a:rPr lang="de-CH"/>
-              <a:t>Hack Apertus Liebefeld · Prototype</a:t>
+              <a:t>Team Ctrl+Free</a:t>
             </a:r>
             <a:endParaRPr lang="de-CH" dirty="0"/>
           </a:p>
@@ -18299,8 +18299,8 @@
         </p:nvSpPr>
         <p:spPr>
           <a:xfrm>
-            <a:off x="841248" y="5669280"/>
-            <a:ext cx="5212080" cy="457200"/>
+            <a:off x="841248" y="5692140"/>
+            <a:ext cx="5212080" cy="274320"/>
           </a:xfrm>
           <a:prstGeom prst="rect">
             <a:avLst/>
@@ -18356,6 +18356,68 @@
           <a:xfrm>
             <a:off x="6126480" y="868680"/>
             <a:ext cx="5852160" cy="5852160"/>
+          </a:xfrm>
+          <a:prstGeom prst="rect">
+            <a:avLst/>
+          </a:prstGeom>
+        </p:spPr>
+      </p:pic>
+      <p:sp>
+        <p:nvSpPr>
+          <p:cNvPr id="908" name="Challenge owner label"/>
+          <p:cNvSpPr txBox="1"/>
+          <p:nvPr/>
+        </p:nvSpPr>
+        <p:spPr>
+          <a:xfrm>
+            <a:off x="7269480" y="5753100"/>
+            <a:ext cx="1371600" cy="152400"/>
+          </a:xfrm>
+          <a:prstGeom prst="rect">
+            <a:avLst/>
+          </a:prstGeom>
+          <a:noFill/>
+        </p:spPr>
+        <p:txBody>
+          <a:bodyPr wrap="square" lIns="0" rIns="0" tIns="0" bIns="0" anchor="t">
+            <a:spAutoFit/>
+          </a:bodyPr>
+          <a:lstStyle/>
+          <a:p>
+            <a:pPr algn="l">
+              <a:spcAft>
+                <a:spcPts val="0"/>
+              </a:spcAft>
+            </a:pPr>
+            <a:r>
+              <a:rPr lang="en-GB" sz="1000" b="0" i="0">
+                <a:solidFill>
+                  <a:srgbClr val="63737B"/>
+                </a:solidFill>
+              </a:rPr>
+              <a:t>Challenge owner</a:t>
+            </a:r>
+          </a:p>
+        </p:txBody>
+      </p:sp>
+      <p:pic>
+        <p:nvPicPr>
+          <p:cNvPr id="909" name="Bern Economic Development Agency logo" descr="Bern Economic Development Agency"/>
+          <p:cNvPicPr>
+            <a:picLocks noChangeAspect="1"/>
+          </p:cNvPicPr>
+          <p:nvPr/>
+        </p:nvPicPr>
+        <p:blipFill>
+          <a:blip r:embed="rId91"/>
+          <a:stretch>
+            <a:fillRect/>
+          </a:stretch>
+        </p:blipFill>
+        <p:spPr>
+          <a:xfrm>
+            <a:off x="8778240" y="5577840"/>
+            <a:ext cx="1566717" cy="502920"/>
           </a:xfrm>
           <a:prstGeom prst="rect">
             <a:avLst/>
@@ -18515,6 +18577,76 @@
                                   </p:childTnLst>
                                 </p:cTn>
                               </p:par>
+                              <p:par>
+                                <p:cTn id="17" presetID="10" presetClass="entr" presetSubtype="0" fill="hold" grpId="0" nodeType="withEffect">
+                                  <p:stCondLst>
+                                    <p:cond delay="5600"/>
+                                  </p:stCondLst>
+                                  <p:childTnLst>
+                                    <p:set>
+                                      <p:cBhvr>
+                                        <p:cTn id="18" dur="1" fill="hold">
+                                          <p:stCondLst>
+                                            <p:cond delay="0"/>
+                                          </p:stCondLst>
+                                        </p:cTn>
+                                        <p:tgtEl>
+                                          <p:spTgt spid="908"/>
+                                        </p:tgtEl>
+                                        <p:attrNameLst>
+                                          <p:attrName>style.visibility</p:attrName>
+                                        </p:attrNameLst>
+                                      </p:cBhvr>
+                                      <p:to>
+                                        <p:strVal val="visible"/>
+                                      </p:to>
+                                    </p:set>
+                                    <p:animEffect transition="in" filter="fade">
+                                      <p:cBhvr>
+                                        <p:cTn id="19" dur="500"/>
+                                        <p:tgtEl>
+                                          <p:spTgt spid="908"/>
+                                        </p:tgtEl>
+                                      </p:cBhvr>
+                                    </p:animEffect>
+                                  </p:childTnLst>
+                                </p:cTn>
+                              </p:par>
+                              <p:par>
+                                <p:cTn id="20" presetID="10" presetClass="entr" presetSubtype="0" fill="hold" grpId="0" nodeType="withEffect">
+                                  <p:stCondLst>
+                                    <p:cond delay="5600"/>
+                                  </p:stCondLst>
+                                  <p:childTnLst>
+                                    <p:set>
+                                      <p:cBhvr>
+                                        <p:cTn id="21" dur="1" fill="hold">
+                                          <p:stCondLst>
+                                            <p:cond delay="0"/>
+                                          </p:stCondLst>
+                                        </p:cTn>
+                                        <p:tgtEl>
+                                          <p:spTgt spid="909"/>
+                                        </p:tgtEl>
+                                        <p:attrNameLst>
+                                          <p:attrName>style.visibility</p:attrName>
+                                        </p:attrNameLst>
+                                      </p:cBhvr>
+                                      <p:to>
+                                        <p:strVal val="visible"/>
+                                      </p:to>
+                                    </p:set>
+                                    <p:animEffect transition="in" filter="fade">
+                                      <p:cBhvr>
+                                        <p:cTn id="22" dur="500"/>
+                                        <p:tgtEl>
+                                          <p:spTgt spid="909"/>
+                                        </p:tgtEl>
+                                      </p:cBhvr>
+                                    </p:animEffect>
+                                  </p:childTnLst>
+                                </p:cTn>
+                              </p:par>
                             </p:childTnLst>
                           </p:cTn>
                         </p:par>
@@ -18558,6 +18690,7 @@
       <p:bldP spid="904" grpId="0" animBg="1"/>
       <p:bldP spid="905" grpId="0" animBg="1"/>
       <p:bldP spid="906" grpId="0" animBg="1"/>
+      <p:bldP spid="908" grpId="0" animBg="1"/>
     </p:bldLst>
   </p:timing>
 </p:sld>
@@ -18625,7 +18758,7 @@
           <a:p>
             <a:r>
               <a:rPr lang="de-CH"/>
-              <a:t>Hack Apertus Liebefeld · Prototype</a:t>
+              <a:t>Team Ctrl+Free</a:t>
             </a:r>
             <a:endParaRPr lang="de-CH" dirty="0"/>
           </a:p>
@@ -19014,7 +19147,7 @@
           <a:p>
             <a:r>
               <a:rPr lang="de-CH"/>
-              <a:t>Hack Apertus Liebefeld · Prototype</a:t>
+              <a:t>Team Ctrl+Free</a:t>
             </a:r>
             <a:endParaRPr lang="de-CH" dirty="0"/>
           </a:p>
@@ -19200,7 +19333,7 @@
           <a:lstStyle/>
           <a:p>
             <a:r>
-              <a:t>Honest by design</a:t>
+              <a:t>Honest and trustworthy by design</a:t>
             </a:r>
           </a:p>
         </p:txBody>
@@ -19257,7 +19390,7 @@
           <a:p>
             <a:r>
               <a:rPr lang="de-CH"/>
-              <a:t>Hack Apertus Liebefeld · Prototype</a:t>
+              <a:t>Team Ctrl+Free</a:t>
             </a:r>
             <a:endParaRPr lang="de-CH" dirty="0"/>
           </a:p>
@@ -19318,7 +19451,7 @@
         </p:blipFill>
         <p:spPr>
           <a:xfrm>
-            <a:off x="841248" y="1874519"/>
+            <a:off x="841248" y="2377440"/>
             <a:ext cx="10972800" cy="2011680"/>
           </a:xfrm>
           <a:prstGeom prst="rect">
@@ -19334,7 +19467,7 @@
         </p:nvSpPr>
         <p:spPr>
           <a:xfrm>
-            <a:off x="841248" y="4069080"/>
+            <a:off x="841248" y="4572001"/>
             <a:ext cx="3383280" cy="548640"/>
           </a:xfrm>
           <a:prstGeom prst="rect">
@@ -19372,7 +19505,7 @@
         </p:nvSpPr>
         <p:spPr>
           <a:xfrm>
-            <a:off x="4544568" y="4069080"/>
+            <a:off x="4544568" y="4572001"/>
             <a:ext cx="3383280" cy="548640"/>
           </a:xfrm>
           <a:prstGeom prst="rect">
@@ -19410,7 +19543,7 @@
         </p:nvSpPr>
         <p:spPr>
           <a:xfrm>
-            <a:off x="8247888" y="4069080"/>
+            <a:off x="8247888" y="4572001"/>
             <a:ext cx="3383280" cy="548640"/>
           </a:xfrm>
           <a:prstGeom prst="rect">
@@ -19448,7 +19581,7 @@
         </p:nvSpPr>
         <p:spPr>
           <a:xfrm>
-            <a:off x="841248" y="5120640"/>
+            <a:off x="841248" y="5623561"/>
             <a:ext cx="10972800" cy="640080"/>
           </a:xfrm>
           <a:prstGeom prst="rect">
@@ -19478,6 +19611,66 @@
           </a:p>
         </p:txBody>
       </p:sp>
+      <p:sp>
+        <p:nvSpPr>
+          <p:cNvPr id="908" name="With Apertus text"/>
+          <p:cNvSpPr txBox="1"/>
+          <p:nvPr/>
+        </p:nvSpPr>
+        <p:spPr>
+          <a:xfrm>
+            <a:off x="838200" y="1783080"/>
+            <a:ext cx="731520" cy="429768"/>
+          </a:xfrm>
+          <a:prstGeom prst="rect">
+            <a:avLst/>
+          </a:prstGeom>
+          <a:noFill/>
+        </p:spPr>
+        <p:txBody>
+          <a:bodyPr wrap="none" lIns="0" rIns="0" tIns="0" bIns="0" anchor="t"/>
+          <a:lstStyle/>
+          <a:p>
+            <a:pPr algn="l">
+              <a:spcAft>
+                <a:spcPts val="0"/>
+              </a:spcAft>
+            </a:pPr>
+            <a:r>
+              <a:rPr lang="en-GB" sz="2800" b="0" i="0">
+                <a:solidFill>
+                  <a:srgbClr val="000000"/>
+                </a:solidFill>
+              </a:rPr>
+              <a:t>with</a:t>
+            </a:r>
+          </a:p>
+        </p:txBody>
+      </p:sp>
+      <p:pic>
+        <p:nvPicPr>
+          <p:cNvPr id="909" name="Apertus logo" descr="Apertus"/>
+          <p:cNvPicPr>
+            <a:picLocks noChangeAspect="1"/>
+          </p:cNvPicPr>
+          <p:nvPr/>
+        </p:nvPicPr>
+        <p:blipFill>
+          <a:blip r:embed="rId90"/>
+          <a:stretch>
+            <a:fillRect/>
+          </a:stretch>
+        </p:blipFill>
+        <p:spPr>
+          <a:xfrm>
+            <a:off x="1578864" y="1850280"/>
+            <a:ext cx="2591837" cy="254000"/>
+          </a:xfrm>
+          <a:prstGeom prst="rect">
+            <a:avLst/>
+          </a:prstGeom>
+        </p:spPr>
+      </p:pic>
     </p:spTree>
   </p:cSld>
   <p:clrMapOvr>
@@ -19798,7 +19991,7 @@
           <a:p>
             <a:r>
               <a:rPr lang="de-CH"/>
-              <a:t>Hack Apertus Liebefeld · Prototype</a:t>
+              <a:t>Team Ctrl+Free</a:t>
             </a:r>
             <a:endParaRPr lang="de-CH" dirty="0"/>
           </a:p>
@@ -20339,7 +20532,7 @@
           <a:p>
             <a:r>
               <a:rPr lang="de-CH"/>
-              <a:t>Hack Apertus Liebefeld · Prototype</a:t>
+              <a:t>Team Ctrl+Free</a:t>
             </a:r>
             <a:endParaRPr lang="de-CH" dirty="0"/>
           </a:p>
@@ -21076,7 +21269,7 @@
           <a:p>
             <a:r>
               <a:rPr lang="de-CH"/>
-              <a:t>Hack Apertus Liebefeld · Prototype</a:t>
+              <a:t>Team Ctrl+Free</a:t>
             </a:r>
             <a:endParaRPr lang="de-CH" dirty="0"/>
           </a:p>
@@ -21144,8 +21337,8 @@
         </p:nvSpPr>
         <p:spPr>
           <a:xfrm>
-            <a:off x="841248" y="5120640"/>
-            <a:ext cx="6400800" cy="365760"/>
+            <a:off x="841248" y="5692140"/>
+            <a:ext cx="5212080" cy="274320"/>
           </a:xfrm>
           <a:prstGeom prst="rect">
             <a:avLst/>
@@ -21164,26 +21357,26 @@
               </a:spcAft>
             </a:pPr>
             <a:r>
-              <a:rPr sz="1600" b="0" i="0">
+              <a:rPr sz="1800" b="0" i="0">
                 <a:solidFill>
                   <a:srgbClr val="63737B"/>
                 </a:solidFill>
               </a:rPr>
-              <a:t>Team Ctrl+Free · Hack Apertus Liebefeld</a:t>
-            </a:r>
-          </a:p>
-        </p:txBody>
-      </p:sp>
-      <p:sp>
-        <p:nvSpPr>
-          <p:cNvPr id="905" name="TextBox 904"/>
+              <a:t>Team Ctrl+Free</a:t>
+            </a:r>
+          </a:p>
+        </p:txBody>
+      </p:sp>
+      <p:sp>
+        <p:nvSpPr>
+          <p:cNvPr id="905" name="Challenge owner label"/>
           <p:cNvSpPr txBox="1"/>
           <p:nvPr/>
         </p:nvSpPr>
         <p:spPr>
           <a:xfrm>
-            <a:off x="7269480" y="5577840"/>
-            <a:ext cx="1828800" cy="274320"/>
+            <a:off x="7269480" y="5753100"/>
+            <a:ext cx="1371600" cy="152400"/>
           </a:xfrm>
           <a:prstGeom prst="rect">
             <a:avLst/>
@@ -21198,11 +21391,11 @@
           <a:p>
             <a:pPr algn="l">
               <a:spcAft>
-                <a:spcPts val="600"/>
+                <a:spcPts val="0"/>
               </a:spcAft>
             </a:pPr>
             <a:r>
-              <a:rPr sz="1000" b="0" i="0">
+              <a:rPr lang="en-GB" sz="1000" b="0" i="0">
                 <a:solidFill>
                   <a:srgbClr val="63737B"/>
                 </a:solidFill>
@@ -21214,7 +21407,7 @@
       </p:sp>
       <p:pic>
         <p:nvPicPr>
-          <p:cNvPr id="906" name="Picture 905" descr="logo.png"/>
+          <p:cNvPr id="906" name="Bern Economic Development Agency logo" descr="Bern Economic Development Agency"/>
           <p:cNvPicPr>
             <a:picLocks noChangeAspect="1"/>
           </p:cNvPicPr>
@@ -21228,7 +21421,7 @@
         </p:blipFill>
         <p:spPr>
           <a:xfrm>
-            <a:off x="8778240" y="5486400"/>
+            <a:off x="8778240" y="5577840"/>
             <a:ext cx="1566717" cy="502920"/>
           </a:xfrm>
           <a:prstGeom prst="rect">

</xml_diff>

<commit_message>
Pitch decks: drop date and footer, align challenge owner lockup
Remove the date and footer placeholders from every slide. Right-align the
"Challenge owner" label against the agency logo on the logo's text baseline,
center the pair under the Mutz artwork, and put "Team Ctrl+Free" on the same
baseline.

Co-Authored-By: Claude Opus 5.5 <noreply@anthropic.com>
</commit_message>
<xml_diff>
--- a/research/Mutz_Pitch_lean_animated.pptx
+++ b/research/Mutz_Pitch_lean_animated.pptx
@@ -6523,7 +6523,7 @@
     <p:sldLayoutId id="2147483663" r:id="rId14"/>
     <p:sldLayoutId id="2147483664" r:id="rId15"/>
   </p:sldLayoutIdLst>
-  <p:hf hdr="0"/>
+  <p:hf hdr="0" dt="0" ftr="0"/>
   <p:txStyles>
     <p:titleStyle>
       <a:lvl1pPr algn="l" defTabSz="447675" rtl="0" eaLnBrk="1" latinLnBrk="0" hangingPunct="1">
@@ -6919,64 +6919,6 @@
       </p:sp>
       <p:sp>
         <p:nvSpPr>
-          <p:cNvPr id="900" name="Datumsplatzhalter 3">
-            <a:extLst>
-              <a:ext uri="{FF2B5EF4-FFF2-40B4-BE49-F238E27FC236}">
-                <a16:creationId xmlns:a16="http://schemas.microsoft.com/office/drawing/2014/main" id="{7759626A-D212-47F9-AD91-396A99606B59}"/>
-              </a:ext>
-            </a:extLst>
-          </p:cNvPr>
-          <p:cNvSpPr>
-            <a:spLocks noGrp="1"/>
-          </p:cNvSpPr>
-          <p:nvPr>
-            <p:ph type="dt" sz="half" idx="10"/>
-          </p:nvPr>
-        </p:nvSpPr>
-        <p:spPr/>
-        <p:txBody>
-          <a:bodyPr/>
-          <a:lstStyle/>
-          <a:p>
-            <a:r>
-              <a:rPr lang="de-CH" smtClean="0"/>
-              <a:t>19 October 2026</a:t>
-            </a:r>
-            <a:endParaRPr lang="de-CH" dirty="0"/>
-          </a:p>
-        </p:txBody>
-      </p:sp>
-      <p:sp>
-        <p:nvSpPr>
-          <p:cNvPr id="901" name="Fußzeilenplatzhalter 4">
-            <a:extLst>
-              <a:ext uri="{FF2B5EF4-FFF2-40B4-BE49-F238E27FC236}">
-                <a16:creationId xmlns:a16="http://schemas.microsoft.com/office/drawing/2014/main" id="{C7FF4EBF-1F95-422C-ABDC-BAC99BA2526A}"/>
-              </a:ext>
-            </a:extLst>
-          </p:cNvPr>
-          <p:cNvSpPr>
-            <a:spLocks noGrp="1"/>
-          </p:cNvSpPr>
-          <p:nvPr>
-            <p:ph type="ftr" sz="quarter" idx="11"/>
-          </p:nvPr>
-        </p:nvSpPr>
-        <p:spPr/>
-        <p:txBody>
-          <a:bodyPr/>
-          <a:lstStyle/>
-          <a:p>
-            <a:r>
-              <a:rPr lang="de-CH"/>
-              <a:t>Team Ctrl+Free</a:t>
-            </a:r>
-            <a:endParaRPr lang="de-CH" dirty="0"/>
-          </a:p>
-        </p:txBody>
-      </p:sp>
-      <p:sp>
-        <p:nvSpPr>
           <p:cNvPr id="902" name="Foliennummernplatzhalter 5">
             <a:extLst>
               <a:ext uri="{FF2B5EF4-FFF2-40B4-BE49-F238E27FC236}">
@@ -7214,64 +7156,6 @@
       </p:sp>
       <p:sp>
         <p:nvSpPr>
-          <p:cNvPr id="900" name="Datumsplatzhalter 3">
-            <a:extLst>
-              <a:ext uri="{FF2B5EF4-FFF2-40B4-BE49-F238E27FC236}">
-                <a16:creationId xmlns:a16="http://schemas.microsoft.com/office/drawing/2014/main" id="{7759626A-D212-47F9-AD91-396A99606B59}"/>
-              </a:ext>
-            </a:extLst>
-          </p:cNvPr>
-          <p:cNvSpPr>
-            <a:spLocks noGrp="1"/>
-          </p:cNvSpPr>
-          <p:nvPr>
-            <p:ph type="dt" sz="half" idx="10"/>
-          </p:nvPr>
-        </p:nvSpPr>
-        <p:spPr/>
-        <p:txBody>
-          <a:bodyPr/>
-          <a:lstStyle/>
-          <a:p>
-            <a:r>
-              <a:rPr lang="de-CH" smtClean="0"/>
-              <a:t>19 October 2026</a:t>
-            </a:r>
-            <a:endParaRPr lang="de-CH" dirty="0"/>
-          </a:p>
-        </p:txBody>
-      </p:sp>
-      <p:sp>
-        <p:nvSpPr>
-          <p:cNvPr id="901" name="Fußzeilenplatzhalter 4">
-            <a:extLst>
-              <a:ext uri="{FF2B5EF4-FFF2-40B4-BE49-F238E27FC236}">
-                <a16:creationId xmlns:a16="http://schemas.microsoft.com/office/drawing/2014/main" id="{C7FF4EBF-1F95-422C-ABDC-BAC99BA2526A}"/>
-              </a:ext>
-            </a:extLst>
-          </p:cNvPr>
-          <p:cNvSpPr>
-            <a:spLocks noGrp="1"/>
-          </p:cNvSpPr>
-          <p:nvPr>
-            <p:ph type="ftr" sz="quarter" idx="11"/>
-          </p:nvPr>
-        </p:nvSpPr>
-        <p:spPr/>
-        <p:txBody>
-          <a:bodyPr/>
-          <a:lstStyle/>
-          <a:p>
-            <a:r>
-              <a:rPr lang="de-CH"/>
-              <a:t>Team Ctrl+Free</a:t>
-            </a:r>
-            <a:endParaRPr lang="de-CH" dirty="0"/>
-          </a:p>
-        </p:txBody>
-      </p:sp>
-      <p:sp>
-        <p:nvSpPr>
           <p:cNvPr id="902" name="Foliennummernplatzhalter 5">
             <a:extLst>
               <a:ext uri="{FF2B5EF4-FFF2-40B4-BE49-F238E27FC236}">
@@ -7821,64 +7705,6 @@
       </p:sp>
       <p:sp>
         <p:nvSpPr>
-          <p:cNvPr id="900" name="Datumsplatzhalter 3">
-            <a:extLst>
-              <a:ext uri="{FF2B5EF4-FFF2-40B4-BE49-F238E27FC236}">
-                <a16:creationId xmlns:a16="http://schemas.microsoft.com/office/drawing/2014/main" id="{7759626A-D212-47F9-AD91-396A99606B59}"/>
-              </a:ext>
-            </a:extLst>
-          </p:cNvPr>
-          <p:cNvSpPr>
-            <a:spLocks noGrp="1"/>
-          </p:cNvSpPr>
-          <p:nvPr>
-            <p:ph type="dt" sz="half" idx="10"/>
-          </p:nvPr>
-        </p:nvSpPr>
-        <p:spPr/>
-        <p:txBody>
-          <a:bodyPr/>
-          <a:lstStyle/>
-          <a:p>
-            <a:r>
-              <a:rPr lang="de-CH" smtClean="0"/>
-              <a:t>19 October 2026</a:t>
-            </a:r>
-            <a:endParaRPr lang="de-CH" dirty="0"/>
-          </a:p>
-        </p:txBody>
-      </p:sp>
-      <p:sp>
-        <p:nvSpPr>
-          <p:cNvPr id="901" name="Fußzeilenplatzhalter 4">
-            <a:extLst>
-              <a:ext uri="{FF2B5EF4-FFF2-40B4-BE49-F238E27FC236}">
-                <a16:creationId xmlns:a16="http://schemas.microsoft.com/office/drawing/2014/main" id="{C7FF4EBF-1F95-422C-ABDC-BAC99BA2526A}"/>
-              </a:ext>
-            </a:extLst>
-          </p:cNvPr>
-          <p:cNvSpPr>
-            <a:spLocks noGrp="1"/>
-          </p:cNvSpPr>
-          <p:nvPr>
-            <p:ph type="ftr" sz="quarter" idx="11"/>
-          </p:nvPr>
-        </p:nvSpPr>
-        <p:spPr/>
-        <p:txBody>
-          <a:bodyPr/>
-          <a:lstStyle/>
-          <a:p>
-            <a:r>
-              <a:rPr lang="de-CH"/>
-              <a:t>Team Ctrl+Free</a:t>
-            </a:r>
-            <a:endParaRPr lang="de-CH" dirty="0"/>
-          </a:p>
-        </p:txBody>
-      </p:sp>
-      <p:sp>
-        <p:nvSpPr>
           <p:cNvPr id="902" name="Foliennummernplatzhalter 5">
             <a:extLst>
               <a:ext uri="{FF2B5EF4-FFF2-40B4-BE49-F238E27FC236}">
@@ -7951,64 +7777,6 @@
       </p:sp>
       <p:sp>
         <p:nvSpPr>
-          <p:cNvPr id="900" name="Datumsplatzhalter 3">
-            <a:extLst>
-              <a:ext uri="{FF2B5EF4-FFF2-40B4-BE49-F238E27FC236}">
-                <a16:creationId xmlns:a16="http://schemas.microsoft.com/office/drawing/2014/main" id="{7759626A-D212-47F9-AD91-396A99606B59}"/>
-              </a:ext>
-            </a:extLst>
-          </p:cNvPr>
-          <p:cNvSpPr>
-            <a:spLocks noGrp="1"/>
-          </p:cNvSpPr>
-          <p:nvPr>
-            <p:ph type="dt" sz="half" idx="10"/>
-          </p:nvPr>
-        </p:nvSpPr>
-        <p:spPr/>
-        <p:txBody>
-          <a:bodyPr/>
-          <a:lstStyle/>
-          <a:p>
-            <a:r>
-              <a:rPr lang="de-CH" smtClean="0"/>
-              <a:t>19 October 2026</a:t>
-            </a:r>
-            <a:endParaRPr lang="de-CH" dirty="0"/>
-          </a:p>
-        </p:txBody>
-      </p:sp>
-      <p:sp>
-        <p:nvSpPr>
-          <p:cNvPr id="901" name="Fußzeilenplatzhalter 4">
-            <a:extLst>
-              <a:ext uri="{FF2B5EF4-FFF2-40B4-BE49-F238E27FC236}">
-                <a16:creationId xmlns:a16="http://schemas.microsoft.com/office/drawing/2014/main" id="{C7FF4EBF-1F95-422C-ABDC-BAC99BA2526A}"/>
-              </a:ext>
-            </a:extLst>
-          </p:cNvPr>
-          <p:cNvSpPr>
-            <a:spLocks noGrp="1"/>
-          </p:cNvSpPr>
-          <p:nvPr>
-            <p:ph type="ftr" sz="quarter" idx="11"/>
-          </p:nvPr>
-        </p:nvSpPr>
-        <p:spPr/>
-        <p:txBody>
-          <a:bodyPr/>
-          <a:lstStyle/>
-          <a:p>
-            <a:r>
-              <a:rPr lang="de-CH"/>
-              <a:t>Team Ctrl+Free</a:t>
-            </a:r>
-            <a:endParaRPr lang="de-CH" dirty="0"/>
-          </a:p>
-        </p:txBody>
-      </p:sp>
-      <p:sp>
-        <p:nvSpPr>
           <p:cNvPr id="902" name="Foliennummernplatzhalter 5">
             <a:extLst>
               <a:ext uri="{FF2B5EF4-FFF2-40B4-BE49-F238E27FC236}">
@@ -9664,64 +9432,6 @@
       </p:sp>
       <p:sp>
         <p:nvSpPr>
-          <p:cNvPr id="900" name="Datumsplatzhalter 3">
-            <a:extLst>
-              <a:ext uri="{FF2B5EF4-FFF2-40B4-BE49-F238E27FC236}">
-                <a16:creationId xmlns:a16="http://schemas.microsoft.com/office/drawing/2014/main" id="{7759626A-D212-47F9-AD91-396A99606B59}"/>
-              </a:ext>
-            </a:extLst>
-          </p:cNvPr>
-          <p:cNvSpPr>
-            <a:spLocks noGrp="1"/>
-          </p:cNvSpPr>
-          <p:nvPr>
-            <p:ph type="dt" sz="half" idx="10"/>
-          </p:nvPr>
-        </p:nvSpPr>
-        <p:spPr/>
-        <p:txBody>
-          <a:bodyPr/>
-          <a:lstStyle/>
-          <a:p>
-            <a:r>
-              <a:rPr lang="de-CH" smtClean="0"/>
-              <a:t>19 October 2026</a:t>
-            </a:r>
-            <a:endParaRPr lang="de-CH" dirty="0"/>
-          </a:p>
-        </p:txBody>
-      </p:sp>
-      <p:sp>
-        <p:nvSpPr>
-          <p:cNvPr id="901" name="Fußzeilenplatzhalter 4">
-            <a:extLst>
-              <a:ext uri="{FF2B5EF4-FFF2-40B4-BE49-F238E27FC236}">
-                <a16:creationId xmlns:a16="http://schemas.microsoft.com/office/drawing/2014/main" id="{C7FF4EBF-1F95-422C-ABDC-BAC99BA2526A}"/>
-              </a:ext>
-            </a:extLst>
-          </p:cNvPr>
-          <p:cNvSpPr>
-            <a:spLocks noGrp="1"/>
-          </p:cNvSpPr>
-          <p:nvPr>
-            <p:ph type="ftr" sz="quarter" idx="11"/>
-          </p:nvPr>
-        </p:nvSpPr>
-        <p:spPr/>
-        <p:txBody>
-          <a:bodyPr/>
-          <a:lstStyle/>
-          <a:p>
-            <a:r>
-              <a:rPr lang="de-CH"/>
-              <a:t>Team Ctrl+Free</a:t>
-            </a:r>
-            <a:endParaRPr lang="de-CH" dirty="0"/>
-          </a:p>
-        </p:txBody>
-      </p:sp>
-      <p:sp>
-        <p:nvSpPr>
           <p:cNvPr id="902" name="Foliennummernplatzhalter 5">
             <a:extLst>
               <a:ext uri="{FF2B5EF4-FFF2-40B4-BE49-F238E27FC236}">
@@ -10364,64 +10074,6 @@
       </p:sp>
       <p:sp>
         <p:nvSpPr>
-          <p:cNvPr id="900" name="Datumsplatzhalter 3">
-            <a:extLst>
-              <a:ext uri="{FF2B5EF4-FFF2-40B4-BE49-F238E27FC236}">
-                <a16:creationId xmlns:a16="http://schemas.microsoft.com/office/drawing/2014/main" id="{7759626A-D212-47F9-AD91-396A99606B59}"/>
-              </a:ext>
-            </a:extLst>
-          </p:cNvPr>
-          <p:cNvSpPr>
-            <a:spLocks noGrp="1"/>
-          </p:cNvSpPr>
-          <p:nvPr>
-            <p:ph type="dt" sz="half" idx="10"/>
-          </p:nvPr>
-        </p:nvSpPr>
-        <p:spPr/>
-        <p:txBody>
-          <a:bodyPr/>
-          <a:lstStyle/>
-          <a:p>
-            <a:r>
-              <a:rPr lang="de-CH" smtClean="0"/>
-              <a:t>19 October 2026</a:t>
-            </a:r>
-            <a:endParaRPr lang="de-CH" dirty="0"/>
-          </a:p>
-        </p:txBody>
-      </p:sp>
-      <p:sp>
-        <p:nvSpPr>
-          <p:cNvPr id="901" name="Fußzeilenplatzhalter 4">
-            <a:extLst>
-              <a:ext uri="{FF2B5EF4-FFF2-40B4-BE49-F238E27FC236}">
-                <a16:creationId xmlns:a16="http://schemas.microsoft.com/office/drawing/2014/main" id="{C7FF4EBF-1F95-422C-ABDC-BAC99BA2526A}"/>
-              </a:ext>
-            </a:extLst>
-          </p:cNvPr>
-          <p:cNvSpPr>
-            <a:spLocks noGrp="1"/>
-          </p:cNvSpPr>
-          <p:nvPr>
-            <p:ph type="ftr" sz="quarter" idx="11"/>
-          </p:nvPr>
-        </p:nvSpPr>
-        <p:spPr/>
-        <p:txBody>
-          <a:bodyPr/>
-          <a:lstStyle/>
-          <a:p>
-            <a:r>
-              <a:rPr lang="de-CH"/>
-              <a:t>Team Ctrl+Free</a:t>
-            </a:r>
-            <a:endParaRPr lang="de-CH" dirty="0"/>
-          </a:p>
-        </p:txBody>
-      </p:sp>
-      <p:sp>
-        <p:nvSpPr>
           <p:cNvPr id="902" name="Foliennummernplatzhalter 5">
             <a:extLst>
               <a:ext uri="{FF2B5EF4-FFF2-40B4-BE49-F238E27FC236}">
@@ -11171,64 +10823,6 @@
             <a:r>
               <a:t>Bern's research never sits idle</a:t>
             </a:r>
-          </a:p>
-        </p:txBody>
-      </p:sp>
-      <p:sp>
-        <p:nvSpPr>
-          <p:cNvPr id="900" name="Datumsplatzhalter 3">
-            <a:extLst>
-              <a:ext uri="{FF2B5EF4-FFF2-40B4-BE49-F238E27FC236}">
-                <a16:creationId xmlns:a16="http://schemas.microsoft.com/office/drawing/2014/main" id="{7759626A-D212-47F9-AD91-396A99606B59}"/>
-              </a:ext>
-            </a:extLst>
-          </p:cNvPr>
-          <p:cNvSpPr>
-            <a:spLocks noGrp="1"/>
-          </p:cNvSpPr>
-          <p:nvPr>
-            <p:ph type="dt" sz="half" idx="10"/>
-          </p:nvPr>
-        </p:nvSpPr>
-        <p:spPr/>
-        <p:txBody>
-          <a:bodyPr/>
-          <a:lstStyle/>
-          <a:p>
-            <a:r>
-              <a:rPr lang="de-CH" smtClean="0"/>
-              <a:t>19 October 2026</a:t>
-            </a:r>
-            <a:endParaRPr lang="de-CH" dirty="0"/>
-          </a:p>
-        </p:txBody>
-      </p:sp>
-      <p:sp>
-        <p:nvSpPr>
-          <p:cNvPr id="901" name="Fußzeilenplatzhalter 4">
-            <a:extLst>
-              <a:ext uri="{FF2B5EF4-FFF2-40B4-BE49-F238E27FC236}">
-                <a16:creationId xmlns:a16="http://schemas.microsoft.com/office/drawing/2014/main" id="{C7FF4EBF-1F95-422C-ABDC-BAC99BA2526A}"/>
-              </a:ext>
-            </a:extLst>
-          </p:cNvPr>
-          <p:cNvSpPr>
-            <a:spLocks noGrp="1"/>
-          </p:cNvSpPr>
-          <p:nvPr>
-            <p:ph type="ftr" sz="quarter" idx="11"/>
-          </p:nvPr>
-        </p:nvSpPr>
-        <p:spPr/>
-        <p:txBody>
-          <a:bodyPr/>
-          <a:lstStyle/>
-          <a:p>
-            <a:r>
-              <a:rPr lang="de-CH"/>
-              <a:t>Team Ctrl+Free</a:t>
-            </a:r>
-            <a:endParaRPr lang="de-CH" dirty="0"/>
           </a:p>
         </p:txBody>
       </p:sp>
@@ -12813,64 +12407,6 @@
       </p:sp>
       <p:sp>
         <p:nvSpPr>
-          <p:cNvPr id="900" name="Datumsplatzhalter 3">
-            <a:extLst>
-              <a:ext uri="{FF2B5EF4-FFF2-40B4-BE49-F238E27FC236}">
-                <a16:creationId xmlns:a16="http://schemas.microsoft.com/office/drawing/2014/main" id="{7759626A-D212-47F9-AD91-396A99606B59}"/>
-              </a:ext>
-            </a:extLst>
-          </p:cNvPr>
-          <p:cNvSpPr>
-            <a:spLocks noGrp="1"/>
-          </p:cNvSpPr>
-          <p:nvPr>
-            <p:ph type="dt" sz="half" idx="10"/>
-          </p:nvPr>
-        </p:nvSpPr>
-        <p:spPr/>
-        <p:txBody>
-          <a:bodyPr/>
-          <a:lstStyle/>
-          <a:p>
-            <a:r>
-              <a:rPr lang="de-CH" smtClean="0"/>
-              <a:t>19 October 2026</a:t>
-            </a:r>
-            <a:endParaRPr lang="de-CH" dirty="0"/>
-          </a:p>
-        </p:txBody>
-      </p:sp>
-      <p:sp>
-        <p:nvSpPr>
-          <p:cNvPr id="901" name="Fußzeilenplatzhalter 4">
-            <a:extLst>
-              <a:ext uri="{FF2B5EF4-FFF2-40B4-BE49-F238E27FC236}">
-                <a16:creationId xmlns:a16="http://schemas.microsoft.com/office/drawing/2014/main" id="{C7FF4EBF-1F95-422C-ABDC-BAC99BA2526A}"/>
-              </a:ext>
-            </a:extLst>
-          </p:cNvPr>
-          <p:cNvSpPr>
-            <a:spLocks noGrp="1"/>
-          </p:cNvSpPr>
-          <p:nvPr>
-            <p:ph type="ftr" sz="quarter" idx="11"/>
-          </p:nvPr>
-        </p:nvSpPr>
-        <p:spPr/>
-        <p:txBody>
-          <a:bodyPr/>
-          <a:lstStyle/>
-          <a:p>
-            <a:r>
-              <a:rPr lang="de-CH"/>
-              <a:t>Team Ctrl+Free</a:t>
-            </a:r>
-            <a:endParaRPr lang="de-CH" dirty="0"/>
-          </a:p>
-        </p:txBody>
-      </p:sp>
-      <p:sp>
-        <p:nvSpPr>
           <p:cNvPr id="902" name="Foliennummernplatzhalter 5">
             <a:extLst>
               <a:ext uri="{FF2B5EF4-FFF2-40B4-BE49-F238E27FC236}">
@@ -14138,64 +13674,6 @@
       </p:sp>
       <p:sp>
         <p:nvSpPr>
-          <p:cNvPr id="900" name="Datumsplatzhalter 3">
-            <a:extLst>
-              <a:ext uri="{FF2B5EF4-FFF2-40B4-BE49-F238E27FC236}">
-                <a16:creationId xmlns:a16="http://schemas.microsoft.com/office/drawing/2014/main" id="{7759626A-D212-47F9-AD91-396A99606B59}"/>
-              </a:ext>
-            </a:extLst>
-          </p:cNvPr>
-          <p:cNvSpPr>
-            <a:spLocks noGrp="1"/>
-          </p:cNvSpPr>
-          <p:nvPr>
-            <p:ph type="dt" sz="half" idx="10"/>
-          </p:nvPr>
-        </p:nvSpPr>
-        <p:spPr/>
-        <p:txBody>
-          <a:bodyPr/>
-          <a:lstStyle/>
-          <a:p>
-            <a:r>
-              <a:rPr lang="de-CH" smtClean="0"/>
-              <a:t>19 October 2026</a:t>
-            </a:r>
-            <a:endParaRPr lang="de-CH" dirty="0"/>
-          </a:p>
-        </p:txBody>
-      </p:sp>
-      <p:sp>
-        <p:nvSpPr>
-          <p:cNvPr id="901" name="Fußzeilenplatzhalter 4">
-            <a:extLst>
-              <a:ext uri="{FF2B5EF4-FFF2-40B4-BE49-F238E27FC236}">
-                <a16:creationId xmlns:a16="http://schemas.microsoft.com/office/drawing/2014/main" id="{C7FF4EBF-1F95-422C-ABDC-BAC99BA2526A}"/>
-              </a:ext>
-            </a:extLst>
-          </p:cNvPr>
-          <p:cNvSpPr>
-            <a:spLocks noGrp="1"/>
-          </p:cNvSpPr>
-          <p:nvPr>
-            <p:ph type="ftr" sz="quarter" idx="11"/>
-          </p:nvPr>
-        </p:nvSpPr>
-        <p:spPr/>
-        <p:txBody>
-          <a:bodyPr/>
-          <a:lstStyle/>
-          <a:p>
-            <a:r>
-              <a:rPr lang="de-CH"/>
-              <a:t>Team Ctrl+Free</a:t>
-            </a:r>
-            <a:endParaRPr lang="de-CH" dirty="0"/>
-          </a:p>
-        </p:txBody>
-      </p:sp>
-      <p:sp>
-        <p:nvSpPr>
           <p:cNvPr id="902" name="Foliennummernplatzhalter 5">
             <a:extLst>
               <a:ext uri="{FF2B5EF4-FFF2-40B4-BE49-F238E27FC236}">
@@ -14720,64 +14198,6 @@
       </p:sp>
       <p:sp>
         <p:nvSpPr>
-          <p:cNvPr id="900" name="Datumsplatzhalter 3">
-            <a:extLst>
-              <a:ext uri="{FF2B5EF4-FFF2-40B4-BE49-F238E27FC236}">
-                <a16:creationId xmlns:a16="http://schemas.microsoft.com/office/drawing/2014/main" id="{7759626A-D212-47F9-AD91-396A99606B59}"/>
-              </a:ext>
-            </a:extLst>
-          </p:cNvPr>
-          <p:cNvSpPr>
-            <a:spLocks noGrp="1"/>
-          </p:cNvSpPr>
-          <p:nvPr>
-            <p:ph type="dt" sz="half" idx="10"/>
-          </p:nvPr>
-        </p:nvSpPr>
-        <p:spPr/>
-        <p:txBody>
-          <a:bodyPr/>
-          <a:lstStyle/>
-          <a:p>
-            <a:r>
-              <a:rPr lang="de-CH" smtClean="0"/>
-              <a:t>19 October 2026</a:t>
-            </a:r>
-            <a:endParaRPr lang="de-CH" dirty="0"/>
-          </a:p>
-        </p:txBody>
-      </p:sp>
-      <p:sp>
-        <p:nvSpPr>
-          <p:cNvPr id="901" name="Fußzeilenplatzhalter 4">
-            <a:extLst>
-              <a:ext uri="{FF2B5EF4-FFF2-40B4-BE49-F238E27FC236}">
-                <a16:creationId xmlns:a16="http://schemas.microsoft.com/office/drawing/2014/main" id="{C7FF4EBF-1F95-422C-ABDC-BAC99BA2526A}"/>
-              </a:ext>
-            </a:extLst>
-          </p:cNvPr>
-          <p:cNvSpPr>
-            <a:spLocks noGrp="1"/>
-          </p:cNvSpPr>
-          <p:nvPr>
-            <p:ph type="ftr" sz="quarter" idx="11"/>
-          </p:nvPr>
-        </p:nvSpPr>
-        <p:spPr/>
-        <p:txBody>
-          <a:bodyPr/>
-          <a:lstStyle/>
-          <a:p>
-            <a:r>
-              <a:rPr lang="de-CH"/>
-              <a:t>Team Ctrl+Free</a:t>
-            </a:r>
-            <a:endParaRPr lang="de-CH" dirty="0"/>
-          </a:p>
-        </p:txBody>
-      </p:sp>
-      <p:sp>
-        <p:nvSpPr>
           <p:cNvPr id="902" name="Foliennummernplatzhalter 5">
             <a:extLst>
               <a:ext uri="{FF2B5EF4-FFF2-40B4-BE49-F238E27FC236}">
@@ -15477,64 +14897,6 @@
       </p:sp>
       <p:sp>
         <p:nvSpPr>
-          <p:cNvPr id="900" name="Datumsplatzhalter 3">
-            <a:extLst>
-              <a:ext uri="{FF2B5EF4-FFF2-40B4-BE49-F238E27FC236}">
-                <a16:creationId xmlns:a16="http://schemas.microsoft.com/office/drawing/2014/main" id="{7759626A-D212-47F9-AD91-396A99606B59}"/>
-              </a:ext>
-            </a:extLst>
-          </p:cNvPr>
-          <p:cNvSpPr>
-            <a:spLocks noGrp="1"/>
-          </p:cNvSpPr>
-          <p:nvPr>
-            <p:ph type="dt" sz="half" idx="10"/>
-          </p:nvPr>
-        </p:nvSpPr>
-        <p:spPr/>
-        <p:txBody>
-          <a:bodyPr/>
-          <a:lstStyle/>
-          <a:p>
-            <a:r>
-              <a:rPr lang="de-CH" smtClean="0"/>
-              <a:t>19 October 2026</a:t>
-            </a:r>
-            <a:endParaRPr lang="de-CH" dirty="0"/>
-          </a:p>
-        </p:txBody>
-      </p:sp>
-      <p:sp>
-        <p:nvSpPr>
-          <p:cNvPr id="901" name="Fußzeilenplatzhalter 4">
-            <a:extLst>
-              <a:ext uri="{FF2B5EF4-FFF2-40B4-BE49-F238E27FC236}">
-                <a16:creationId xmlns:a16="http://schemas.microsoft.com/office/drawing/2014/main" id="{C7FF4EBF-1F95-422C-ABDC-BAC99BA2526A}"/>
-              </a:ext>
-            </a:extLst>
-          </p:cNvPr>
-          <p:cNvSpPr>
-            <a:spLocks noGrp="1"/>
-          </p:cNvSpPr>
-          <p:nvPr>
-            <p:ph type="ftr" sz="quarter" idx="11"/>
-          </p:nvPr>
-        </p:nvSpPr>
-        <p:spPr/>
-        <p:txBody>
-          <a:bodyPr/>
-          <a:lstStyle/>
-          <a:p>
-            <a:r>
-              <a:rPr lang="de-CH"/>
-              <a:t>Team Ctrl+Free</a:t>
-            </a:r>
-            <a:endParaRPr lang="de-CH" dirty="0"/>
-          </a:p>
-        </p:txBody>
-      </p:sp>
-      <p:sp>
-        <p:nvSpPr>
           <p:cNvPr id="902" name="Foliennummernplatzhalter 5">
             <a:extLst>
               <a:ext uri="{FF2B5EF4-FFF2-40B4-BE49-F238E27FC236}">
@@ -16856,64 +16218,6 @@
         <p:nvPr/>
       </p:nvGrpSpPr>
       <p:grpSpPr/>
-      <p:sp>
-        <p:nvSpPr>
-          <p:cNvPr id="900" name="Datumsplatzhalter 3">
-            <a:extLst>
-              <a:ext uri="{FF2B5EF4-FFF2-40B4-BE49-F238E27FC236}">
-                <a16:creationId xmlns:a16="http://schemas.microsoft.com/office/drawing/2014/main" id="{7759626A-D212-47F9-AD91-396A99606B59}"/>
-              </a:ext>
-            </a:extLst>
-          </p:cNvPr>
-          <p:cNvSpPr>
-            <a:spLocks noGrp="1"/>
-          </p:cNvSpPr>
-          <p:nvPr>
-            <p:ph type="dt" sz="half" idx="10"/>
-          </p:nvPr>
-        </p:nvSpPr>
-        <p:spPr/>
-        <p:txBody>
-          <a:bodyPr/>
-          <a:lstStyle/>
-          <a:p>
-            <a:r>
-              <a:rPr lang="de-CH" smtClean="0"/>
-              <a:t>19 October 2026</a:t>
-            </a:r>
-            <a:endParaRPr lang="de-CH" dirty="0"/>
-          </a:p>
-        </p:txBody>
-      </p:sp>
-      <p:sp>
-        <p:nvSpPr>
-          <p:cNvPr id="901" name="Fußzeilenplatzhalter 4">
-            <a:extLst>
-              <a:ext uri="{FF2B5EF4-FFF2-40B4-BE49-F238E27FC236}">
-                <a16:creationId xmlns:a16="http://schemas.microsoft.com/office/drawing/2014/main" id="{C7FF4EBF-1F95-422C-ABDC-BAC99BA2526A}"/>
-              </a:ext>
-            </a:extLst>
-          </p:cNvPr>
-          <p:cNvSpPr>
-            <a:spLocks noGrp="1"/>
-          </p:cNvSpPr>
-          <p:nvPr>
-            <p:ph type="ftr" sz="quarter" idx="11"/>
-          </p:nvPr>
-        </p:nvSpPr>
-        <p:spPr/>
-        <p:txBody>
-          <a:bodyPr/>
-          <a:lstStyle/>
-          <a:p>
-            <a:r>
-              <a:rPr lang="de-CH"/>
-              <a:t>Team Ctrl+Free</a:t>
-            </a:r>
-            <a:endParaRPr lang="de-CH" dirty="0"/>
-          </a:p>
-        </p:txBody>
-      </p:sp>
       <p:sp>
         <p:nvSpPr>
           <p:cNvPr id="902" name="Foliennummernplatzhalter 5">
@@ -17289,64 +16593,6 @@
       </p:sp>
       <p:sp>
         <p:nvSpPr>
-          <p:cNvPr id="900" name="Datumsplatzhalter 3">
-            <a:extLst>
-              <a:ext uri="{FF2B5EF4-FFF2-40B4-BE49-F238E27FC236}">
-                <a16:creationId xmlns:a16="http://schemas.microsoft.com/office/drawing/2014/main" id="{7759626A-D212-47F9-AD91-396A99606B59}"/>
-              </a:ext>
-            </a:extLst>
-          </p:cNvPr>
-          <p:cNvSpPr>
-            <a:spLocks noGrp="1"/>
-          </p:cNvSpPr>
-          <p:nvPr>
-            <p:ph type="dt" sz="half" idx="10"/>
-          </p:nvPr>
-        </p:nvSpPr>
-        <p:spPr/>
-        <p:txBody>
-          <a:bodyPr/>
-          <a:lstStyle/>
-          <a:p>
-            <a:r>
-              <a:rPr lang="de-CH" smtClean="0"/>
-              <a:t>19 October 2026</a:t>
-            </a:r>
-            <a:endParaRPr lang="de-CH" dirty="0"/>
-          </a:p>
-        </p:txBody>
-      </p:sp>
-      <p:sp>
-        <p:nvSpPr>
-          <p:cNvPr id="901" name="Fußzeilenplatzhalter 4">
-            <a:extLst>
-              <a:ext uri="{FF2B5EF4-FFF2-40B4-BE49-F238E27FC236}">
-                <a16:creationId xmlns:a16="http://schemas.microsoft.com/office/drawing/2014/main" id="{C7FF4EBF-1F95-422C-ABDC-BAC99BA2526A}"/>
-              </a:ext>
-            </a:extLst>
-          </p:cNvPr>
-          <p:cNvSpPr>
-            <a:spLocks noGrp="1"/>
-          </p:cNvSpPr>
-          <p:nvPr>
-            <p:ph type="ftr" sz="quarter" idx="11"/>
-          </p:nvPr>
-        </p:nvSpPr>
-        <p:spPr/>
-        <p:txBody>
-          <a:bodyPr/>
-          <a:lstStyle/>
-          <a:p>
-            <a:r>
-              <a:rPr lang="de-CH"/>
-              <a:t>Team Ctrl+Free</a:t>
-            </a:r>
-            <a:endParaRPr lang="de-CH" dirty="0"/>
-          </a:p>
-        </p:txBody>
-      </p:sp>
-      <p:sp>
-        <p:nvSpPr>
           <p:cNvPr id="902" name="Foliennummernplatzhalter 5">
             <a:extLst>
               <a:ext uri="{FF2B5EF4-FFF2-40B4-BE49-F238E27FC236}">
@@ -18091,64 +17337,6 @@
       <p:grpSpPr/>
       <p:sp>
         <p:nvSpPr>
-          <p:cNvPr id="900" name="Datumsplatzhalter 3">
-            <a:extLst>
-              <a:ext uri="{FF2B5EF4-FFF2-40B4-BE49-F238E27FC236}">
-                <a16:creationId xmlns:a16="http://schemas.microsoft.com/office/drawing/2014/main" id="{7759626A-D212-47F9-AD91-396A99606B59}"/>
-              </a:ext>
-            </a:extLst>
-          </p:cNvPr>
-          <p:cNvSpPr>
-            <a:spLocks noGrp="1"/>
-          </p:cNvSpPr>
-          <p:nvPr>
-            <p:ph type="dt" sz="half" idx="10"/>
-          </p:nvPr>
-        </p:nvSpPr>
-        <p:spPr/>
-        <p:txBody>
-          <a:bodyPr/>
-          <a:lstStyle/>
-          <a:p>
-            <a:r>
-              <a:rPr lang="de-CH" smtClean="0"/>
-              <a:t>19 October 2026</a:t>
-            </a:r>
-            <a:endParaRPr lang="de-CH" dirty="0"/>
-          </a:p>
-        </p:txBody>
-      </p:sp>
-      <p:sp>
-        <p:nvSpPr>
-          <p:cNvPr id="901" name="Fußzeilenplatzhalter 4">
-            <a:extLst>
-              <a:ext uri="{FF2B5EF4-FFF2-40B4-BE49-F238E27FC236}">
-                <a16:creationId xmlns:a16="http://schemas.microsoft.com/office/drawing/2014/main" id="{C7FF4EBF-1F95-422C-ABDC-BAC99BA2526A}"/>
-              </a:ext>
-            </a:extLst>
-          </p:cNvPr>
-          <p:cNvSpPr>
-            <a:spLocks noGrp="1"/>
-          </p:cNvSpPr>
-          <p:nvPr>
-            <p:ph type="ftr" sz="quarter" idx="11"/>
-          </p:nvPr>
-        </p:nvSpPr>
-        <p:spPr/>
-        <p:txBody>
-          <a:bodyPr/>
-          <a:lstStyle/>
-          <a:p>
-            <a:r>
-              <a:rPr lang="de-CH"/>
-              <a:t>Team Ctrl+Free</a:t>
-            </a:r>
-            <a:endParaRPr lang="de-CH" dirty="0"/>
-          </a:p>
-        </p:txBody>
-      </p:sp>
-      <p:sp>
-        <p:nvSpPr>
           <p:cNvPr id="902" name="Foliennummernplatzhalter 5">
             <a:extLst>
               <a:ext uri="{FF2B5EF4-FFF2-40B4-BE49-F238E27FC236}">
@@ -18299,7 +17487,7 @@
         </p:nvSpPr>
         <p:spPr>
           <a:xfrm>
-            <a:off x="841248" y="5692140"/>
+            <a:off x="841248" y="5838354"/>
             <a:ext cx="5212080" cy="274320"/>
           </a:xfrm>
           <a:prstGeom prst="rect">
@@ -18370,7 +17558,7 @@
         </p:nvSpPr>
         <p:spPr>
           <a:xfrm>
-            <a:off x="7269480" y="5753100"/>
+            <a:off x="7318988" y="5930302"/>
             <a:ext cx="1371600" cy="152400"/>
           </a:xfrm>
           <a:prstGeom prst="rect">
@@ -18384,7 +17572,7 @@
           </a:bodyPr>
           <a:lstStyle/>
           <a:p>
-            <a:pPr algn="l">
+            <a:pPr algn="r">
               <a:spcAft>
                 <a:spcPts val="0"/>
               </a:spcAft>
@@ -18416,7 +17604,7 @@
         </p:blipFill>
         <p:spPr>
           <a:xfrm>
-            <a:off x="8778240" y="5577840"/>
+            <a:off x="8800316" y="5577840"/>
             <a:ext cx="1566717" cy="502920"/>
           </a:xfrm>
           <a:prstGeom prst="rect">
@@ -18708,64 +17896,6 @@
       <p:grpSpPr/>
       <p:sp>
         <p:nvSpPr>
-          <p:cNvPr id="900" name="Datumsplatzhalter 3">
-            <a:extLst>
-              <a:ext uri="{FF2B5EF4-FFF2-40B4-BE49-F238E27FC236}">
-                <a16:creationId xmlns:a16="http://schemas.microsoft.com/office/drawing/2014/main" id="{7759626A-D212-47F9-AD91-396A99606B59}"/>
-              </a:ext>
-            </a:extLst>
-          </p:cNvPr>
-          <p:cNvSpPr>
-            <a:spLocks noGrp="1"/>
-          </p:cNvSpPr>
-          <p:nvPr>
-            <p:ph type="dt" sz="half" idx="10"/>
-          </p:nvPr>
-        </p:nvSpPr>
-        <p:spPr/>
-        <p:txBody>
-          <a:bodyPr/>
-          <a:lstStyle/>
-          <a:p>
-            <a:r>
-              <a:rPr lang="de-CH" smtClean="0"/>
-              <a:t>19 October 2026</a:t>
-            </a:r>
-            <a:endParaRPr lang="de-CH" dirty="0"/>
-          </a:p>
-        </p:txBody>
-      </p:sp>
-      <p:sp>
-        <p:nvSpPr>
-          <p:cNvPr id="901" name="Fußzeilenplatzhalter 4">
-            <a:extLst>
-              <a:ext uri="{FF2B5EF4-FFF2-40B4-BE49-F238E27FC236}">
-                <a16:creationId xmlns:a16="http://schemas.microsoft.com/office/drawing/2014/main" id="{C7FF4EBF-1F95-422C-ABDC-BAC99BA2526A}"/>
-              </a:ext>
-            </a:extLst>
-          </p:cNvPr>
-          <p:cNvSpPr>
-            <a:spLocks noGrp="1"/>
-          </p:cNvSpPr>
-          <p:nvPr>
-            <p:ph type="ftr" sz="quarter" idx="11"/>
-          </p:nvPr>
-        </p:nvSpPr>
-        <p:spPr/>
-        <p:txBody>
-          <a:bodyPr/>
-          <a:lstStyle/>
-          <a:p>
-            <a:r>
-              <a:rPr lang="de-CH"/>
-              <a:t>Team Ctrl+Free</a:t>
-            </a:r>
-            <a:endParaRPr lang="de-CH" dirty="0"/>
-          </a:p>
-        </p:txBody>
-      </p:sp>
-      <p:sp>
-        <p:nvSpPr>
           <p:cNvPr id="902" name="Foliennummernplatzhalter 5">
             <a:extLst>
               <a:ext uri="{FF2B5EF4-FFF2-40B4-BE49-F238E27FC236}">
@@ -19097,64 +18227,6 @@
       </p:sp>
       <p:sp>
         <p:nvSpPr>
-          <p:cNvPr id="900" name="Datumsplatzhalter 3">
-            <a:extLst>
-              <a:ext uri="{FF2B5EF4-FFF2-40B4-BE49-F238E27FC236}">
-                <a16:creationId xmlns:a16="http://schemas.microsoft.com/office/drawing/2014/main" id="{7759626A-D212-47F9-AD91-396A99606B59}"/>
-              </a:ext>
-            </a:extLst>
-          </p:cNvPr>
-          <p:cNvSpPr>
-            <a:spLocks noGrp="1"/>
-          </p:cNvSpPr>
-          <p:nvPr>
-            <p:ph type="dt" sz="half" idx="10"/>
-          </p:nvPr>
-        </p:nvSpPr>
-        <p:spPr/>
-        <p:txBody>
-          <a:bodyPr/>
-          <a:lstStyle/>
-          <a:p>
-            <a:r>
-              <a:rPr lang="de-CH" smtClean="0"/>
-              <a:t>19 October 2026</a:t>
-            </a:r>
-            <a:endParaRPr lang="de-CH" dirty="0"/>
-          </a:p>
-        </p:txBody>
-      </p:sp>
-      <p:sp>
-        <p:nvSpPr>
-          <p:cNvPr id="901" name="Fußzeilenplatzhalter 4">
-            <a:extLst>
-              <a:ext uri="{FF2B5EF4-FFF2-40B4-BE49-F238E27FC236}">
-                <a16:creationId xmlns:a16="http://schemas.microsoft.com/office/drawing/2014/main" id="{C7FF4EBF-1F95-422C-ABDC-BAC99BA2526A}"/>
-              </a:ext>
-            </a:extLst>
-          </p:cNvPr>
-          <p:cNvSpPr>
-            <a:spLocks noGrp="1"/>
-          </p:cNvSpPr>
-          <p:nvPr>
-            <p:ph type="ftr" sz="quarter" idx="11"/>
-          </p:nvPr>
-        </p:nvSpPr>
-        <p:spPr/>
-        <p:txBody>
-          <a:bodyPr/>
-          <a:lstStyle/>
-          <a:p>
-            <a:r>
-              <a:rPr lang="de-CH"/>
-              <a:t>Team Ctrl+Free</a:t>
-            </a:r>
-            <a:endParaRPr lang="de-CH" dirty="0"/>
-          </a:p>
-        </p:txBody>
-      </p:sp>
-      <p:sp>
-        <p:nvSpPr>
           <p:cNvPr id="902" name="Foliennummernplatzhalter 5">
             <a:extLst>
               <a:ext uri="{FF2B5EF4-FFF2-40B4-BE49-F238E27FC236}">
@@ -19335,64 +18407,6 @@
             <a:r>
               <a:t>Honest and trustworthy by design</a:t>
             </a:r>
-          </a:p>
-        </p:txBody>
-      </p:sp>
-      <p:sp>
-        <p:nvSpPr>
-          <p:cNvPr id="900" name="Datumsplatzhalter 3">
-            <a:extLst>
-              <a:ext uri="{FF2B5EF4-FFF2-40B4-BE49-F238E27FC236}">
-                <a16:creationId xmlns:a16="http://schemas.microsoft.com/office/drawing/2014/main" id="{7759626A-D212-47F9-AD91-396A99606B59}"/>
-              </a:ext>
-            </a:extLst>
-          </p:cNvPr>
-          <p:cNvSpPr>
-            <a:spLocks noGrp="1"/>
-          </p:cNvSpPr>
-          <p:nvPr>
-            <p:ph type="dt" sz="half" idx="10"/>
-          </p:nvPr>
-        </p:nvSpPr>
-        <p:spPr/>
-        <p:txBody>
-          <a:bodyPr/>
-          <a:lstStyle/>
-          <a:p>
-            <a:r>
-              <a:rPr lang="de-CH" smtClean="0"/>
-              <a:t>19 October 2026</a:t>
-            </a:r>
-            <a:endParaRPr lang="de-CH" dirty="0"/>
-          </a:p>
-        </p:txBody>
-      </p:sp>
-      <p:sp>
-        <p:nvSpPr>
-          <p:cNvPr id="901" name="Fußzeilenplatzhalter 4">
-            <a:extLst>
-              <a:ext uri="{FF2B5EF4-FFF2-40B4-BE49-F238E27FC236}">
-                <a16:creationId xmlns:a16="http://schemas.microsoft.com/office/drawing/2014/main" id="{C7FF4EBF-1F95-422C-ABDC-BAC99BA2526A}"/>
-              </a:ext>
-            </a:extLst>
-          </p:cNvPr>
-          <p:cNvSpPr>
-            <a:spLocks noGrp="1"/>
-          </p:cNvSpPr>
-          <p:nvPr>
-            <p:ph type="ftr" sz="quarter" idx="11"/>
-          </p:nvPr>
-        </p:nvSpPr>
-        <p:spPr/>
-        <p:txBody>
-          <a:bodyPr/>
-          <a:lstStyle/>
-          <a:p>
-            <a:r>
-              <a:rPr lang="de-CH"/>
-              <a:t>Team Ctrl+Free</a:t>
-            </a:r>
-            <a:endParaRPr lang="de-CH" dirty="0"/>
           </a:p>
         </p:txBody>
       </p:sp>
@@ -19941,64 +18955,6 @@
       </p:sp>
       <p:sp>
         <p:nvSpPr>
-          <p:cNvPr id="900" name="Datumsplatzhalter 3">
-            <a:extLst>
-              <a:ext uri="{FF2B5EF4-FFF2-40B4-BE49-F238E27FC236}">
-                <a16:creationId xmlns:a16="http://schemas.microsoft.com/office/drawing/2014/main" id="{7759626A-D212-47F9-AD91-396A99606B59}"/>
-              </a:ext>
-            </a:extLst>
-          </p:cNvPr>
-          <p:cNvSpPr>
-            <a:spLocks noGrp="1"/>
-          </p:cNvSpPr>
-          <p:nvPr>
-            <p:ph type="dt" sz="half" idx="10"/>
-          </p:nvPr>
-        </p:nvSpPr>
-        <p:spPr/>
-        <p:txBody>
-          <a:bodyPr/>
-          <a:lstStyle/>
-          <a:p>
-            <a:r>
-              <a:rPr lang="de-CH" smtClean="0"/>
-              <a:t>19 October 2026</a:t>
-            </a:r>
-            <a:endParaRPr lang="de-CH" dirty="0"/>
-          </a:p>
-        </p:txBody>
-      </p:sp>
-      <p:sp>
-        <p:nvSpPr>
-          <p:cNvPr id="901" name="Fußzeilenplatzhalter 4">
-            <a:extLst>
-              <a:ext uri="{FF2B5EF4-FFF2-40B4-BE49-F238E27FC236}">
-                <a16:creationId xmlns:a16="http://schemas.microsoft.com/office/drawing/2014/main" id="{C7FF4EBF-1F95-422C-ABDC-BAC99BA2526A}"/>
-              </a:ext>
-            </a:extLst>
-          </p:cNvPr>
-          <p:cNvSpPr>
-            <a:spLocks noGrp="1"/>
-          </p:cNvSpPr>
-          <p:nvPr>
-            <p:ph type="ftr" sz="quarter" idx="11"/>
-          </p:nvPr>
-        </p:nvSpPr>
-        <p:spPr/>
-        <p:txBody>
-          <a:bodyPr/>
-          <a:lstStyle/>
-          <a:p>
-            <a:r>
-              <a:rPr lang="de-CH"/>
-              <a:t>Team Ctrl+Free</a:t>
-            </a:r>
-            <a:endParaRPr lang="de-CH" dirty="0"/>
-          </a:p>
-        </p:txBody>
-      </p:sp>
-      <p:sp>
-        <p:nvSpPr>
           <p:cNvPr id="902" name="Foliennummernplatzhalter 5">
             <a:extLst>
               <a:ext uri="{FF2B5EF4-FFF2-40B4-BE49-F238E27FC236}">
@@ -20477,64 +19433,6 @@
             <a:r>
               <a:t>Results</a:t>
             </a:r>
-          </a:p>
-        </p:txBody>
-      </p:sp>
-      <p:sp>
-        <p:nvSpPr>
-          <p:cNvPr id="900" name="Datumsplatzhalter 3">
-            <a:extLst>
-              <a:ext uri="{FF2B5EF4-FFF2-40B4-BE49-F238E27FC236}">
-                <a16:creationId xmlns:a16="http://schemas.microsoft.com/office/drawing/2014/main" id="{7759626A-D212-47F9-AD91-396A99606B59}"/>
-              </a:ext>
-            </a:extLst>
-          </p:cNvPr>
-          <p:cNvSpPr>
-            <a:spLocks noGrp="1"/>
-          </p:cNvSpPr>
-          <p:nvPr>
-            <p:ph type="dt" sz="half" idx="10"/>
-          </p:nvPr>
-        </p:nvSpPr>
-        <p:spPr/>
-        <p:txBody>
-          <a:bodyPr/>
-          <a:lstStyle/>
-          <a:p>
-            <a:r>
-              <a:rPr lang="de-CH" smtClean="0"/>
-              <a:t>19 October 2026</a:t>
-            </a:r>
-            <a:endParaRPr lang="de-CH" dirty="0"/>
-          </a:p>
-        </p:txBody>
-      </p:sp>
-      <p:sp>
-        <p:nvSpPr>
-          <p:cNvPr id="901" name="Fußzeilenplatzhalter 4">
-            <a:extLst>
-              <a:ext uri="{FF2B5EF4-FFF2-40B4-BE49-F238E27FC236}">
-                <a16:creationId xmlns:a16="http://schemas.microsoft.com/office/drawing/2014/main" id="{C7FF4EBF-1F95-422C-ABDC-BAC99BA2526A}"/>
-              </a:ext>
-            </a:extLst>
-          </p:cNvPr>
-          <p:cNvSpPr>
-            <a:spLocks noGrp="1"/>
-          </p:cNvSpPr>
-          <p:nvPr>
-            <p:ph type="ftr" sz="quarter" idx="11"/>
-          </p:nvPr>
-        </p:nvSpPr>
-        <p:spPr/>
-        <p:txBody>
-          <a:bodyPr/>
-          <a:lstStyle/>
-          <a:p>
-            <a:r>
-              <a:rPr lang="de-CH"/>
-              <a:t>Team Ctrl+Free</a:t>
-            </a:r>
-            <a:endParaRPr lang="de-CH" dirty="0"/>
           </a:p>
         </p:txBody>
       </p:sp>
@@ -21219,64 +20117,6 @@
       </p:sp>
       <p:sp>
         <p:nvSpPr>
-          <p:cNvPr id="900" name="Datumsplatzhalter 3">
-            <a:extLst>
-              <a:ext uri="{FF2B5EF4-FFF2-40B4-BE49-F238E27FC236}">
-                <a16:creationId xmlns:a16="http://schemas.microsoft.com/office/drawing/2014/main" id="{7759626A-D212-47F9-AD91-396A99606B59}"/>
-              </a:ext>
-            </a:extLst>
-          </p:cNvPr>
-          <p:cNvSpPr>
-            <a:spLocks noGrp="1"/>
-          </p:cNvSpPr>
-          <p:nvPr>
-            <p:ph type="dt" sz="half" idx="10"/>
-          </p:nvPr>
-        </p:nvSpPr>
-        <p:spPr/>
-        <p:txBody>
-          <a:bodyPr/>
-          <a:lstStyle/>
-          <a:p>
-            <a:r>
-              <a:rPr lang="de-CH" smtClean="0"/>
-              <a:t>19 October 2026</a:t>
-            </a:r>
-            <a:endParaRPr lang="de-CH" dirty="0"/>
-          </a:p>
-        </p:txBody>
-      </p:sp>
-      <p:sp>
-        <p:nvSpPr>
-          <p:cNvPr id="901" name="Fußzeilenplatzhalter 4">
-            <a:extLst>
-              <a:ext uri="{FF2B5EF4-FFF2-40B4-BE49-F238E27FC236}">
-                <a16:creationId xmlns:a16="http://schemas.microsoft.com/office/drawing/2014/main" id="{C7FF4EBF-1F95-422C-ABDC-BAC99BA2526A}"/>
-              </a:ext>
-            </a:extLst>
-          </p:cNvPr>
-          <p:cNvSpPr>
-            <a:spLocks noGrp="1"/>
-          </p:cNvSpPr>
-          <p:nvPr>
-            <p:ph type="ftr" sz="quarter" idx="11"/>
-          </p:nvPr>
-        </p:nvSpPr>
-        <p:spPr/>
-        <p:txBody>
-          <a:bodyPr/>
-          <a:lstStyle/>
-          <a:p>
-            <a:r>
-              <a:rPr lang="de-CH"/>
-              <a:t>Team Ctrl+Free</a:t>
-            </a:r>
-            <a:endParaRPr lang="de-CH" dirty="0"/>
-          </a:p>
-        </p:txBody>
-      </p:sp>
-      <p:sp>
-        <p:nvSpPr>
           <p:cNvPr id="902" name="Foliennummernplatzhalter 5">
             <a:extLst>
               <a:ext uri="{FF2B5EF4-FFF2-40B4-BE49-F238E27FC236}">
@@ -21337,7 +20177,7 @@
         </p:nvSpPr>
         <p:spPr>
           <a:xfrm>
-            <a:off x="841248" y="5692140"/>
+            <a:off x="841248" y="5838354"/>
             <a:ext cx="5212080" cy="274320"/>
           </a:xfrm>
           <a:prstGeom prst="rect">
@@ -21375,7 +20215,7 @@
         </p:nvSpPr>
         <p:spPr>
           <a:xfrm>
-            <a:off x="7269480" y="5753100"/>
+            <a:off x="7776188" y="5930302"/>
             <a:ext cx="1371600" cy="152400"/>
           </a:xfrm>
           <a:prstGeom prst="rect">
@@ -21389,7 +20229,7 @@
           </a:bodyPr>
           <a:lstStyle/>
           <a:p>
-            <a:pPr algn="l">
+            <a:pPr algn="r">
               <a:spcAft>
                 <a:spcPts val="0"/>
               </a:spcAft>
@@ -21421,7 +20261,7 @@
         </p:blipFill>
         <p:spPr>
           <a:xfrm>
-            <a:off x="8778240" y="5577840"/>
+            <a:off x="9257516" y="5577840"/>
             <a:ext cx="1566717" cy="502920"/>
           </a:xfrm>
           <a:prstGeom prst="rect">

</xml_diff>

<commit_message>
Pitch decks: keep Team Ctrl+Free footer, slide numbers bottom right
Restore the footer at the top right, move slide numbers to the bottom-right
margin on the slide master, and drop the bottom-left Team Ctrl+Free sign-off
on slides 3 and 9.

Co-Authored-By: Claude Opus 5.5 <noreply@anthropic.com>
</commit_message>
<xml_diff>
--- a/research/Mutz_Pitch_lean_animated.pptx
+++ b/research/Mutz_Pitch_lean_animated.pptx
@@ -6434,7 +6434,7 @@
         </p:nvSpPr>
         <p:spPr>
           <a:xfrm>
-            <a:off x="11496600" y="297072"/>
+            <a:off x="11496600" y="6452928"/>
             <a:ext cx="321625" cy="108000"/>
           </a:xfrm>
           <a:prstGeom prst="rect">
@@ -6523,7 +6523,7 @@
     <p:sldLayoutId id="2147483663" r:id="rId14"/>
     <p:sldLayoutId id="2147483664" r:id="rId15"/>
   </p:sldLayoutIdLst>
-  <p:hf hdr="0" dt="0" ftr="0"/>
+  <p:hf hdr="0" dt="0"/>
   <p:txStyles>
     <p:titleStyle>
       <a:lvl1pPr algn="l" defTabSz="447675" rtl="0" eaLnBrk="1" latinLnBrk="0" hangingPunct="1">
@@ -6919,6 +6919,35 @@
       </p:sp>
       <p:sp>
         <p:nvSpPr>
+          <p:cNvPr id="901" name="Fußzeilenplatzhalter 4">
+            <a:extLst>
+              <a:ext uri="{FF2B5EF4-FFF2-40B4-BE49-F238E27FC236}">
+                <a16:creationId xmlns:a16="http://schemas.microsoft.com/office/drawing/2014/main" id="{C7FF4EBF-1F95-422C-ABDC-BAC99BA2526A}"/>
+              </a:ext>
+            </a:extLst>
+          </p:cNvPr>
+          <p:cNvSpPr>
+            <a:spLocks noGrp="1"/>
+          </p:cNvSpPr>
+          <p:nvPr>
+            <p:ph type="ftr" sz="quarter" idx="11"/>
+          </p:nvPr>
+        </p:nvSpPr>
+        <p:spPr/>
+        <p:txBody>
+          <a:bodyPr/>
+          <a:lstStyle/>
+          <a:p>
+            <a:r>
+              <a:rPr lang="de-CH"/>
+              <a:t>Team Ctrl+Free</a:t>
+            </a:r>
+            <a:endParaRPr lang="de-CH" dirty="0"/>
+          </a:p>
+        </p:txBody>
+      </p:sp>
+      <p:sp>
+        <p:nvSpPr>
           <p:cNvPr id="902" name="Foliennummernplatzhalter 5">
             <a:extLst>
               <a:ext uri="{FF2B5EF4-FFF2-40B4-BE49-F238E27FC236}">
@@ -7156,6 +7185,35 @@
       </p:sp>
       <p:sp>
         <p:nvSpPr>
+          <p:cNvPr id="901" name="Fußzeilenplatzhalter 4">
+            <a:extLst>
+              <a:ext uri="{FF2B5EF4-FFF2-40B4-BE49-F238E27FC236}">
+                <a16:creationId xmlns:a16="http://schemas.microsoft.com/office/drawing/2014/main" id="{C7FF4EBF-1F95-422C-ABDC-BAC99BA2526A}"/>
+              </a:ext>
+            </a:extLst>
+          </p:cNvPr>
+          <p:cNvSpPr>
+            <a:spLocks noGrp="1"/>
+          </p:cNvSpPr>
+          <p:nvPr>
+            <p:ph type="ftr" sz="quarter" idx="11"/>
+          </p:nvPr>
+        </p:nvSpPr>
+        <p:spPr/>
+        <p:txBody>
+          <a:bodyPr/>
+          <a:lstStyle/>
+          <a:p>
+            <a:r>
+              <a:rPr lang="de-CH"/>
+              <a:t>Team Ctrl+Free</a:t>
+            </a:r>
+            <a:endParaRPr lang="de-CH" dirty="0"/>
+          </a:p>
+        </p:txBody>
+      </p:sp>
+      <p:sp>
+        <p:nvSpPr>
           <p:cNvPr id="902" name="Foliennummernplatzhalter 5">
             <a:extLst>
               <a:ext uri="{FF2B5EF4-FFF2-40B4-BE49-F238E27FC236}">
@@ -7705,6 +7763,35 @@
       </p:sp>
       <p:sp>
         <p:nvSpPr>
+          <p:cNvPr id="901" name="Fußzeilenplatzhalter 4">
+            <a:extLst>
+              <a:ext uri="{FF2B5EF4-FFF2-40B4-BE49-F238E27FC236}">
+                <a16:creationId xmlns:a16="http://schemas.microsoft.com/office/drawing/2014/main" id="{C7FF4EBF-1F95-422C-ABDC-BAC99BA2526A}"/>
+              </a:ext>
+            </a:extLst>
+          </p:cNvPr>
+          <p:cNvSpPr>
+            <a:spLocks noGrp="1"/>
+          </p:cNvSpPr>
+          <p:nvPr>
+            <p:ph type="ftr" sz="quarter" idx="11"/>
+          </p:nvPr>
+        </p:nvSpPr>
+        <p:spPr/>
+        <p:txBody>
+          <a:bodyPr/>
+          <a:lstStyle/>
+          <a:p>
+            <a:r>
+              <a:rPr lang="de-CH"/>
+              <a:t>Team Ctrl+Free</a:t>
+            </a:r>
+            <a:endParaRPr lang="de-CH" dirty="0"/>
+          </a:p>
+        </p:txBody>
+      </p:sp>
+      <p:sp>
+        <p:nvSpPr>
           <p:cNvPr id="902" name="Foliennummernplatzhalter 5">
             <a:extLst>
               <a:ext uri="{FF2B5EF4-FFF2-40B4-BE49-F238E27FC236}">
@@ -7777,6 +7864,35 @@
       </p:sp>
       <p:sp>
         <p:nvSpPr>
+          <p:cNvPr id="901" name="Fußzeilenplatzhalter 4">
+            <a:extLst>
+              <a:ext uri="{FF2B5EF4-FFF2-40B4-BE49-F238E27FC236}">
+                <a16:creationId xmlns:a16="http://schemas.microsoft.com/office/drawing/2014/main" id="{C7FF4EBF-1F95-422C-ABDC-BAC99BA2526A}"/>
+              </a:ext>
+            </a:extLst>
+          </p:cNvPr>
+          <p:cNvSpPr>
+            <a:spLocks noGrp="1"/>
+          </p:cNvSpPr>
+          <p:nvPr>
+            <p:ph type="ftr" sz="quarter" idx="11"/>
+          </p:nvPr>
+        </p:nvSpPr>
+        <p:spPr/>
+        <p:txBody>
+          <a:bodyPr/>
+          <a:lstStyle/>
+          <a:p>
+            <a:r>
+              <a:rPr lang="de-CH"/>
+              <a:t>Team Ctrl+Free</a:t>
+            </a:r>
+            <a:endParaRPr lang="de-CH" dirty="0"/>
+          </a:p>
+        </p:txBody>
+      </p:sp>
+      <p:sp>
+        <p:nvSpPr>
           <p:cNvPr id="902" name="Foliennummernplatzhalter 5">
             <a:extLst>
               <a:ext uri="{FF2B5EF4-FFF2-40B4-BE49-F238E27FC236}">
@@ -9432,6 +9548,35 @@
       </p:sp>
       <p:sp>
         <p:nvSpPr>
+          <p:cNvPr id="901" name="Fußzeilenplatzhalter 4">
+            <a:extLst>
+              <a:ext uri="{FF2B5EF4-FFF2-40B4-BE49-F238E27FC236}">
+                <a16:creationId xmlns:a16="http://schemas.microsoft.com/office/drawing/2014/main" id="{C7FF4EBF-1F95-422C-ABDC-BAC99BA2526A}"/>
+              </a:ext>
+            </a:extLst>
+          </p:cNvPr>
+          <p:cNvSpPr>
+            <a:spLocks noGrp="1"/>
+          </p:cNvSpPr>
+          <p:nvPr>
+            <p:ph type="ftr" sz="quarter" idx="11"/>
+          </p:nvPr>
+        </p:nvSpPr>
+        <p:spPr/>
+        <p:txBody>
+          <a:bodyPr/>
+          <a:lstStyle/>
+          <a:p>
+            <a:r>
+              <a:rPr lang="de-CH"/>
+              <a:t>Team Ctrl+Free</a:t>
+            </a:r>
+            <a:endParaRPr lang="de-CH" dirty="0"/>
+          </a:p>
+        </p:txBody>
+      </p:sp>
+      <p:sp>
+        <p:nvSpPr>
           <p:cNvPr id="902" name="Foliennummernplatzhalter 5">
             <a:extLst>
               <a:ext uri="{FF2B5EF4-FFF2-40B4-BE49-F238E27FC236}">
@@ -10074,6 +10219,35 @@
       </p:sp>
       <p:sp>
         <p:nvSpPr>
+          <p:cNvPr id="901" name="Fußzeilenplatzhalter 4">
+            <a:extLst>
+              <a:ext uri="{FF2B5EF4-FFF2-40B4-BE49-F238E27FC236}">
+                <a16:creationId xmlns:a16="http://schemas.microsoft.com/office/drawing/2014/main" id="{C7FF4EBF-1F95-422C-ABDC-BAC99BA2526A}"/>
+              </a:ext>
+            </a:extLst>
+          </p:cNvPr>
+          <p:cNvSpPr>
+            <a:spLocks noGrp="1"/>
+          </p:cNvSpPr>
+          <p:nvPr>
+            <p:ph type="ftr" sz="quarter" idx="11"/>
+          </p:nvPr>
+        </p:nvSpPr>
+        <p:spPr/>
+        <p:txBody>
+          <a:bodyPr/>
+          <a:lstStyle/>
+          <a:p>
+            <a:r>
+              <a:rPr lang="de-CH"/>
+              <a:t>Team Ctrl+Free</a:t>
+            </a:r>
+            <a:endParaRPr lang="de-CH" dirty="0"/>
+          </a:p>
+        </p:txBody>
+      </p:sp>
+      <p:sp>
+        <p:nvSpPr>
           <p:cNvPr id="902" name="Foliennummernplatzhalter 5">
             <a:extLst>
               <a:ext uri="{FF2B5EF4-FFF2-40B4-BE49-F238E27FC236}">
@@ -10823,6 +10997,35 @@
             <a:r>
               <a:t>Bern's research never sits idle</a:t>
             </a:r>
+          </a:p>
+        </p:txBody>
+      </p:sp>
+      <p:sp>
+        <p:nvSpPr>
+          <p:cNvPr id="901" name="Fußzeilenplatzhalter 4">
+            <a:extLst>
+              <a:ext uri="{FF2B5EF4-FFF2-40B4-BE49-F238E27FC236}">
+                <a16:creationId xmlns:a16="http://schemas.microsoft.com/office/drawing/2014/main" id="{C7FF4EBF-1F95-422C-ABDC-BAC99BA2526A}"/>
+              </a:ext>
+            </a:extLst>
+          </p:cNvPr>
+          <p:cNvSpPr>
+            <a:spLocks noGrp="1"/>
+          </p:cNvSpPr>
+          <p:nvPr>
+            <p:ph type="ftr" sz="quarter" idx="11"/>
+          </p:nvPr>
+        </p:nvSpPr>
+        <p:spPr/>
+        <p:txBody>
+          <a:bodyPr/>
+          <a:lstStyle/>
+          <a:p>
+            <a:r>
+              <a:rPr lang="de-CH"/>
+              <a:t>Team Ctrl+Free</a:t>
+            </a:r>
+            <a:endParaRPr lang="de-CH" dirty="0"/>
           </a:p>
         </p:txBody>
       </p:sp>
@@ -12407,6 +12610,35 @@
       </p:sp>
       <p:sp>
         <p:nvSpPr>
+          <p:cNvPr id="901" name="Fußzeilenplatzhalter 4">
+            <a:extLst>
+              <a:ext uri="{FF2B5EF4-FFF2-40B4-BE49-F238E27FC236}">
+                <a16:creationId xmlns:a16="http://schemas.microsoft.com/office/drawing/2014/main" id="{C7FF4EBF-1F95-422C-ABDC-BAC99BA2526A}"/>
+              </a:ext>
+            </a:extLst>
+          </p:cNvPr>
+          <p:cNvSpPr>
+            <a:spLocks noGrp="1"/>
+          </p:cNvSpPr>
+          <p:nvPr>
+            <p:ph type="ftr" sz="quarter" idx="11"/>
+          </p:nvPr>
+        </p:nvSpPr>
+        <p:spPr/>
+        <p:txBody>
+          <a:bodyPr/>
+          <a:lstStyle/>
+          <a:p>
+            <a:r>
+              <a:rPr lang="de-CH"/>
+              <a:t>Team Ctrl+Free</a:t>
+            </a:r>
+            <a:endParaRPr lang="de-CH" dirty="0"/>
+          </a:p>
+        </p:txBody>
+      </p:sp>
+      <p:sp>
+        <p:nvSpPr>
           <p:cNvPr id="902" name="Foliennummernplatzhalter 5">
             <a:extLst>
               <a:ext uri="{FF2B5EF4-FFF2-40B4-BE49-F238E27FC236}">
@@ -13674,6 +13906,35 @@
       </p:sp>
       <p:sp>
         <p:nvSpPr>
+          <p:cNvPr id="901" name="Fußzeilenplatzhalter 4">
+            <a:extLst>
+              <a:ext uri="{FF2B5EF4-FFF2-40B4-BE49-F238E27FC236}">
+                <a16:creationId xmlns:a16="http://schemas.microsoft.com/office/drawing/2014/main" id="{C7FF4EBF-1F95-422C-ABDC-BAC99BA2526A}"/>
+              </a:ext>
+            </a:extLst>
+          </p:cNvPr>
+          <p:cNvSpPr>
+            <a:spLocks noGrp="1"/>
+          </p:cNvSpPr>
+          <p:nvPr>
+            <p:ph type="ftr" sz="quarter" idx="11"/>
+          </p:nvPr>
+        </p:nvSpPr>
+        <p:spPr/>
+        <p:txBody>
+          <a:bodyPr/>
+          <a:lstStyle/>
+          <a:p>
+            <a:r>
+              <a:rPr lang="de-CH"/>
+              <a:t>Team Ctrl+Free</a:t>
+            </a:r>
+            <a:endParaRPr lang="de-CH" dirty="0"/>
+          </a:p>
+        </p:txBody>
+      </p:sp>
+      <p:sp>
+        <p:nvSpPr>
           <p:cNvPr id="902" name="Foliennummernplatzhalter 5">
             <a:extLst>
               <a:ext uri="{FF2B5EF4-FFF2-40B4-BE49-F238E27FC236}">
@@ -14198,6 +14459,35 @@
       </p:sp>
       <p:sp>
         <p:nvSpPr>
+          <p:cNvPr id="901" name="Fußzeilenplatzhalter 4">
+            <a:extLst>
+              <a:ext uri="{FF2B5EF4-FFF2-40B4-BE49-F238E27FC236}">
+                <a16:creationId xmlns:a16="http://schemas.microsoft.com/office/drawing/2014/main" id="{C7FF4EBF-1F95-422C-ABDC-BAC99BA2526A}"/>
+              </a:ext>
+            </a:extLst>
+          </p:cNvPr>
+          <p:cNvSpPr>
+            <a:spLocks noGrp="1"/>
+          </p:cNvSpPr>
+          <p:nvPr>
+            <p:ph type="ftr" sz="quarter" idx="11"/>
+          </p:nvPr>
+        </p:nvSpPr>
+        <p:spPr/>
+        <p:txBody>
+          <a:bodyPr/>
+          <a:lstStyle/>
+          <a:p>
+            <a:r>
+              <a:rPr lang="de-CH"/>
+              <a:t>Team Ctrl+Free</a:t>
+            </a:r>
+            <a:endParaRPr lang="de-CH" dirty="0"/>
+          </a:p>
+        </p:txBody>
+      </p:sp>
+      <p:sp>
+        <p:nvSpPr>
           <p:cNvPr id="902" name="Foliennummernplatzhalter 5">
             <a:extLst>
               <a:ext uri="{FF2B5EF4-FFF2-40B4-BE49-F238E27FC236}">
@@ -14897,6 +15187,35 @@
       </p:sp>
       <p:sp>
         <p:nvSpPr>
+          <p:cNvPr id="901" name="Fußzeilenplatzhalter 4">
+            <a:extLst>
+              <a:ext uri="{FF2B5EF4-FFF2-40B4-BE49-F238E27FC236}">
+                <a16:creationId xmlns:a16="http://schemas.microsoft.com/office/drawing/2014/main" id="{C7FF4EBF-1F95-422C-ABDC-BAC99BA2526A}"/>
+              </a:ext>
+            </a:extLst>
+          </p:cNvPr>
+          <p:cNvSpPr>
+            <a:spLocks noGrp="1"/>
+          </p:cNvSpPr>
+          <p:nvPr>
+            <p:ph type="ftr" sz="quarter" idx="11"/>
+          </p:nvPr>
+        </p:nvSpPr>
+        <p:spPr/>
+        <p:txBody>
+          <a:bodyPr/>
+          <a:lstStyle/>
+          <a:p>
+            <a:r>
+              <a:rPr lang="de-CH"/>
+              <a:t>Team Ctrl+Free</a:t>
+            </a:r>
+            <a:endParaRPr lang="de-CH" dirty="0"/>
+          </a:p>
+        </p:txBody>
+      </p:sp>
+      <p:sp>
+        <p:nvSpPr>
           <p:cNvPr id="902" name="Foliennummernplatzhalter 5">
             <a:extLst>
               <a:ext uri="{FF2B5EF4-FFF2-40B4-BE49-F238E27FC236}">
@@ -16218,6 +16537,35 @@
         <p:nvPr/>
       </p:nvGrpSpPr>
       <p:grpSpPr/>
+      <p:sp>
+        <p:nvSpPr>
+          <p:cNvPr id="901" name="Fußzeilenplatzhalter 4">
+            <a:extLst>
+              <a:ext uri="{FF2B5EF4-FFF2-40B4-BE49-F238E27FC236}">
+                <a16:creationId xmlns:a16="http://schemas.microsoft.com/office/drawing/2014/main" id="{C7FF4EBF-1F95-422C-ABDC-BAC99BA2526A}"/>
+              </a:ext>
+            </a:extLst>
+          </p:cNvPr>
+          <p:cNvSpPr>
+            <a:spLocks noGrp="1"/>
+          </p:cNvSpPr>
+          <p:nvPr>
+            <p:ph type="ftr" sz="quarter" idx="11"/>
+          </p:nvPr>
+        </p:nvSpPr>
+        <p:spPr/>
+        <p:txBody>
+          <a:bodyPr/>
+          <a:lstStyle/>
+          <a:p>
+            <a:r>
+              <a:rPr lang="de-CH"/>
+              <a:t>Team Ctrl+Free</a:t>
+            </a:r>
+            <a:endParaRPr lang="de-CH" dirty="0"/>
+          </a:p>
+        </p:txBody>
+      </p:sp>
       <p:sp>
         <p:nvSpPr>
           <p:cNvPr id="902" name="Foliennummernplatzhalter 5">
@@ -16593,6 +16941,35 @@
       </p:sp>
       <p:sp>
         <p:nvSpPr>
+          <p:cNvPr id="901" name="Fußzeilenplatzhalter 4">
+            <a:extLst>
+              <a:ext uri="{FF2B5EF4-FFF2-40B4-BE49-F238E27FC236}">
+                <a16:creationId xmlns:a16="http://schemas.microsoft.com/office/drawing/2014/main" id="{C7FF4EBF-1F95-422C-ABDC-BAC99BA2526A}"/>
+              </a:ext>
+            </a:extLst>
+          </p:cNvPr>
+          <p:cNvSpPr>
+            <a:spLocks noGrp="1"/>
+          </p:cNvSpPr>
+          <p:nvPr>
+            <p:ph type="ftr" sz="quarter" idx="11"/>
+          </p:nvPr>
+        </p:nvSpPr>
+        <p:spPr/>
+        <p:txBody>
+          <a:bodyPr/>
+          <a:lstStyle/>
+          <a:p>
+            <a:r>
+              <a:rPr lang="de-CH"/>
+              <a:t>Team Ctrl+Free</a:t>
+            </a:r>
+            <a:endParaRPr lang="de-CH" dirty="0"/>
+          </a:p>
+        </p:txBody>
+      </p:sp>
+      <p:sp>
+        <p:nvSpPr>
           <p:cNvPr id="902" name="Foliennummernplatzhalter 5">
             <a:extLst>
               <a:ext uri="{FF2B5EF4-FFF2-40B4-BE49-F238E27FC236}">
@@ -17337,10 +17714,10 @@
       <p:grpSpPr/>
       <p:sp>
         <p:nvSpPr>
-          <p:cNvPr id="902" name="Foliennummernplatzhalter 5">
+          <p:cNvPr id="901" name="Fußzeilenplatzhalter 4">
             <a:extLst>
               <a:ext uri="{FF2B5EF4-FFF2-40B4-BE49-F238E27FC236}">
-                <a16:creationId xmlns:a16="http://schemas.microsoft.com/office/drawing/2014/main" id="{56A97AFD-16FE-4EA5-A888-4A84A29DE559}"/>
+                <a16:creationId xmlns:a16="http://schemas.microsoft.com/office/drawing/2014/main" id="{C7FF4EBF-1F95-422C-ABDC-BAC99BA2526A}"/>
               </a:ext>
             </a:extLst>
           </p:cNvPr>
@@ -17348,7 +17725,7 @@
             <a:spLocks noGrp="1"/>
           </p:cNvSpPr>
           <p:nvPr>
-            <p:ph type="sldNum" sz="quarter" idx="12"/>
+            <p:ph type="ftr" sz="quarter" idx="11"/>
           </p:nvPr>
         </p:nvSpPr>
         <p:spPr/>
@@ -17356,11 +17733,10 @@
           <a:bodyPr/>
           <a:lstStyle/>
           <a:p>
-            <a:fld id="{442AD375-037F-43D0-B059-5172DA06796A}" type="slidenum">
-              <a:rPr lang="de-CH" smtClean="0"/>
-              <a:pPr/>
-              <a:t>3</a:t>
-            </a:fld>
+            <a:r>
+              <a:rPr lang="de-CH"/>
+              <a:t>Team Ctrl+Free</a:t>
+            </a:r>
             <a:endParaRPr lang="de-CH" dirty="0"/>
           </a:p>
         </p:txBody>
@@ -17475,44 +17851,6 @@
                 </a:solidFill>
               </a:rPr>
               <a:t>the right research partner for every company.</a:t>
-            </a:r>
-          </a:p>
-        </p:txBody>
-      </p:sp>
-      <p:sp>
-        <p:nvSpPr>
-          <p:cNvPr id="906" name="TextBox 905"/>
-          <p:cNvSpPr txBox="1"/>
-          <p:nvPr/>
-        </p:nvSpPr>
-        <p:spPr>
-          <a:xfrm>
-            <a:off x="841248" y="5838354"/>
-            <a:ext cx="5212080" cy="274320"/>
-          </a:xfrm>
-          <a:prstGeom prst="rect">
-            <a:avLst/>
-          </a:prstGeom>
-          <a:noFill/>
-        </p:spPr>
-        <p:txBody>
-          <a:bodyPr wrap="square" lIns="0" rIns="0" tIns="0" bIns="0" anchor="t">
-            <a:spAutoFit/>
-          </a:bodyPr>
-          <a:lstStyle/>
-          <a:p>
-            <a:pPr algn="l">
-              <a:spcAft>
-                <a:spcPts val="0"/>
-              </a:spcAft>
-            </a:pPr>
-            <a:r>
-              <a:rPr sz="1800" b="0" i="0">
-                <a:solidFill>
-                  <a:srgbClr val="63737B"/>
-                </a:solidFill>
-              </a:rPr>
-              <a:t>Team Ctrl+Free</a:t>
             </a:r>
           </a:p>
         </p:txBody>
@@ -17612,6 +17950,36 @@
           </a:prstGeom>
         </p:spPr>
       </p:pic>
+      <p:sp>
+        <p:nvSpPr>
+          <p:cNvPr id="902" name="Foliennummernplatzhalter 5">
+            <a:extLst>
+              <a:ext uri="{FF2B5EF4-FFF2-40B4-BE49-F238E27FC236}">
+                <a16:creationId xmlns:a16="http://schemas.microsoft.com/office/drawing/2014/main" id="{56A97AFD-16FE-4EA5-A888-4A84A29DE559}"/>
+              </a:ext>
+            </a:extLst>
+          </p:cNvPr>
+          <p:cNvSpPr>
+            <a:spLocks noGrp="1"/>
+          </p:cNvSpPr>
+          <p:nvPr>
+            <p:ph type="sldNum" sz="quarter" idx="12"/>
+          </p:nvPr>
+        </p:nvSpPr>
+        <p:spPr/>
+        <p:txBody>
+          <a:bodyPr/>
+          <a:lstStyle/>
+          <a:p>
+            <a:fld id="{442AD375-037F-43D0-B059-5172DA06796A}" type="slidenum">
+              <a:rPr lang="de-CH" smtClean="0"/>
+              <a:pPr/>
+              <a:t>3</a:t>
+            </a:fld>
+            <a:endParaRPr lang="de-CH" dirty="0"/>
+          </a:p>
+        </p:txBody>
+      </p:sp>
     </p:spTree>
   </p:cSld>
   <p:clrMapOvr>
@@ -17896,6 +18264,35 @@
       <p:grpSpPr/>
       <p:sp>
         <p:nvSpPr>
+          <p:cNvPr id="901" name="Fußzeilenplatzhalter 4">
+            <a:extLst>
+              <a:ext uri="{FF2B5EF4-FFF2-40B4-BE49-F238E27FC236}">
+                <a16:creationId xmlns:a16="http://schemas.microsoft.com/office/drawing/2014/main" id="{C7FF4EBF-1F95-422C-ABDC-BAC99BA2526A}"/>
+              </a:ext>
+            </a:extLst>
+          </p:cNvPr>
+          <p:cNvSpPr>
+            <a:spLocks noGrp="1"/>
+          </p:cNvSpPr>
+          <p:nvPr>
+            <p:ph type="ftr" sz="quarter" idx="11"/>
+          </p:nvPr>
+        </p:nvSpPr>
+        <p:spPr/>
+        <p:txBody>
+          <a:bodyPr/>
+          <a:lstStyle/>
+          <a:p>
+            <a:r>
+              <a:rPr lang="de-CH"/>
+              <a:t>Team Ctrl+Free</a:t>
+            </a:r>
+            <a:endParaRPr lang="de-CH" dirty="0"/>
+          </a:p>
+        </p:txBody>
+      </p:sp>
+      <p:sp>
+        <p:nvSpPr>
           <p:cNvPr id="902" name="Foliennummernplatzhalter 5">
             <a:extLst>
               <a:ext uri="{FF2B5EF4-FFF2-40B4-BE49-F238E27FC236}">
@@ -18227,6 +18624,35 @@
       </p:sp>
       <p:sp>
         <p:nvSpPr>
+          <p:cNvPr id="901" name="Fußzeilenplatzhalter 4">
+            <a:extLst>
+              <a:ext uri="{FF2B5EF4-FFF2-40B4-BE49-F238E27FC236}">
+                <a16:creationId xmlns:a16="http://schemas.microsoft.com/office/drawing/2014/main" id="{C7FF4EBF-1F95-422C-ABDC-BAC99BA2526A}"/>
+              </a:ext>
+            </a:extLst>
+          </p:cNvPr>
+          <p:cNvSpPr>
+            <a:spLocks noGrp="1"/>
+          </p:cNvSpPr>
+          <p:nvPr>
+            <p:ph type="ftr" sz="quarter" idx="11"/>
+          </p:nvPr>
+        </p:nvSpPr>
+        <p:spPr/>
+        <p:txBody>
+          <a:bodyPr/>
+          <a:lstStyle/>
+          <a:p>
+            <a:r>
+              <a:rPr lang="de-CH"/>
+              <a:t>Team Ctrl+Free</a:t>
+            </a:r>
+            <a:endParaRPr lang="de-CH" dirty="0"/>
+          </a:p>
+        </p:txBody>
+      </p:sp>
+      <p:sp>
+        <p:nvSpPr>
           <p:cNvPr id="902" name="Foliennummernplatzhalter 5">
             <a:extLst>
               <a:ext uri="{FF2B5EF4-FFF2-40B4-BE49-F238E27FC236}">
@@ -18407,6 +18833,35 @@
             <a:r>
               <a:t>Honest and trustworthy by design</a:t>
             </a:r>
+          </a:p>
+        </p:txBody>
+      </p:sp>
+      <p:sp>
+        <p:nvSpPr>
+          <p:cNvPr id="901" name="Fußzeilenplatzhalter 4">
+            <a:extLst>
+              <a:ext uri="{FF2B5EF4-FFF2-40B4-BE49-F238E27FC236}">
+                <a16:creationId xmlns:a16="http://schemas.microsoft.com/office/drawing/2014/main" id="{C7FF4EBF-1F95-422C-ABDC-BAC99BA2526A}"/>
+              </a:ext>
+            </a:extLst>
+          </p:cNvPr>
+          <p:cNvSpPr>
+            <a:spLocks noGrp="1"/>
+          </p:cNvSpPr>
+          <p:nvPr>
+            <p:ph type="ftr" sz="quarter" idx="11"/>
+          </p:nvPr>
+        </p:nvSpPr>
+        <p:spPr/>
+        <p:txBody>
+          <a:bodyPr/>
+          <a:lstStyle/>
+          <a:p>
+            <a:r>
+              <a:rPr lang="de-CH"/>
+              <a:t>Team Ctrl+Free</a:t>
+            </a:r>
+            <a:endParaRPr lang="de-CH" dirty="0"/>
           </a:p>
         </p:txBody>
       </p:sp>
@@ -18955,6 +19410,35 @@
       </p:sp>
       <p:sp>
         <p:nvSpPr>
+          <p:cNvPr id="901" name="Fußzeilenplatzhalter 4">
+            <a:extLst>
+              <a:ext uri="{FF2B5EF4-FFF2-40B4-BE49-F238E27FC236}">
+                <a16:creationId xmlns:a16="http://schemas.microsoft.com/office/drawing/2014/main" id="{C7FF4EBF-1F95-422C-ABDC-BAC99BA2526A}"/>
+              </a:ext>
+            </a:extLst>
+          </p:cNvPr>
+          <p:cNvSpPr>
+            <a:spLocks noGrp="1"/>
+          </p:cNvSpPr>
+          <p:nvPr>
+            <p:ph type="ftr" sz="quarter" idx="11"/>
+          </p:nvPr>
+        </p:nvSpPr>
+        <p:spPr/>
+        <p:txBody>
+          <a:bodyPr/>
+          <a:lstStyle/>
+          <a:p>
+            <a:r>
+              <a:rPr lang="de-CH"/>
+              <a:t>Team Ctrl+Free</a:t>
+            </a:r>
+            <a:endParaRPr lang="de-CH" dirty="0"/>
+          </a:p>
+        </p:txBody>
+      </p:sp>
+      <p:sp>
+        <p:nvSpPr>
           <p:cNvPr id="902" name="Foliennummernplatzhalter 5">
             <a:extLst>
               <a:ext uri="{FF2B5EF4-FFF2-40B4-BE49-F238E27FC236}">
@@ -19433,6 +19917,35 @@
             <a:r>
               <a:t>Results</a:t>
             </a:r>
+          </a:p>
+        </p:txBody>
+      </p:sp>
+      <p:sp>
+        <p:nvSpPr>
+          <p:cNvPr id="901" name="Fußzeilenplatzhalter 4">
+            <a:extLst>
+              <a:ext uri="{FF2B5EF4-FFF2-40B4-BE49-F238E27FC236}">
+                <a16:creationId xmlns:a16="http://schemas.microsoft.com/office/drawing/2014/main" id="{C7FF4EBF-1F95-422C-ABDC-BAC99BA2526A}"/>
+              </a:ext>
+            </a:extLst>
+          </p:cNvPr>
+          <p:cNvSpPr>
+            <a:spLocks noGrp="1"/>
+          </p:cNvSpPr>
+          <p:nvPr>
+            <p:ph type="ftr" sz="quarter" idx="11"/>
+          </p:nvPr>
+        </p:nvSpPr>
+        <p:spPr/>
+        <p:txBody>
+          <a:bodyPr/>
+          <a:lstStyle/>
+          <a:p>
+            <a:r>
+              <a:rPr lang="de-CH"/>
+              <a:t>Team Ctrl+Free</a:t>
+            </a:r>
+            <a:endParaRPr lang="de-CH" dirty="0"/>
           </a:p>
         </p:txBody>
       </p:sp>
@@ -20117,6 +20630,121 @@
       </p:sp>
       <p:sp>
         <p:nvSpPr>
+          <p:cNvPr id="901" name="Fußzeilenplatzhalter 4">
+            <a:extLst>
+              <a:ext uri="{FF2B5EF4-FFF2-40B4-BE49-F238E27FC236}">
+                <a16:creationId xmlns:a16="http://schemas.microsoft.com/office/drawing/2014/main" id="{C7FF4EBF-1F95-422C-ABDC-BAC99BA2526A}"/>
+              </a:ext>
+            </a:extLst>
+          </p:cNvPr>
+          <p:cNvSpPr>
+            <a:spLocks noGrp="1"/>
+          </p:cNvSpPr>
+          <p:nvPr>
+            <p:ph type="ftr" sz="quarter" idx="11"/>
+          </p:nvPr>
+        </p:nvSpPr>
+        <p:spPr/>
+        <p:txBody>
+          <a:bodyPr/>
+          <a:lstStyle/>
+          <a:p>
+            <a:r>
+              <a:rPr lang="de-CH"/>
+              <a:t>Team Ctrl+Free</a:t>
+            </a:r>
+            <a:endParaRPr lang="de-CH" dirty="0"/>
+          </a:p>
+        </p:txBody>
+      </p:sp>
+      <p:pic>
+        <p:nvPicPr>
+          <p:cNvPr id="903" name="Mutz lockup" descr="splash-last.png"/>
+          <p:cNvPicPr>
+            <a:picLocks noChangeAspect="1"/>
+          </p:cNvPicPr>
+          <p:nvPr/>
+        </p:nvPicPr>
+        <p:blipFill>
+          <a:blip r:embed="rId2"/>
+          <a:stretch>
+            <a:fillRect/>
+          </a:stretch>
+        </p:blipFill>
+        <p:spPr>
+          <a:xfrm>
+            <a:off x="7269480" y="960120"/>
+            <a:ext cx="4480560" cy="4480560"/>
+          </a:xfrm>
+          <a:prstGeom prst="rect">
+            <a:avLst/>
+          </a:prstGeom>
+        </p:spPr>
+      </p:pic>
+      <p:sp>
+        <p:nvSpPr>
+          <p:cNvPr id="905" name="Challenge owner label"/>
+          <p:cNvSpPr txBox="1"/>
+          <p:nvPr/>
+        </p:nvSpPr>
+        <p:spPr>
+          <a:xfrm>
+            <a:off x="7776188" y="5930302"/>
+            <a:ext cx="1371600" cy="152400"/>
+          </a:xfrm>
+          <a:prstGeom prst="rect">
+            <a:avLst/>
+          </a:prstGeom>
+          <a:noFill/>
+        </p:spPr>
+        <p:txBody>
+          <a:bodyPr wrap="square" lIns="0" rIns="0" tIns="0" bIns="0" anchor="t">
+            <a:spAutoFit/>
+          </a:bodyPr>
+          <a:lstStyle/>
+          <a:p>
+            <a:pPr algn="r">
+              <a:spcAft>
+                <a:spcPts val="0"/>
+              </a:spcAft>
+            </a:pPr>
+            <a:r>
+              <a:rPr lang="en-GB" sz="1000" b="0" i="0">
+                <a:solidFill>
+                  <a:srgbClr val="63737B"/>
+                </a:solidFill>
+              </a:rPr>
+              <a:t>Challenge owner</a:t>
+            </a:r>
+          </a:p>
+        </p:txBody>
+      </p:sp>
+      <p:pic>
+        <p:nvPicPr>
+          <p:cNvPr id="906" name="Bern Economic Development Agency logo" descr="Bern Economic Development Agency"/>
+          <p:cNvPicPr>
+            <a:picLocks noChangeAspect="1"/>
+          </p:cNvPicPr>
+          <p:nvPr/>
+        </p:nvPicPr>
+        <p:blipFill>
+          <a:blip r:embed="rId3"/>
+          <a:stretch>
+            <a:fillRect/>
+          </a:stretch>
+        </p:blipFill>
+        <p:spPr>
+          <a:xfrm>
+            <a:off x="9257516" y="5577840"/>
+            <a:ext cx="1566717" cy="502920"/>
+          </a:xfrm>
+          <a:prstGeom prst="rect">
+            <a:avLst/>
+          </a:prstGeom>
+        </p:spPr>
+      </p:pic>
+      <p:sp>
+        <p:nvSpPr>
           <p:cNvPr id="902" name="Foliennummernplatzhalter 5">
             <a:extLst>
               <a:ext uri="{FF2B5EF4-FFF2-40B4-BE49-F238E27FC236}">
@@ -20145,130 +20773,6 @@
           </a:p>
         </p:txBody>
       </p:sp>
-      <p:pic>
-        <p:nvPicPr>
-          <p:cNvPr id="903" name="Mutz lockup" descr="splash-last.png"/>
-          <p:cNvPicPr>
-            <a:picLocks noChangeAspect="1"/>
-          </p:cNvPicPr>
-          <p:nvPr/>
-        </p:nvPicPr>
-        <p:blipFill>
-          <a:blip r:embed="rId2"/>
-          <a:stretch>
-            <a:fillRect/>
-          </a:stretch>
-        </p:blipFill>
-        <p:spPr>
-          <a:xfrm>
-            <a:off x="7269480" y="960120"/>
-            <a:ext cx="4480560" cy="4480560"/>
-          </a:xfrm>
-          <a:prstGeom prst="rect">
-            <a:avLst/>
-          </a:prstGeom>
-        </p:spPr>
-      </p:pic>
-      <p:sp>
-        <p:nvSpPr>
-          <p:cNvPr id="904" name="TextBox 903"/>
-          <p:cNvSpPr txBox="1"/>
-          <p:nvPr/>
-        </p:nvSpPr>
-        <p:spPr>
-          <a:xfrm>
-            <a:off x="841248" y="5838354"/>
-            <a:ext cx="5212080" cy="274320"/>
-          </a:xfrm>
-          <a:prstGeom prst="rect">
-            <a:avLst/>
-          </a:prstGeom>
-          <a:noFill/>
-        </p:spPr>
-        <p:txBody>
-          <a:bodyPr wrap="square" lIns="0" rIns="0" tIns="0" bIns="0" anchor="t">
-            <a:spAutoFit/>
-          </a:bodyPr>
-          <a:lstStyle/>
-          <a:p>
-            <a:pPr algn="l">
-              <a:spcAft>
-                <a:spcPts val="600"/>
-              </a:spcAft>
-            </a:pPr>
-            <a:r>
-              <a:rPr sz="1800" b="0" i="0">
-                <a:solidFill>
-                  <a:srgbClr val="63737B"/>
-                </a:solidFill>
-              </a:rPr>
-              <a:t>Team Ctrl+Free</a:t>
-            </a:r>
-          </a:p>
-        </p:txBody>
-      </p:sp>
-      <p:sp>
-        <p:nvSpPr>
-          <p:cNvPr id="905" name="Challenge owner label"/>
-          <p:cNvSpPr txBox="1"/>
-          <p:nvPr/>
-        </p:nvSpPr>
-        <p:spPr>
-          <a:xfrm>
-            <a:off x="7776188" y="5930302"/>
-            <a:ext cx="1371600" cy="152400"/>
-          </a:xfrm>
-          <a:prstGeom prst="rect">
-            <a:avLst/>
-          </a:prstGeom>
-          <a:noFill/>
-        </p:spPr>
-        <p:txBody>
-          <a:bodyPr wrap="square" lIns="0" rIns="0" tIns="0" bIns="0" anchor="t">
-            <a:spAutoFit/>
-          </a:bodyPr>
-          <a:lstStyle/>
-          <a:p>
-            <a:pPr algn="r">
-              <a:spcAft>
-                <a:spcPts val="0"/>
-              </a:spcAft>
-            </a:pPr>
-            <a:r>
-              <a:rPr lang="en-GB" sz="1000" b="0" i="0">
-                <a:solidFill>
-                  <a:srgbClr val="63737B"/>
-                </a:solidFill>
-              </a:rPr>
-              <a:t>Challenge owner</a:t>
-            </a:r>
-          </a:p>
-        </p:txBody>
-      </p:sp>
-      <p:pic>
-        <p:nvPicPr>
-          <p:cNvPr id="906" name="Bern Economic Development Agency logo" descr="Bern Economic Development Agency"/>
-          <p:cNvPicPr>
-            <a:picLocks noChangeAspect="1"/>
-          </p:cNvPicPr>
-          <p:nvPr/>
-        </p:nvPicPr>
-        <p:blipFill>
-          <a:blip r:embed="rId3"/>
-          <a:stretch>
-            <a:fillRect/>
-          </a:stretch>
-        </p:blipFill>
-        <p:spPr>
-          <a:xfrm>
-            <a:off x="9257516" y="5577840"/>
-            <a:ext cx="1566717" cy="502920"/>
-          </a:xfrm>
-          <a:prstGeom prst="rect">
-            <a:avLst/>
-          </a:prstGeom>
-        </p:spPr>
-      </p:pic>
     </p:spTree>
   </p:cSld>
   <p:clrMapOvr>

</xml_diff>

<commit_message>
Pitch decks: Team Ctrl+Free footer flush top right, 11 pt
Right-align the footer on the slide master to the same right edge as the
slide number, anchor it to the top margin, and raise it from 8.2 to 11 pt.

Co-Authored-By: Claude Opus 5.5 <noreply@anthropic.com>
</commit_message>
<xml_diff>
--- a/research/Mutz_Pitch_lean_animated.pptx
+++ b/research/Mutz_Pitch_lean_animated.pptx
@@ -6395,18 +6395,18 @@
         </p:nvSpPr>
         <p:spPr>
           <a:xfrm>
-            <a:off x="9336360" y="297071"/>
-            <a:ext cx="2088232" cy="124409"/>
-          </a:xfrm>
-          <a:prstGeom prst="rect">
-            <a:avLst/>
-          </a:prstGeom>
-        </p:spPr>
-        <p:txBody>
-          <a:bodyPr vert="horz" lIns="0" tIns="0" rIns="0" bIns="0" rtlCol="0" anchor="b" anchorCtr="0"/>
+            <a:off x="9075025" y="297072"/>
+            <a:ext cx="2743200" cy="167640"/>
+          </a:xfrm>
+          <a:prstGeom prst="rect">
+            <a:avLst/>
+          </a:prstGeom>
+        </p:spPr>
+        <p:txBody>
+          <a:bodyPr vert="horz" lIns="0" tIns="0" rIns="0" bIns="0" rtlCol="0" anchor="t" anchorCtr="0"/>
           <a:lstStyle>
-            <a:lvl1pPr algn="l">
-              <a:defRPr sz="820" baseline="0">
+            <a:lvl1pPr algn="r">
+              <a:defRPr sz="1100" baseline="0">
                 <a:solidFill>
                   <a:schemeClr val="tx1"/>
                 </a:solidFill>

</xml_diff>

<commit_message>
Rename Kei Hung to Kei Honig in the app and pitch decks
The no-match message on the matches and states pages, Mutz's chat reply,
the demo path test, the slide 6 label and the slide 7 speaker notes now
say "Kei Honig im Topf".

Co-Authored-By: Claude Opus 5.5 <noreply@anthropic.com>
</commit_message>
<xml_diff>
--- a/research/Mutz_Pitch_lean_animated.pptx
+++ b/research/Mutz_Pitch_lean_animated.pptx
@@ -2219,7 +2219,7 @@
           </a:p>
           <a:p>
             <a:r>
-              <a:t>5. Weak field (battery recycling): "And when Bern has nothing? Kei Hung im Topf. No honey in the pot. Mutz says so, and shows everything it searched."</a:t>
+              <a:t>5. Weak field (battery recycling): "And when Bern has nothing? Kei Honig im Topf. No honey in the pot. Mutz says so, and shows everything it searched."</a:t>
             </a:r>
           </a:p>
           <a:p>
@@ -19037,7 +19037,7 @@
                   <a:srgbClr val="EA161F"/>
                 </a:solidFill>
               </a:rPr>
-              <a:t>Kei Hung</a:t>
+              <a:t>Kei Honig</a:t>
             </a:r>
           </a:p>
         </p:txBody>

</xml_diff>

<commit_message>
Pitch decks: add Hugging Face logo next to Apertus on slide 6
Slide 6 now reads "with Apertus and Hugging Face", with the official
Hugging Face logo lined up with the Apertus logo.

Co-Authored-By: Claude Opus 5.5 <noreply@anthropic.com>
</commit_message>
<xml_diff>
--- a/research/Mutz_Pitch_lean_animated.pptx
+++ b/research/Mutz_Pitch_lean_animated.pptx
@@ -19134,6 +19134,66 @@
           <a:xfrm>
             <a:off x="1578864" y="1850280"/>
             <a:ext cx="2591837" cy="254000"/>
+          </a:xfrm>
+          <a:prstGeom prst="rect">
+            <a:avLst/>
+          </a:prstGeom>
+        </p:spPr>
+      </p:pic>
+      <p:sp>
+        <p:nvSpPr>
+          <p:cNvPr id="910" name="And Hugging Face text"/>
+          <p:cNvSpPr txBox="1"/>
+          <p:nvPr/>
+        </p:nvSpPr>
+        <p:spPr>
+          <a:xfrm>
+            <a:off x="4278700" y="1783080"/>
+            <a:ext cx="640080" cy="429768"/>
+          </a:xfrm>
+          <a:prstGeom prst="rect">
+            <a:avLst/>
+          </a:prstGeom>
+          <a:noFill/>
+        </p:spPr>
+        <p:txBody>
+          <a:bodyPr wrap="none" lIns="0" rIns="0" tIns="0" bIns="0" anchor="t"/>
+          <a:lstStyle/>
+          <a:p>
+            <a:pPr algn="l">
+              <a:spcAft>
+                <a:spcPts val="0"/>
+              </a:spcAft>
+            </a:pPr>
+            <a:r>
+              <a:rPr lang="en-GB" sz="2800" b="0" i="0">
+                <a:solidFill>
+                  <a:srgbClr val="000000"/>
+                </a:solidFill>
+              </a:rPr>
+              <a:t>and</a:t>
+            </a:r>
+          </a:p>
+        </p:txBody>
+      </p:sp>
+      <p:pic>
+        <p:nvPicPr>
+          <p:cNvPr id="911" name="Hugging Face logo" descr="Hugging Face"/>
+          <p:cNvPicPr>
+            <a:picLocks noChangeAspect="1"/>
+          </p:cNvPicPr>
+          <p:nvPr/>
+        </p:nvPicPr>
+        <p:blipFill>
+          <a:blip r:embed="rId91"/>
+          <a:stretch>
+            <a:fillRect/>
+          </a:stretch>
+        </p:blipFill>
+        <p:spPr>
+          <a:xfrm>
+            <a:off x="4980000" y="1708446"/>
+            <a:ext cx="2420717" cy="548640"/>
           </a:xfrm>
           <a:prstGeom prst="rect">
             <a:avLst/>

</xml_diff>

<commit_message>
Locales, pitch rewrite, after-send view and clean PDF export
Adds German/Italian/French locales for the app and pitch, a pitch
rewrite step, a sent-state view, loading states for pitch drafts and a
clean PDF export, plus matching demo capture and deck updates.

Co-Authored-By: Claude Opus 5.5 <noreply@anthropic.com>
</commit_message>
<xml_diff>
--- a/research/Mutz_Pitch_lean_animated.pptx
+++ b/research/Mutz_Pitch_lean_animated.pptx
@@ -31,6 +31,8 @@
     <p:sldId id="298" r:id="rId43"/>
     <p:sldId id="299" r:id="rId44"/>
     <p:sldId id="300" r:id="rId45"/>
+    <p:sldId id="302" r:id="rId20"/>
+    <p:sldId id="303" r:id="rId19"/>
   </p:sldIdLst>
   <p:sldSz cx="12192000" cy="6858000"/>
   <p:notesSz cx="6858000" cy="9144000"/>
@@ -696,6 +698,113 @@
 </p:notesMaster>
 </file>
 
+<file path=ppt/notesSlides/notesSlide1.xml><?xml version="1.0" encoding="utf-8"?>
+<p:notes xmlns:a="http://schemas.openxmlformats.org/drawingml/2006/main" xmlns:p="http://schemas.openxmlformats.org/presentationml/2006/main" xmlns:r="http://schemas.openxmlformats.org/officeDocument/2006/relationships">
+  <p:cSld>
+    <p:spTree>
+      <p:nvGrpSpPr>
+        <p:cNvPr id="1" name=""/>
+        <p:cNvGrpSpPr/>
+        <p:nvPr/>
+      </p:nvGrpSpPr>
+      <p:grpSpPr>
+        <a:xfrm>
+          <a:off x="0" y="0"/>
+          <a:ext cx="0" cy="0"/>
+          <a:chOff x="0" y="0"/>
+          <a:chExt cx="0" cy="0"/>
+        </a:xfrm>
+      </p:grpSpPr>
+      <p:sp>
+        <p:nvSpPr>
+          <p:cNvPr id="2" name="Slide Image Placeholder 1"/>
+          <p:cNvSpPr>
+            <a:spLocks noGrp="1"/>
+          </p:cNvSpPr>
+          <p:nvPr>
+            <p:ph type="sldImg" idx="2"/>
+          </p:nvPr>
+        </p:nvSpPr>
+        <p:spPr/>
+      </p:sp>
+      <p:sp>
+        <p:nvSpPr>
+          <p:cNvPr id="3" name="Slide Number Placeholder 2"/>
+          <p:cNvSpPr>
+            <a:spLocks noGrp="1"/>
+          </p:cNvSpPr>
+          <p:nvPr>
+            <p:ph type="sldNum" idx="5" sz="quarter"/>
+          </p:nvPr>
+        </p:nvSpPr>
+        <p:spPr/>
+      </p:sp>
+      <p:sp>
+        <p:nvSpPr>
+          <p:cNvPr id="4" name="Notes Placeholder 3"/>
+          <p:cNvSpPr>
+            <a:spLocks noGrp="1"/>
+          </p:cNvSpPr>
+          <p:nvPr>
+            <p:ph type="body" idx="3" sz="quarter"/>
+          </p:nvPr>
+        </p:nvSpPr>
+        <p:spPr/>
+        <p:txBody>
+          <a:bodyPr/>
+          <a:lstStyle/>
+          <a:p>
+            <a:r>
+              <a:t>[Q&amp;A] Speaker B. Use when a judge asks "why no vector database?" or "why not pgvector?"</a:t>
+            </a:r>
+          </a:p>
+          <a:p/>
+          <a:p>
+            <a:r>
+              <a:t>"We do use vector search: every chunk is embedded with BGE-M3 and fused with keyword search. We just don't need a database to hold six thousand vectors. We tested pgvector on our own data: for the same exact results it was about seventeen times slower. With its default index it returned only forty of the two hundred candidates we need, and with a source filter almost none, without an error. A database becomes the right tool past about a hundred thousand chunks, and the swap is one function."</a:t>
+            </a:r>
+          </a:p>
+          <a:p/>
+          <a:p>
+            <a:r>
+              <a:t>If asked:</a:t>
+            </a:r>
+          </a:p>
+          <a:p>
+            <a:r>
+              <a:t>- Exact means brute force over every vector; only the vector step is exact. The final ranking also uses BM25 fusion, the cross-encoder and the Apertus grade.</a:t>
+            </a:r>
+          </a:p>
+          <a:p>
+            <a:r>
+              <a:t>- pgvector 0.8 has iterative index scans that fix the filter problem, but you have to know to switch them on.</a:t>
+            </a:r>
+          </a:p>
+          <a:p>
+            <a:r>
+              <a:t>- Each Cloud Run instance holds its own read-only copy: about 23 MB in memory. The models use far more.</a:t>
+            </a:r>
+          </a:p>
+          <a:p>
+            <a:r>
+              <a:t>- Benchmark 19 Oct 2026, local Docker, synthetic queries (chunk vectors plus noise). Absolute numbers differ on Cloud SQL; the pattern does not.</a:t>
+            </a:r>
+          </a:p>
+          <a:p>
+            <a:r>
+              <a:t>Don't say "next to Apertus": the container runs in Zurich (europe-west6), Apertus at CSCS via the Keera gateway.</a:t>
+            </a:r>
+          </a:p>
+        </p:txBody>
+      </p:sp>
+    </p:spTree>
+  </p:cSld>
+  <p:clrMapOvr>
+    <a:masterClrMapping/>
+  </p:clrMapOvr>
+</p:notes>
+</file>
+
 <file path=ppt/notesSlides/notesSlide10.xml><?xml version="1.0" encoding="utf-8"?>
 <p:notes xmlns:a="http://schemas.openxmlformats.org/drawingml/2006/main" xmlns:p="http://schemas.openxmlformats.org/presentationml/2006/main" xmlns:r="http://schemas.openxmlformats.org/officeDocument/2006/relationships">
   <p:cSld>
@@ -1784,6 +1893,118 @@
           <a:p>
             <a:r>
               <a:t>Use when a judge asks about ranking fairness or 'black box'. The explanation is built from logged scores, never invented by the model.</a:t>
+            </a:r>
+          </a:p>
+        </p:txBody>
+      </p:sp>
+    </p:spTree>
+  </p:cSld>
+  <p:clrMapOvr>
+    <a:masterClrMapping/>
+  </p:clrMapOvr>
+</p:notes>
+</file>
+
+<file path=ppt/notesSlides/notesSlide22.xml><?xml version="1.0" encoding="utf-8"?>
+<p:notes xmlns:a="http://schemas.openxmlformats.org/drawingml/2006/main" xmlns:p="http://schemas.openxmlformats.org/presentationml/2006/main" xmlns:r="http://schemas.openxmlformats.org/officeDocument/2006/relationships">
+  <p:cSld>
+    <p:spTree>
+      <p:nvGrpSpPr>
+        <p:cNvPr id="1" name=""/>
+        <p:cNvGrpSpPr/>
+        <p:nvPr/>
+      </p:nvGrpSpPr>
+      <p:grpSpPr>
+        <a:xfrm>
+          <a:off x="0" y="0"/>
+          <a:ext cx="0" cy="0"/>
+          <a:chOff x="0" y="0"/>
+          <a:chExt cx="0" cy="0"/>
+        </a:xfrm>
+      </p:grpSpPr>
+      <p:sp>
+        <p:nvSpPr>
+          <p:cNvPr id="2" name="Slide Image Placeholder 1"/>
+          <p:cNvSpPr>
+            <a:spLocks noGrp="1"/>
+          </p:cNvSpPr>
+          <p:nvPr>
+            <p:ph type="sldImg" idx="2"/>
+          </p:nvPr>
+        </p:nvSpPr>
+        <p:spPr/>
+      </p:sp>
+      <p:sp>
+        <p:nvSpPr>
+          <p:cNvPr id="3" name="Slide Number Placeholder 2"/>
+          <p:cNvSpPr>
+            <a:spLocks noGrp="1"/>
+          </p:cNvSpPr>
+          <p:nvPr>
+            <p:ph type="sldNum" idx="5" sz="quarter"/>
+          </p:nvPr>
+        </p:nvSpPr>
+        <p:spPr/>
+      </p:sp>
+      <p:sp>
+        <p:nvSpPr>
+          <p:cNvPr id="4" name="Notes Placeholder 3"/>
+          <p:cNvSpPr>
+            <a:spLocks noGrp="1"/>
+          </p:cNvSpPr>
+          <p:nvPr>
+            <p:ph type="body" idx="3" sz="quarter"/>
+          </p:nvPr>
+        </p:nvSpPr>
+        <p:spPr/>
+        <p:txBody>
+          <a:bodyPr/>
+          <a:lstStyle/>
+          <a:p>
+            <a:r>
+              <a:t>[Q&amp;A] Speaker A. Use when a judge asks "why only 3,000 pages?" or "why not all of UniBE?"</a:t>
+            </a:r>
+          </a:p>
+          <a:p/>
+          <a:p>
+            <a:r>
+              <a:t>"We chose depth over breadth. Our pages aren't just indexed: Apertus reads the ones about people and research and extracts people, units, projects and infrastructure, and then code checks every fact against the page. That check threw out forty percent of what the model extracted. So for the prototype we covered the Diabetes Center and ARTORG's research pages completely, and 14 more sites from the university inventory, the life science and medtech ones. That is 16 of the 42 inventory sites; adding one is a line of config, and the other 26 are already listed in the repo."</a:t>
+            </a:r>
+          </a:p>
+          <a:p/>
+          <a:p>
+            <a:r>
+              <a:t>HONESTY: the case asks for the whole UniBE inventory. Medtech was our choice, not the case's; don't say the case limited it.</a:t>
+            </a:r>
+          </a:p>
+          <a:p>
+            <a:r>
+              <a:t>- The 42 inventory entries include ARTORG and DCB, so we cover 16 and 26 remain.</a:t>
+            </a:r>
+          </a:p>
+          <a:p>
+            <a:r>
+              <a:t>- 8 of the 14 UniBE sites hit the 200 page cap, so don't say those are complete. Raising the cap is one number.</a:t>
+            </a:r>
+          </a:p>
+          <a:p>
+            <a:r>
+              <a:t>- Extraction runs on Apertus 8B (bulk); needs, expansions, grading and reasons run on Apertus 70B.</a:t>
+            </a:r>
+          </a:p>
+          <a:p>
+            <a:r>
+              <a:t>- Left out on purpose: computer science, Vetsuisse, legal medicine, medical education and history, non life science institutes.</a:t>
+            </a:r>
+          </a:p>
+          <a:p>
+            <a:r>
+              <a:t>- A question outside the crawl gets "no match" plus the list of sources searched, never a guess.</a:t>
+            </a:r>
+          </a:p>
+          <a:p>
+            <a:r>
+              <a:t>Counts: data/pages.jsonl (3,026 pages), data/chunks.jsonl (5,666), logs/extract_stats.json, data/kg.sqlite.</a:t>
             </a:r>
           </a:p>
         </p:txBody>
@@ -17687,6 +17908,2105 @@
                 </a:solidFill>
               </a:rPr>
               <a:t>not stated anywhere</a:t>
+            </a:r>
+          </a:p>
+        </p:txBody>
+      </p:sp>
+    </p:spTree>
+  </p:cSld>
+  <p:clrMapOvr>
+    <a:masterClrMapping/>
+  </p:clrMapOvr>
+  <p:transition spd="med">
+    <p:fade/>
+  </p:transition>
+</p:sld>
+</file>
+
+<file path=ppt/slides/slide21.xml><?xml version="1.0" encoding="utf-8"?>
+<p:sld xmlns:a="http://schemas.openxmlformats.org/drawingml/2006/main" xmlns:p="http://schemas.openxmlformats.org/presentationml/2006/main" xmlns:r="http://schemas.openxmlformats.org/officeDocument/2006/relationships">
+  <p:cSld>
+    <p:spTree>
+      <p:nvGrpSpPr>
+        <p:cNvPr id="1" name=""/>
+        <p:cNvGrpSpPr/>
+        <p:nvPr/>
+      </p:nvGrpSpPr>
+      <p:grpSpPr/>
+      <p:sp>
+        <p:nvSpPr>
+          <p:cNvPr id="2" name="Title 1"/>
+          <p:cNvSpPr>
+            <a:spLocks noGrp="1"/>
+          </p:cNvSpPr>
+          <p:nvPr>
+            <p:ph type="title"/>
+          </p:nvPr>
+        </p:nvSpPr>
+        <p:spPr/>
+        <p:txBody>
+          <a:bodyPr/>
+          <a:lstStyle/>
+          <a:p>
+            <a:r>
+              <a:t>Appendix · Why no vector database?</a:t>
+            </a:r>
+          </a:p>
+        </p:txBody>
+      </p:sp>
+      <p:sp>
+        <p:nvSpPr>
+          <p:cNvPr id="901" name="Fußzeilenplatzhalter 4">
+            <a:extLst>
+              <a:ext uri="{FF2B5EF4-FFF2-40B4-BE49-F238E27FC236}">
+                <a16:creationId xmlns:a16="http://schemas.microsoft.com/office/drawing/2014/main" id="{C7FF4EBF-1F95-422C-ABDC-BAC99BA2526A}"/>
+              </a:ext>
+            </a:extLst>
+          </p:cNvPr>
+          <p:cNvSpPr>
+            <a:spLocks noGrp="1"/>
+          </p:cNvSpPr>
+          <p:nvPr>
+            <p:ph type="ftr" sz="quarter" idx="11"/>
+          </p:nvPr>
+        </p:nvSpPr>
+        <p:spPr/>
+        <p:txBody>
+          <a:bodyPr/>
+          <a:lstStyle/>
+          <a:p>
+            <a:r>
+              <a:rPr lang="de-CH"/>
+              <a:t>Team Ctrl+Free</a:t>
+            </a:r>
+            <a:endParaRPr lang="de-CH" dirty="0"/>
+          </a:p>
+        </p:txBody>
+      </p:sp>
+      <p:sp>
+        <p:nvSpPr>
+          <p:cNvPr id="902" name="Foliennummernplatzhalter 5">
+            <a:extLst>
+              <a:ext uri="{FF2B5EF4-FFF2-40B4-BE49-F238E27FC236}">
+                <a16:creationId xmlns:a16="http://schemas.microsoft.com/office/drawing/2014/main" id="{56A97AFD-16FE-4EA5-A888-4A84A29DE559}"/>
+              </a:ext>
+            </a:extLst>
+          </p:cNvPr>
+          <p:cNvSpPr>
+            <a:spLocks noGrp="1"/>
+          </p:cNvSpPr>
+          <p:nvPr>
+            <p:ph type="sldNum" sz="quarter" idx="12"/>
+          </p:nvPr>
+        </p:nvSpPr>
+        <p:spPr/>
+        <p:txBody>
+          <a:bodyPr/>
+          <a:lstStyle/>
+          <a:p>
+            <a:fld id="{442AD375-037F-43D0-B059-5172DA06796A}" type="slidenum">
+              <a:rPr lang="de-CH" smtClean="0"/>
+              <a:pPr/>
+              <a:t>20</a:t>
+            </a:fld>
+            <a:endParaRPr lang="de-CH" dirty="0"/>
+          </a:p>
+        </p:txBody>
+      </p:sp>
+      <p:graphicFrame>
+        <p:nvGraphicFramePr>
+          <p:cNvPr id="1001" name="Table 1001"/>
+          <p:cNvGraphicFramePr>
+            <a:graphicFrameLocks noGrp="1"/>
+          </p:cNvGraphicFramePr>
+          <p:nvPr/>
+        </p:nvGraphicFramePr>
+        <p:xfrm>
+          <a:off x="841248" y="1920240"/>
+          <a:ext cx="6583680" cy="2697480"/>
+        </p:xfrm>
+        <a:graphic>
+          <a:graphicData uri="http://schemas.openxmlformats.org/drawingml/2006/table">
+            <a:tbl>
+              <a:tblPr firstRow="1"/>
+              <a:tblGrid>
+                <a:gridCol w="3017520"/>
+                <a:gridCol w="1234440"/>
+                <a:gridCol w="1051560"/>
+                <a:gridCol w="1280160"/>
+              </a:tblGrid>
+              <a:tr h="411480">
+                <a:tc>
+                  <a:txBody>
+                    <a:bodyPr/>
+                    <a:lstStyle/>
+                    <a:p>
+                      <a:pPr algn="l"/>
+                      <a:r>
+                        <a:rPr lang="en-GB" sz="1200" b="1" i="0" dirty="0">
+                          <a:solidFill>
+                            <a:srgbClr val="63737B"/>
+                          </a:solidFill>
+                        </a:rPr>
+                        <a:t>Same top 200 search on our vectors</a:t>
+                      </a:r>
+                    </a:p>
+                  </a:txBody>
+                  <a:tcPr marL="91440" marR="91440" marT="45720" marB="45720" anchor="ctr">
+                    <a:lnL>
+                      <a:noFill/>
+                    </a:lnL>
+                    <a:lnR>
+                      <a:noFill/>
+                    </a:lnR>
+                    <a:lnT>
+                      <a:noFill/>
+                    </a:lnT>
+                    <a:lnB w="19050">
+                      <a:solidFill>
+                        <a:srgbClr val="000000"/>
+                      </a:solidFill>
+                    </a:lnB>
+                    <a:noFill/>
+                  </a:tcPr>
+                </a:tc>
+                <a:tc>
+                  <a:txBody>
+                    <a:bodyPr/>
+                    <a:lstStyle/>
+                    <a:p>
+                      <a:pPr algn="r"/>
+                      <a:r>
+                        <a:rPr lang="en-GB" sz="1200" b="1" i="0" dirty="0">
+                          <a:solidFill>
+                            <a:srgbClr val="63737B"/>
+                          </a:solidFill>
+                        </a:rPr>
+                        <a:t>Per query</a:t>
+                      </a:r>
+                    </a:p>
+                  </a:txBody>
+                  <a:tcPr marL="91440" marR="91440" marT="45720" marB="45720" anchor="ctr">
+                    <a:lnL>
+                      <a:noFill/>
+                    </a:lnL>
+                    <a:lnR>
+                      <a:noFill/>
+                    </a:lnR>
+                    <a:lnT>
+                      <a:noFill/>
+                    </a:lnT>
+                    <a:lnB w="19050">
+                      <a:solidFill>
+                        <a:srgbClr val="000000"/>
+                      </a:solidFill>
+                    </a:lnB>
+                    <a:noFill/>
+                  </a:tcPr>
+                </a:tc>
+                <a:tc>
+                  <a:txBody>
+                    <a:bodyPr/>
+                    <a:lstStyle/>
+                    <a:p>
+                      <a:pPr algn="r"/>
+                      <a:r>
+                        <a:rPr lang="en-GB" sz="1200" b="1" i="0" dirty="0">
+                          <a:solidFill>
+                            <a:srgbClr val="63737B"/>
+                          </a:solidFill>
+                        </a:rPr>
+                        <a:t>Rows</a:t>
+                      </a:r>
+                    </a:p>
+                  </a:txBody>
+                  <a:tcPr marL="91440" marR="91440" marT="45720" marB="45720" anchor="ctr">
+                    <a:lnL>
+                      <a:noFill/>
+                    </a:lnL>
+                    <a:lnR>
+                      <a:noFill/>
+                    </a:lnR>
+                    <a:lnT>
+                      <a:noFill/>
+                    </a:lnT>
+                    <a:lnB w="19050">
+                      <a:solidFill>
+                        <a:srgbClr val="000000"/>
+                      </a:solidFill>
+                    </a:lnB>
+                    <a:noFill/>
+                  </a:tcPr>
+                </a:tc>
+                <a:tc>
+                  <a:txBody>
+                    <a:bodyPr/>
+                    <a:lstStyle/>
+                    <a:p>
+                      <a:pPr algn="r"/>
+                      <a:r>
+                        <a:rPr lang="en-GB" sz="1200" b="1" i="0" dirty="0">
+                          <a:solidFill>
+                            <a:srgbClr val="63737B"/>
+                          </a:solidFill>
+                        </a:rPr>
+                        <a:t>Recall</a:t>
+                      </a:r>
+                    </a:p>
+                  </a:txBody>
+                  <a:tcPr marL="91440" marR="91440" marT="45720" marB="45720" anchor="ctr">
+                    <a:lnL>
+                      <a:noFill/>
+                    </a:lnL>
+                    <a:lnR>
+                      <a:noFill/>
+                    </a:lnR>
+                    <a:lnT>
+                      <a:noFill/>
+                    </a:lnT>
+                    <a:lnB w="19050">
+                      <a:solidFill>
+                        <a:srgbClr val="000000"/>
+                      </a:solidFill>
+                    </a:lnB>
+                    <a:noFill/>
+                  </a:tcPr>
+                </a:tc>
+              </a:tr>
+              <a:tr h="457200">
+                <a:tc>
+                  <a:txBody>
+                    <a:bodyPr/>
+                    <a:lstStyle/>
+                    <a:p>
+                      <a:pPr algn="l"/>
+                      <a:r>
+                        <a:rPr lang="en-GB" sz="1300" b="1" i="0" dirty="0">
+                          <a:solidFill>
+                            <a:srgbClr val="000000"/>
+                          </a:solidFill>
+                        </a:rPr>
+                        <a:t>Ours: exact search in the app</a:t>
+                      </a:r>
+                    </a:p>
+                  </a:txBody>
+                  <a:tcPr marL="91440" marR="91440" marT="45720" marB="45720" anchor="ctr">
+                    <a:lnL>
+                      <a:noFill/>
+                    </a:lnL>
+                    <a:lnR>
+                      <a:noFill/>
+                    </a:lnR>
+                    <a:lnT>
+                      <a:noFill/>
+                    </a:lnT>
+                    <a:lnB w="6350">
+                      <a:solidFill>
+                        <a:srgbClr val="B1B9BD"/>
+                      </a:solidFill>
+                    </a:lnB>
+                    <a:solidFill>
+                      <a:srgbClr val="EEF1F2"/>
+                    </a:solidFill>
+                  </a:tcPr>
+                </a:tc>
+                <a:tc>
+                  <a:txBody>
+                    <a:bodyPr/>
+                    <a:lstStyle/>
+                    <a:p>
+                      <a:pPr algn="r"/>
+                      <a:r>
+                        <a:rPr lang="en-GB" sz="1300" b="1" i="0" dirty="0">
+                          <a:solidFill>
+                            <a:srgbClr val="000000"/>
+                          </a:solidFill>
+                        </a:rPr>
+                        <a:t>0.5 ms</a:t>
+                      </a:r>
+                    </a:p>
+                  </a:txBody>
+                  <a:tcPr marL="91440" marR="91440" marT="45720" marB="45720" anchor="ctr">
+                    <a:lnL>
+                      <a:noFill/>
+                    </a:lnL>
+                    <a:lnR>
+                      <a:noFill/>
+                    </a:lnR>
+                    <a:lnT>
+                      <a:noFill/>
+                    </a:lnT>
+                    <a:lnB w="6350">
+                      <a:solidFill>
+                        <a:srgbClr val="B1B9BD"/>
+                      </a:solidFill>
+                    </a:lnB>
+                    <a:solidFill>
+                      <a:srgbClr val="EEF1F2"/>
+                    </a:solidFill>
+                  </a:tcPr>
+                </a:tc>
+                <a:tc>
+                  <a:txBody>
+                    <a:bodyPr/>
+                    <a:lstStyle/>
+                    <a:p>
+                      <a:pPr algn="r"/>
+                      <a:r>
+                        <a:rPr lang="en-GB" sz="1300" b="1" i="0" dirty="0">
+                          <a:solidFill>
+                            <a:srgbClr val="000000"/>
+                          </a:solidFill>
+                        </a:rPr>
+                        <a:t>200</a:t>
+                      </a:r>
+                    </a:p>
+                  </a:txBody>
+                  <a:tcPr marL="91440" marR="91440" marT="45720" marB="45720" anchor="ctr">
+                    <a:lnL>
+                      <a:noFill/>
+                    </a:lnL>
+                    <a:lnR>
+                      <a:noFill/>
+                    </a:lnR>
+                    <a:lnT>
+                      <a:noFill/>
+                    </a:lnT>
+                    <a:lnB w="6350">
+                      <a:solidFill>
+                        <a:srgbClr val="B1B9BD"/>
+                      </a:solidFill>
+                    </a:lnB>
+                    <a:solidFill>
+                      <a:srgbClr val="EEF1F2"/>
+                    </a:solidFill>
+                  </a:tcPr>
+                </a:tc>
+                <a:tc>
+                  <a:txBody>
+                    <a:bodyPr/>
+                    <a:lstStyle/>
+                    <a:p>
+                      <a:pPr algn="r"/>
+                      <a:r>
+                        <a:rPr lang="en-GB" sz="1300" b="1" i="0" dirty="0">
+                          <a:solidFill>
+                            <a:srgbClr val="000000"/>
+                          </a:solidFill>
+                        </a:rPr>
+                        <a:t>100%</a:t>
+                      </a:r>
+                    </a:p>
+                  </a:txBody>
+                  <a:tcPr marL="91440" marR="91440" marT="45720" marB="45720" anchor="ctr">
+                    <a:lnL>
+                      <a:noFill/>
+                    </a:lnL>
+                    <a:lnR>
+                      <a:noFill/>
+                    </a:lnR>
+                    <a:lnT>
+                      <a:noFill/>
+                    </a:lnT>
+                    <a:lnB w="6350">
+                      <a:solidFill>
+                        <a:srgbClr val="B1B9BD"/>
+                      </a:solidFill>
+                    </a:lnB>
+                    <a:solidFill>
+                      <a:srgbClr val="EEF1F2"/>
+                    </a:solidFill>
+                  </a:tcPr>
+                </a:tc>
+              </a:tr>
+              <a:tr h="457200">
+                <a:tc>
+                  <a:txBody>
+                    <a:bodyPr/>
+                    <a:lstStyle/>
+                    <a:p>
+                      <a:pPr algn="l"/>
+                      <a:r>
+                        <a:rPr lang="en-GB" sz="1300" b="0" i="0" dirty="0">
+                          <a:solidFill>
+                            <a:srgbClr val="000000"/>
+                          </a:solidFill>
+                        </a:rPr>
+                        <a:t>pgvector, exact</a:t>
+                      </a:r>
+                    </a:p>
+                  </a:txBody>
+                  <a:tcPr marL="91440" marR="91440" marT="45720" marB="45720" anchor="ctr">
+                    <a:lnL>
+                      <a:noFill/>
+                    </a:lnL>
+                    <a:lnR>
+                      <a:noFill/>
+                    </a:lnR>
+                    <a:lnT>
+                      <a:noFill/>
+                    </a:lnT>
+                    <a:lnB w="6350">
+                      <a:solidFill>
+                        <a:srgbClr val="B1B9BD"/>
+                      </a:solidFill>
+                    </a:lnB>
+                    <a:noFill/>
+                  </a:tcPr>
+                </a:tc>
+                <a:tc>
+                  <a:txBody>
+                    <a:bodyPr/>
+                    <a:lstStyle/>
+                    <a:p>
+                      <a:pPr algn="r"/>
+                      <a:r>
+                        <a:rPr lang="en-GB" sz="1300" b="0" i="0" dirty="0">
+                          <a:solidFill>
+                            <a:srgbClr val="000000"/>
+                          </a:solidFill>
+                        </a:rPr>
+                        <a:t>8.7 ms</a:t>
+                      </a:r>
+                    </a:p>
+                  </a:txBody>
+                  <a:tcPr marL="91440" marR="91440" marT="45720" marB="45720" anchor="ctr">
+                    <a:lnL>
+                      <a:noFill/>
+                    </a:lnL>
+                    <a:lnR>
+                      <a:noFill/>
+                    </a:lnR>
+                    <a:lnT>
+                      <a:noFill/>
+                    </a:lnT>
+                    <a:lnB w="6350">
+                      <a:solidFill>
+                        <a:srgbClr val="B1B9BD"/>
+                      </a:solidFill>
+                    </a:lnB>
+                    <a:noFill/>
+                  </a:tcPr>
+                </a:tc>
+                <a:tc>
+                  <a:txBody>
+                    <a:bodyPr/>
+                    <a:lstStyle/>
+                    <a:p>
+                      <a:pPr algn="r"/>
+                      <a:r>
+                        <a:rPr lang="en-GB" sz="1300" b="0" i="0" dirty="0">
+                          <a:solidFill>
+                            <a:srgbClr val="000000"/>
+                          </a:solidFill>
+                        </a:rPr>
+                        <a:t>200</a:t>
+                      </a:r>
+                    </a:p>
+                  </a:txBody>
+                  <a:tcPr marL="91440" marR="91440" marT="45720" marB="45720" anchor="ctr">
+                    <a:lnL>
+                      <a:noFill/>
+                    </a:lnL>
+                    <a:lnR>
+                      <a:noFill/>
+                    </a:lnR>
+                    <a:lnT>
+                      <a:noFill/>
+                    </a:lnT>
+                    <a:lnB w="6350">
+                      <a:solidFill>
+                        <a:srgbClr val="B1B9BD"/>
+                      </a:solidFill>
+                    </a:lnB>
+                    <a:noFill/>
+                  </a:tcPr>
+                </a:tc>
+                <a:tc>
+                  <a:txBody>
+                    <a:bodyPr/>
+                    <a:lstStyle/>
+                    <a:p>
+                      <a:pPr algn="r"/>
+                      <a:r>
+                        <a:rPr lang="en-GB" sz="1300" b="0" i="0" dirty="0">
+                          <a:solidFill>
+                            <a:srgbClr val="000000"/>
+                          </a:solidFill>
+                        </a:rPr>
+                        <a:t>100%</a:t>
+                      </a:r>
+                    </a:p>
+                  </a:txBody>
+                  <a:tcPr marL="91440" marR="91440" marT="45720" marB="45720" anchor="ctr">
+                    <a:lnL>
+                      <a:noFill/>
+                    </a:lnL>
+                    <a:lnR>
+                      <a:noFill/>
+                    </a:lnR>
+                    <a:lnT>
+                      <a:noFill/>
+                    </a:lnT>
+                    <a:lnB w="6350">
+                      <a:solidFill>
+                        <a:srgbClr val="B1B9BD"/>
+                      </a:solidFill>
+                    </a:lnB>
+                    <a:noFill/>
+                  </a:tcPr>
+                </a:tc>
+              </a:tr>
+              <a:tr h="457200">
+                <a:tc>
+                  <a:txBody>
+                    <a:bodyPr/>
+                    <a:lstStyle/>
+                    <a:p>
+                      <a:pPr algn="l"/>
+                      <a:r>
+                        <a:rPr lang="en-GB" sz="1300" b="0" i="0" dirty="0">
+                          <a:solidFill>
+                            <a:srgbClr val="000000"/>
+                          </a:solidFill>
+                        </a:rPr>
+                        <a:t>pgvector HNSW, default settings</a:t>
+                      </a:r>
+                    </a:p>
+                  </a:txBody>
+                  <a:tcPr marL="91440" marR="91440" marT="45720" marB="45720" anchor="ctr">
+                    <a:lnL>
+                      <a:noFill/>
+                    </a:lnL>
+                    <a:lnR>
+                      <a:noFill/>
+                    </a:lnR>
+                    <a:lnT>
+                      <a:noFill/>
+                    </a:lnT>
+                    <a:lnB w="6350">
+                      <a:solidFill>
+                        <a:srgbClr val="B1B9BD"/>
+                      </a:solidFill>
+                    </a:lnB>
+                    <a:noFill/>
+                  </a:tcPr>
+                </a:tc>
+                <a:tc>
+                  <a:txBody>
+                    <a:bodyPr/>
+                    <a:lstStyle/>
+                    <a:p>
+                      <a:pPr algn="r"/>
+                      <a:r>
+                        <a:rPr lang="en-GB" sz="1300" b="0" i="0" dirty="0">
+                          <a:solidFill>
+                            <a:srgbClr val="000000"/>
+                          </a:solidFill>
+                        </a:rPr>
+                        <a:t>1.9 ms</a:t>
+                      </a:r>
+                    </a:p>
+                  </a:txBody>
+                  <a:tcPr marL="91440" marR="91440" marT="45720" marB="45720" anchor="ctr">
+                    <a:lnL>
+                      <a:noFill/>
+                    </a:lnL>
+                    <a:lnR>
+                      <a:noFill/>
+                    </a:lnR>
+                    <a:lnT>
+                      <a:noFill/>
+                    </a:lnT>
+                    <a:lnB w="6350">
+                      <a:solidFill>
+                        <a:srgbClr val="B1B9BD"/>
+                      </a:solidFill>
+                    </a:lnB>
+                    <a:noFill/>
+                  </a:tcPr>
+                </a:tc>
+                <a:tc>
+                  <a:txBody>
+                    <a:bodyPr/>
+                    <a:lstStyle/>
+                    <a:p>
+                      <a:pPr algn="r"/>
+                      <a:r>
+                        <a:rPr lang="en-GB" sz="1300" b="0" i="0" dirty="0">
+                          <a:solidFill>
+                            <a:srgbClr val="EA161F"/>
+                          </a:solidFill>
+                        </a:rPr>
+                        <a:t>40</a:t>
+                      </a:r>
+                    </a:p>
+                  </a:txBody>
+                  <a:tcPr marL="91440" marR="91440" marT="45720" marB="45720" anchor="ctr">
+                    <a:lnL>
+                      <a:noFill/>
+                    </a:lnL>
+                    <a:lnR>
+                      <a:noFill/>
+                    </a:lnR>
+                    <a:lnT>
+                      <a:noFill/>
+                    </a:lnT>
+                    <a:lnB w="6350">
+                      <a:solidFill>
+                        <a:srgbClr val="B1B9BD"/>
+                      </a:solidFill>
+                    </a:lnB>
+                    <a:noFill/>
+                  </a:tcPr>
+                </a:tc>
+                <a:tc>
+                  <a:txBody>
+                    <a:bodyPr/>
+                    <a:lstStyle/>
+                    <a:p>
+                      <a:pPr algn="r"/>
+                      <a:r>
+                        <a:rPr lang="en-GB" sz="1300" b="0" i="0" dirty="0">
+                          <a:solidFill>
+                            <a:srgbClr val="EA161F"/>
+                          </a:solidFill>
+                        </a:rPr>
+                        <a:t>20%</a:t>
+                      </a:r>
+                    </a:p>
+                  </a:txBody>
+                  <a:tcPr marL="91440" marR="91440" marT="45720" marB="45720" anchor="ctr">
+                    <a:lnL>
+                      <a:noFill/>
+                    </a:lnL>
+                    <a:lnR>
+                      <a:noFill/>
+                    </a:lnR>
+                    <a:lnT>
+                      <a:noFill/>
+                    </a:lnT>
+                    <a:lnB w="6350">
+                      <a:solidFill>
+                        <a:srgbClr val="B1B9BD"/>
+                      </a:solidFill>
+                    </a:lnB>
+                    <a:noFill/>
+                  </a:tcPr>
+                </a:tc>
+              </a:tr>
+              <a:tr h="457200">
+                <a:tc>
+                  <a:txBody>
+                    <a:bodyPr/>
+                    <a:lstStyle/>
+                    <a:p>
+                      <a:pPr algn="l"/>
+                      <a:r>
+                        <a:rPr lang="en-GB" sz="1300" b="0" i="0" dirty="0">
+                          <a:solidFill>
+                            <a:srgbClr val="000000"/>
+                          </a:solidFill>
+                        </a:rPr>
+                        <a:t>pgvector HNSW, ef_search = 200</a:t>
+                      </a:r>
+                    </a:p>
+                  </a:txBody>
+                  <a:tcPr marL="91440" marR="91440" marT="45720" marB="45720" anchor="ctr">
+                    <a:lnL>
+                      <a:noFill/>
+                    </a:lnL>
+                    <a:lnR>
+                      <a:noFill/>
+                    </a:lnR>
+                    <a:lnT>
+                      <a:noFill/>
+                    </a:lnT>
+                    <a:lnB w="6350">
+                      <a:solidFill>
+                        <a:srgbClr val="B1B9BD"/>
+                      </a:solidFill>
+                    </a:lnB>
+                    <a:noFill/>
+                  </a:tcPr>
+                </a:tc>
+                <a:tc>
+                  <a:txBody>
+                    <a:bodyPr/>
+                    <a:lstStyle/>
+                    <a:p>
+                      <a:pPr algn="r"/>
+                      <a:r>
+                        <a:rPr lang="en-GB" sz="1300" b="0" i="0" dirty="0">
+                          <a:solidFill>
+                            <a:srgbClr val="000000"/>
+                          </a:solidFill>
+                        </a:rPr>
+                        <a:t>4.7 ms</a:t>
+                      </a:r>
+                    </a:p>
+                  </a:txBody>
+                  <a:tcPr marL="91440" marR="91440" marT="45720" marB="45720" anchor="ctr">
+                    <a:lnL>
+                      <a:noFill/>
+                    </a:lnL>
+                    <a:lnR>
+                      <a:noFill/>
+                    </a:lnR>
+                    <a:lnT>
+                      <a:noFill/>
+                    </a:lnT>
+                    <a:lnB w="6350">
+                      <a:solidFill>
+                        <a:srgbClr val="B1B9BD"/>
+                      </a:solidFill>
+                    </a:lnB>
+                    <a:noFill/>
+                  </a:tcPr>
+                </a:tc>
+                <a:tc>
+                  <a:txBody>
+                    <a:bodyPr/>
+                    <a:lstStyle/>
+                    <a:p>
+                      <a:pPr algn="r"/>
+                      <a:r>
+                        <a:rPr lang="en-GB" sz="1300" b="0" i="0" dirty="0">
+                          <a:solidFill>
+                            <a:srgbClr val="000000"/>
+                          </a:solidFill>
+                        </a:rPr>
+                        <a:t>200</a:t>
+                      </a:r>
+                    </a:p>
+                  </a:txBody>
+                  <a:tcPr marL="91440" marR="91440" marT="45720" marB="45720" anchor="ctr">
+                    <a:lnL>
+                      <a:noFill/>
+                    </a:lnL>
+                    <a:lnR>
+                      <a:noFill/>
+                    </a:lnR>
+                    <a:lnT>
+                      <a:noFill/>
+                    </a:lnT>
+                    <a:lnB w="6350">
+                      <a:solidFill>
+                        <a:srgbClr val="B1B9BD"/>
+                      </a:solidFill>
+                    </a:lnB>
+                    <a:noFill/>
+                  </a:tcPr>
+                </a:tc>
+                <a:tc>
+                  <a:txBody>
+                    <a:bodyPr/>
+                    <a:lstStyle/>
+                    <a:p>
+                      <a:pPr algn="r"/>
+                      <a:r>
+                        <a:rPr lang="en-GB" sz="1300" b="0" i="0" dirty="0">
+                          <a:solidFill>
+                            <a:srgbClr val="000000"/>
+                          </a:solidFill>
+                        </a:rPr>
+                        <a:t>99%</a:t>
+                      </a:r>
+                    </a:p>
+                  </a:txBody>
+                  <a:tcPr marL="91440" marR="91440" marT="45720" marB="45720" anchor="ctr">
+                    <a:lnL>
+                      <a:noFill/>
+                    </a:lnL>
+                    <a:lnR>
+                      <a:noFill/>
+                    </a:lnR>
+                    <a:lnT>
+                      <a:noFill/>
+                    </a:lnT>
+                    <a:lnB w="6350">
+                      <a:solidFill>
+                        <a:srgbClr val="B1B9BD"/>
+                      </a:solidFill>
+                    </a:lnB>
+                    <a:noFill/>
+                  </a:tcPr>
+                </a:tc>
+              </a:tr>
+              <a:tr h="457200">
+                <a:tc>
+                  <a:txBody>
+                    <a:bodyPr/>
+                    <a:lstStyle/>
+                    <a:p>
+                      <a:pPr algn="l"/>
+                      <a:r>
+                        <a:rPr lang="en-GB" sz="1300" b="0" i="0" dirty="0">
+                          <a:solidFill>
+                            <a:srgbClr val="000000"/>
+                          </a:solidFill>
+                        </a:rPr>
+                        <a:t>pgvector HNSW + source filter</a:t>
+                      </a:r>
+                    </a:p>
+                  </a:txBody>
+                  <a:tcPr marL="91440" marR="91440" marT="45720" marB="45720" anchor="ctr">
+                    <a:lnL>
+                      <a:noFill/>
+                    </a:lnL>
+                    <a:lnR>
+                      <a:noFill/>
+                    </a:lnR>
+                    <a:lnT>
+                      <a:noFill/>
+                    </a:lnT>
+                    <a:lnB w="6350">
+                      <a:solidFill>
+                        <a:srgbClr val="B1B9BD"/>
+                      </a:solidFill>
+                    </a:lnB>
+                    <a:noFill/>
+                  </a:tcPr>
+                </a:tc>
+                <a:tc>
+                  <a:txBody>
+                    <a:bodyPr/>
+                    <a:lstStyle/>
+                    <a:p>
+                      <a:pPr algn="r"/>
+                      <a:r>
+                        <a:rPr lang="en-GB" sz="1300" b="0" i="0" dirty="0">
+                          <a:solidFill>
+                            <a:srgbClr val="000000"/>
+                          </a:solidFill>
+                        </a:rPr>
+                        <a:t>2–4 ms</a:t>
+                      </a:r>
+                    </a:p>
+                  </a:txBody>
+                  <a:tcPr marL="91440" marR="91440" marT="45720" marB="45720" anchor="ctr">
+                    <a:lnL>
+                      <a:noFill/>
+                    </a:lnL>
+                    <a:lnR>
+                      <a:noFill/>
+                    </a:lnR>
+                    <a:lnT>
+                      <a:noFill/>
+                    </a:lnT>
+                    <a:lnB w="6350">
+                      <a:solidFill>
+                        <a:srgbClr val="B1B9BD"/>
+                      </a:solidFill>
+                    </a:lnB>
+                    <a:noFill/>
+                  </a:tcPr>
+                </a:tc>
+                <a:tc>
+                  <a:txBody>
+                    <a:bodyPr/>
+                    <a:lstStyle/>
+                    <a:p>
+                      <a:pPr algn="r"/>
+                      <a:r>
+                        <a:rPr lang="en-GB" sz="1300" b="0" i="0" dirty="0">
+                          <a:solidFill>
+                            <a:srgbClr val="EA161F"/>
+                          </a:solidFill>
+                        </a:rPr>
+                        <a:t>0–1</a:t>
+                      </a:r>
+                    </a:p>
+                  </a:txBody>
+                  <a:tcPr marL="91440" marR="91440" marT="45720" marB="45720" anchor="ctr">
+                    <a:lnL>
+                      <a:noFill/>
+                    </a:lnL>
+                    <a:lnR>
+                      <a:noFill/>
+                    </a:lnR>
+                    <a:lnT>
+                      <a:noFill/>
+                    </a:lnT>
+                    <a:lnB w="6350">
+                      <a:solidFill>
+                        <a:srgbClr val="B1B9BD"/>
+                      </a:solidFill>
+                    </a:lnB>
+                    <a:noFill/>
+                  </a:tcPr>
+                </a:tc>
+                <a:tc>
+                  <a:txBody>
+                    <a:bodyPr/>
+                    <a:lstStyle/>
+                    <a:p>
+                      <a:pPr algn="r"/>
+                      <a:r>
+                        <a:rPr lang="en-GB" sz="1300" b="0" i="0" dirty="0">
+                          <a:solidFill>
+                            <a:srgbClr val="EA161F"/>
+                          </a:solidFill>
+                        </a:rPr>
+                        <a:t>2–10%</a:t>
+                      </a:r>
+                    </a:p>
+                  </a:txBody>
+                  <a:tcPr marL="91440" marR="91440" marT="45720" marB="45720" anchor="ctr">
+                    <a:lnL>
+                      <a:noFill/>
+                    </a:lnL>
+                    <a:lnR>
+                      <a:noFill/>
+                    </a:lnR>
+                    <a:lnT>
+                      <a:noFill/>
+                    </a:lnT>
+                    <a:lnB w="6350">
+                      <a:solidFill>
+                        <a:srgbClr val="B1B9BD"/>
+                      </a:solidFill>
+                    </a:lnB>
+                    <a:noFill/>
+                  </a:tcPr>
+                </a:tc>
+              </a:tr>
+            </a:tbl>
+          </a:graphicData>
+        </a:graphic>
+      </p:graphicFrame>
+      <p:sp>
+        <p:nvSpPr>
+          <p:cNvPr id="1002" name="TextBox 1002"/>
+          <p:cNvSpPr txBox="1"/>
+          <p:nvPr/>
+        </p:nvSpPr>
+        <p:spPr>
+          <a:xfrm>
+            <a:off x="841248" y="4846320"/>
+            <a:ext cx="6583680" cy="1097280"/>
+          </a:xfrm>
+          <a:prstGeom prst="rect">
+            <a:avLst/>
+          </a:prstGeom>
+          <a:noFill/>
+        </p:spPr>
+        <p:txBody>
+          <a:bodyPr wrap="square" lIns="0" rIns="0" tIns="0" bIns="0" anchor="t">
+            <a:normAutofit/>
+          </a:bodyPr>
+          <a:lstStyle/>
+          <a:p>
+            <a:pPr algn="l">
+              <a:spcAft>
+                <a:spcPts val="600"/>
+              </a:spcAft>
+            </a:pPr>
+            <a:r>
+              <a:rPr lang="en-GB" sz="1200" b="0" i="0" dirty="0">
+                <a:solidFill>
+                  <a:srgbClr val="63737B"/>
+                </a:solidFill>
+              </a:rPr>
+              <a:t>Measured on our 5,666 BGE-M3 vectors (1024 dims), 100 queries, top 200 per query as search/query.py asks for. Postgres 17 + pgvector in Docker on a laptop; Cloud SQL would add network time.</a:t>
+            </a:r>
+          </a:p>
+        </p:txBody>
+      </p:sp>
+      <p:cxnSp>
+        <p:nvCxnSpPr>
+          <p:cNvPr id="1003" name="Connector 1003"/>
+          <p:cNvCxnSpPr/>
+          <p:nvPr/>
+        </p:nvCxnSpPr>
+        <p:spPr>
+          <a:xfrm>
+            <a:off x="7818120" y="1920240"/>
+            <a:ext cx="0" cy="4297680"/>
+          </a:xfrm>
+          <a:prstGeom prst="line">
+            <a:avLst/>
+          </a:prstGeom>
+          <a:ln w="9525">
+            <a:solidFill>
+              <a:srgbClr val="B1B9BD"/>
+            </a:solidFill>
+          </a:ln>
+        </p:spPr>
+      </p:cxnSp>
+      <p:sp>
+        <p:nvSpPr>
+          <p:cNvPr id="1004" name="TextBox 1004"/>
+          <p:cNvSpPr txBox="1"/>
+          <p:nvPr/>
+        </p:nvSpPr>
+        <p:spPr>
+          <a:xfrm>
+            <a:off x="8183880" y="1920240"/>
+            <a:ext cx="3657600" cy="365760"/>
+          </a:xfrm>
+          <a:prstGeom prst="rect">
+            <a:avLst/>
+          </a:prstGeom>
+          <a:noFill/>
+        </p:spPr>
+        <p:txBody>
+          <a:bodyPr wrap="square" lIns="0" rIns="0" tIns="0" bIns="0" anchor="t">
+            <a:normAutofit/>
+          </a:bodyPr>
+          <a:lstStyle/>
+          <a:p>
+            <a:pPr algn="l">
+              <a:spcAft>
+                <a:spcPts val="600"/>
+              </a:spcAft>
+            </a:pPr>
+            <a:r>
+              <a:rPr lang="en-GB" sz="1600" b="1" i="0" dirty="0">
+                <a:solidFill>
+                  <a:srgbClr val="000000"/>
+                </a:solidFill>
+              </a:rPr>
+              <a:t>At our size, exact search wins</a:t>
+            </a:r>
+          </a:p>
+        </p:txBody>
+      </p:sp>
+      <p:sp>
+        <p:nvSpPr>
+          <p:cNvPr id="1005" name="TextBox 1005"/>
+          <p:cNvSpPr txBox="1"/>
+          <p:nvPr/>
+        </p:nvSpPr>
+        <p:spPr>
+          <a:xfrm>
+            <a:off x="8183880" y="2377440"/>
+            <a:ext cx="3657600" cy="822960"/>
+          </a:xfrm>
+          <a:prstGeom prst="rect">
+            <a:avLst/>
+          </a:prstGeom>
+          <a:noFill/>
+        </p:spPr>
+        <p:txBody>
+          <a:bodyPr wrap="square" lIns="0" rIns="0" tIns="0" bIns="0" anchor="ctr">
+            <a:normAutofit/>
+          </a:bodyPr>
+          <a:lstStyle/>
+          <a:p>
+            <a:pPr algn="l">
+              <a:spcAft>
+                <a:spcPts val="0"/>
+              </a:spcAft>
+            </a:pPr>
+            <a:r>
+              <a:rPr lang="en-GB" sz="4400" b="1" i="0" dirty="0">
+                <a:solidFill>
+                  <a:srgbClr val="EA161F"/>
+                </a:solidFill>
+              </a:rPr>
+              <a:t>0.5 ms</a:t>
+            </a:r>
+            <a:r>
+              <a:rPr lang="en-GB" sz="1500" b="0" i="0" dirty="0">
+                <a:solidFill>
+                  <a:srgbClr val="000000"/>
+                </a:solidFill>
+              </a:rPr>
+              <a:t> per query</a:t>
+            </a:r>
+          </a:p>
+        </p:txBody>
+      </p:sp>
+      <p:sp>
+        <p:nvSpPr>
+          <p:cNvPr id="1006" name="TextBox 1006"/>
+          <p:cNvSpPr txBox="1"/>
+          <p:nvPr/>
+        </p:nvSpPr>
+        <p:spPr>
+          <a:xfrm>
+            <a:off x="8183880" y="3200400"/>
+            <a:ext cx="3657600" cy="365760"/>
+          </a:xfrm>
+          <a:prstGeom prst="rect">
+            <a:avLst/>
+          </a:prstGeom>
+          <a:noFill/>
+        </p:spPr>
+        <p:txBody>
+          <a:bodyPr wrap="square" lIns="0" rIns="0" tIns="0" bIns="0" anchor="t">
+            <a:normAutofit/>
+          </a:bodyPr>
+          <a:lstStyle/>
+          <a:p>
+            <a:pPr algn="l">
+              <a:spcAft>
+                <a:spcPts val="600"/>
+              </a:spcAft>
+            </a:pPr>
+            <a:r>
+              <a:rPr lang="en-GB" sz="1300" b="0" i="0" dirty="0">
+                <a:solidFill>
+                  <a:srgbClr val="63737B"/>
+                </a:solidFill>
+              </a:rPr>
+              <a:t>exact, over all 5,666 chunks, in the app</a:t>
+            </a:r>
+          </a:p>
+        </p:txBody>
+      </p:sp>
+      <p:cxnSp>
+        <p:nvCxnSpPr>
+          <p:cNvPr id="1007" name="Connector 1007"/>
+          <p:cNvCxnSpPr/>
+          <p:nvPr/>
+        </p:nvCxnSpPr>
+        <p:spPr>
+          <a:xfrm>
+            <a:off x="8183880" y="4023360"/>
+            <a:ext cx="640080" cy="0"/>
+          </a:xfrm>
+          <a:prstGeom prst="line">
+            <a:avLst/>
+          </a:prstGeom>
+          <a:ln w="38100">
+            <a:solidFill>
+              <a:srgbClr val="000000"/>
+            </a:solidFill>
+          </a:ln>
+        </p:spPr>
+      </p:cxnSp>
+      <p:sp>
+        <p:nvSpPr>
+          <p:cNvPr id="1008" name="TextBox 1008"/>
+          <p:cNvSpPr txBox="1"/>
+          <p:nvPr/>
+        </p:nvSpPr>
+        <p:spPr>
+          <a:xfrm>
+            <a:off x="9006840" y="3794760"/>
+            <a:ext cx="2834640" cy="731520"/>
+          </a:xfrm>
+          <a:prstGeom prst="rect">
+            <a:avLst/>
+          </a:prstGeom>
+          <a:noFill/>
+        </p:spPr>
+        <p:txBody>
+          <a:bodyPr wrap="square" lIns="0" rIns="0" tIns="0" bIns="0" anchor="t">
+            <a:normAutofit/>
+          </a:bodyPr>
+          <a:lstStyle/>
+          <a:p>
+            <a:pPr algn="l">
+              <a:spcAft>
+                <a:spcPts val="200"/>
+              </a:spcAft>
+            </a:pPr>
+            <a:r>
+              <a:rPr lang="en-GB" sz="1500" b="1" i="0" dirty="0">
+                <a:solidFill>
+                  <a:srgbClr val="000000"/>
+                </a:solidFill>
+              </a:rPr>
+              <a:t>17× slower</a:t>
+            </a:r>
+          </a:p>
+          <a:p>
+            <a:pPr algn="l">
+              <a:spcAft>
+                <a:spcPts val="200"/>
+              </a:spcAft>
+            </a:pPr>
+            <a:r>
+              <a:rPr lang="en-GB" sz="1300" b="0" i="0" dirty="0">
+                <a:solidFill>
+                  <a:srgbClr val="63737B"/>
+                </a:solidFill>
+              </a:rPr>
+              <a:t>pgvector, for the same exact result</a:t>
+            </a:r>
+          </a:p>
+        </p:txBody>
+      </p:sp>
+      <p:cxnSp>
+        <p:nvCxnSpPr>
+          <p:cNvPr id="1009" name="Connector 1009"/>
+          <p:cNvCxnSpPr/>
+          <p:nvPr/>
+        </p:nvCxnSpPr>
+        <p:spPr>
+          <a:xfrm>
+            <a:off x="8183880" y="4800600"/>
+            <a:ext cx="640080" cy="0"/>
+          </a:xfrm>
+          <a:prstGeom prst="line">
+            <a:avLst/>
+          </a:prstGeom>
+          <a:ln w="38100">
+            <a:solidFill>
+              <a:srgbClr val="EA161F"/>
+            </a:solidFill>
+          </a:ln>
+        </p:spPr>
+      </p:cxnSp>
+      <p:sp>
+        <p:nvSpPr>
+          <p:cNvPr id="1010" name="TextBox 1010"/>
+          <p:cNvSpPr txBox="1"/>
+          <p:nvPr/>
+        </p:nvSpPr>
+        <p:spPr>
+          <a:xfrm>
+            <a:off x="9006840" y="4572000"/>
+            <a:ext cx="2834640" cy="731520"/>
+          </a:xfrm>
+          <a:prstGeom prst="rect">
+            <a:avLst/>
+          </a:prstGeom>
+          <a:noFill/>
+        </p:spPr>
+        <p:txBody>
+          <a:bodyPr wrap="square" lIns="0" rIns="0" tIns="0" bIns="0" anchor="t">
+            <a:normAutofit/>
+          </a:bodyPr>
+          <a:lstStyle/>
+          <a:p>
+            <a:pPr algn="l">
+              <a:spcAft>
+                <a:spcPts val="200"/>
+              </a:spcAft>
+            </a:pPr>
+            <a:r>
+              <a:rPr lang="en-GB" sz="1500" b="1" i="0" dirty="0">
+                <a:solidFill>
+                  <a:srgbClr val="000000"/>
+                </a:solidFill>
+              </a:rPr>
+              <a:t>Fails silently</a:t>
+            </a:r>
+          </a:p>
+          <a:p>
+            <a:pPr algn="l">
+              <a:spcAft>
+                <a:spcPts val="200"/>
+              </a:spcAft>
+            </a:pPr>
+            <a:r>
+              <a:rPr lang="en-GB" sz="1300" b="0" i="0" dirty="0">
+                <a:solidFill>
+                  <a:srgbClr val="63737B"/>
+                </a:solidFill>
+              </a:rPr>
+              <a:t>default returns 40 of 200; filters ~none</a:t>
+            </a:r>
+          </a:p>
+        </p:txBody>
+      </p:sp>
+      <p:cxnSp>
+        <p:nvCxnSpPr>
+          <p:cNvPr id="1011" name="Connector 1011"/>
+          <p:cNvCxnSpPr/>
+          <p:nvPr/>
+        </p:nvCxnSpPr>
+        <p:spPr>
+          <a:xfrm>
+            <a:off x="8183880" y="5577840"/>
+            <a:ext cx="640080" cy="0"/>
+          </a:xfrm>
+          <a:prstGeom prst="line">
+            <a:avLst/>
+          </a:prstGeom>
+          <a:ln w="38100">
+            <a:solidFill>
+              <a:srgbClr val="B1B9BD"/>
+            </a:solidFill>
+          </a:ln>
+        </p:spPr>
+      </p:cxnSp>
+      <p:sp>
+        <p:nvSpPr>
+          <p:cNvPr id="1012" name="TextBox 1012"/>
+          <p:cNvSpPr txBox="1"/>
+          <p:nvPr/>
+        </p:nvSpPr>
+        <p:spPr>
+          <a:xfrm>
+            <a:off x="9006840" y="5349240"/>
+            <a:ext cx="2834640" cy="731520"/>
+          </a:xfrm>
+          <a:prstGeom prst="rect">
+            <a:avLst/>
+          </a:prstGeom>
+          <a:noFill/>
+        </p:spPr>
+        <p:txBody>
+          <a:bodyPr wrap="square" lIns="0" rIns="0" tIns="0" bIns="0" anchor="t">
+            <a:normAutofit/>
+          </a:bodyPr>
+          <a:lstStyle/>
+          <a:p>
+            <a:pPr algn="l">
+              <a:spcAft>
+                <a:spcPts val="200"/>
+              </a:spcAft>
+            </a:pPr>
+            <a:r>
+              <a:rPr lang="en-GB" sz="1500" b="1" i="0" dirty="0">
+                <a:solidFill>
+                  <a:srgbClr val="000000"/>
+                </a:solidFill>
+              </a:rPr>
+              <a:t>Swap point past ~100k</a:t>
+            </a:r>
+          </a:p>
+          <a:p>
+            <a:pPr algn="l">
+              <a:spcAft>
+                <a:spcPts val="200"/>
+              </a:spcAft>
+            </a:pPr>
+            <a:r>
+              <a:rPr lang="en-GB" sz="1300" b="0" i="0" dirty="0">
+                <a:solidFill>
+                  <a:srgbClr val="63737B"/>
+                </a:solidFill>
+              </a:rPr>
+              <a:t>one function: _rank_lists in search/query.py</a:t>
+            </a:r>
+          </a:p>
+        </p:txBody>
+      </p:sp>
+    </p:spTree>
+  </p:cSld>
+  <p:clrMapOvr>
+    <a:masterClrMapping/>
+  </p:clrMapOvr>
+  <p:transition spd="med">
+    <p:fade/>
+  </p:transition>
+</p:sld>
+</file>
+
+<file path=ppt/slides/slide22.xml><?xml version="1.0" encoding="utf-8"?>
+<p:sld xmlns:a="http://schemas.openxmlformats.org/drawingml/2006/main" xmlns:p="http://schemas.openxmlformats.org/presentationml/2006/main" xmlns:r="http://schemas.openxmlformats.org/officeDocument/2006/relationships">
+  <p:cSld>
+    <p:spTree>
+      <p:nvGrpSpPr>
+        <p:cNvPr id="1" name=""/>
+        <p:cNvGrpSpPr/>
+        <p:nvPr/>
+      </p:nvGrpSpPr>
+      <p:grpSpPr/>
+      <p:sp>
+        <p:nvSpPr>
+          <p:cNvPr id="2" name="Title 1"/>
+          <p:cNvSpPr>
+            <a:spLocks noGrp="1"/>
+          </p:cNvSpPr>
+          <p:nvPr>
+            <p:ph type="title"/>
+          </p:nvPr>
+        </p:nvSpPr>
+        <p:spPr/>
+        <p:txBody>
+          <a:bodyPr/>
+          <a:lstStyle/>
+          <a:p>
+            <a:r>
+              <a:t>Appendix · What we crawled, and why</a:t>
+            </a:r>
+          </a:p>
+        </p:txBody>
+      </p:sp>
+      <p:sp>
+        <p:nvSpPr>
+          <p:cNvPr id="901" name="Fußzeilenplatzhalter 4">
+            <a:extLst>
+              <a:ext uri="{FF2B5EF4-FFF2-40B4-BE49-F238E27FC236}">
+                <a16:creationId xmlns:a16="http://schemas.microsoft.com/office/drawing/2014/main" id="{C7FF4EBF-1F95-422C-ABDC-BAC99BA2526A}"/>
+              </a:ext>
+            </a:extLst>
+          </p:cNvPr>
+          <p:cNvSpPr>
+            <a:spLocks noGrp="1"/>
+          </p:cNvSpPr>
+          <p:nvPr>
+            <p:ph type="ftr" sz="quarter" idx="11"/>
+          </p:nvPr>
+        </p:nvSpPr>
+        <p:spPr/>
+        <p:txBody>
+          <a:bodyPr/>
+          <a:lstStyle/>
+          <a:p>
+            <a:r>
+              <a:rPr lang="de-CH"/>
+              <a:t>Team Ctrl+Free</a:t>
+            </a:r>
+            <a:endParaRPr lang="de-CH" dirty="0"/>
+          </a:p>
+        </p:txBody>
+      </p:sp>
+      <p:sp>
+        <p:nvSpPr>
+          <p:cNvPr id="902" name="Foliennummernplatzhalter 5">
+            <a:extLst>
+              <a:ext uri="{FF2B5EF4-FFF2-40B4-BE49-F238E27FC236}">
+                <a16:creationId xmlns:a16="http://schemas.microsoft.com/office/drawing/2014/main" id="{56A97AFD-16FE-4EA5-A888-4A84A29DE559}"/>
+              </a:ext>
+            </a:extLst>
+          </p:cNvPr>
+          <p:cNvSpPr>
+            <a:spLocks noGrp="1"/>
+          </p:cNvSpPr>
+          <p:nvPr>
+            <p:ph type="sldNum" sz="quarter" idx="12"/>
+          </p:nvPr>
+        </p:nvSpPr>
+        <p:spPr/>
+        <p:txBody>
+          <a:bodyPr/>
+          <a:lstStyle/>
+          <a:p>
+            <a:fld id="{442AD375-037F-43D0-B059-5172DA06796A}" type="slidenum">
+              <a:rPr lang="de-CH" smtClean="0"/>
+              <a:pPr/>
+              <a:t>21</a:t>
+            </a:fld>
+            <a:endParaRPr lang="de-CH" dirty="0"/>
+          </a:p>
+        </p:txBody>
+      </p:sp>
+      <p:cxnSp>
+        <p:nvCxnSpPr>
+          <p:cNvPr id="1013" name="Connector 1013"/>
+          <p:cNvCxnSpPr/>
+          <p:nvPr/>
+        </p:nvCxnSpPr>
+        <p:spPr>
+          <a:xfrm>
+            <a:off x="841248" y="2148840"/>
+            <a:ext cx="640080" cy="0"/>
+          </a:xfrm>
+          <a:prstGeom prst="line">
+            <a:avLst/>
+          </a:prstGeom>
+          <a:ln w="38100">
+            <a:solidFill>
+              <a:srgbClr val="000000"/>
+            </a:solidFill>
+          </a:ln>
+        </p:spPr>
+      </p:cxnSp>
+      <p:sp>
+        <p:nvSpPr>
+          <p:cNvPr id="1014" name="TextBox 1014"/>
+          <p:cNvSpPr txBox="1"/>
+          <p:nvPr/>
+        </p:nvSpPr>
+        <p:spPr>
+          <a:xfrm>
+            <a:off x="1664208" y="1920240"/>
+            <a:ext cx="5760720" cy="731520"/>
+          </a:xfrm>
+          <a:prstGeom prst="rect">
+            <a:avLst/>
+          </a:prstGeom>
+          <a:noFill/>
+        </p:spPr>
+        <p:txBody>
+          <a:bodyPr wrap="square" lIns="0" rIns="0" tIns="0" bIns="0" anchor="t">
+            <a:normAutofit/>
+          </a:bodyPr>
+          <a:lstStyle/>
+          <a:p>
+            <a:pPr algn="l">
+              <a:spcAft>
+                <a:spcPts val="200"/>
+              </a:spcAft>
+            </a:pPr>
+            <a:r>
+              <a:rPr lang="en-GB" sz="1500" b="1" i="0" dirty="0">
+                <a:solidFill>
+                  <a:srgbClr val="000000"/>
+                </a:solidFill>
+              </a:rPr>
+              <a:t>Diabetes Center Berne</a:t>
+            </a:r>
+          </a:p>
+          <a:p>
+            <a:pPr algn="l">
+              <a:spcAft>
+                <a:spcPts val="200"/>
+              </a:spcAft>
+            </a:pPr>
+            <a:r>
+              <a:rPr lang="en-GB" sz="1300" b="0" i="0" dirty="0">
+                <a:solidFill>
+                  <a:srgbClr val="63737B"/>
+                </a:solidFill>
+              </a:rPr>
+              <a:t>whole site, crawled completely · 450 pages</a:t>
+            </a:r>
+          </a:p>
+        </p:txBody>
+      </p:sp>
+      <p:cxnSp>
+        <p:nvCxnSpPr>
+          <p:cNvPr id="1015" name="Connector 1015"/>
+          <p:cNvCxnSpPr/>
+          <p:nvPr/>
+        </p:nvCxnSpPr>
+        <p:spPr>
+          <a:xfrm>
+            <a:off x="841248" y="2971800"/>
+            <a:ext cx="640080" cy="0"/>
+          </a:xfrm>
+          <a:prstGeom prst="line">
+            <a:avLst/>
+          </a:prstGeom>
+          <a:ln w="38100">
+            <a:solidFill>
+              <a:srgbClr val="000000"/>
+            </a:solidFill>
+          </a:ln>
+        </p:spPr>
+      </p:cxnSp>
+      <p:sp>
+        <p:nvSpPr>
+          <p:cNvPr id="1016" name="TextBox 1016"/>
+          <p:cNvSpPr txBox="1"/>
+          <p:nvPr/>
+        </p:nvSpPr>
+        <p:spPr>
+          <a:xfrm>
+            <a:off x="1664208" y="2743200"/>
+            <a:ext cx="5760720" cy="731520"/>
+          </a:xfrm>
+          <a:prstGeom prst="rect">
+            <a:avLst/>
+          </a:prstGeom>
+          <a:noFill/>
+        </p:spPr>
+        <p:txBody>
+          <a:bodyPr wrap="square" lIns="0" rIns="0" tIns="0" bIns="0" anchor="t">
+            <a:normAutofit/>
+          </a:bodyPr>
+          <a:lstStyle/>
+          <a:p>
+            <a:pPr algn="l">
+              <a:spcAft>
+                <a:spcPts val="200"/>
+              </a:spcAft>
+            </a:pPr>
+            <a:r>
+              <a:rPr lang="en-GB" sz="1500" b="1" i="0" dirty="0">
+                <a:solidFill>
+                  <a:srgbClr val="000000"/>
+                </a:solidFill>
+              </a:rPr>
+              <a:t>ARTORG</a:t>
+            </a:r>
+          </a:p>
+          <a:p>
+            <a:pPr algn="l">
+              <a:spcAft>
+                <a:spcPts val="200"/>
+              </a:spcAft>
+            </a:pPr>
+            <a:r>
+              <a:rPr lang="en-GB" sz="1300" b="0" i="0" dirty="0">
+                <a:solidFill>
+                  <a:srgbClr val="63737B"/>
+                </a:solidFill>
+              </a:rPr>
+              <a:t>research section, crawled completely · 363 pages</a:t>
+            </a:r>
+          </a:p>
+        </p:txBody>
+      </p:sp>
+      <p:cxnSp>
+        <p:nvCxnSpPr>
+          <p:cNvPr id="1017" name="Connector 1017"/>
+          <p:cNvCxnSpPr/>
+          <p:nvPr/>
+        </p:nvCxnSpPr>
+        <p:spPr>
+          <a:xfrm>
+            <a:off x="841248" y="3794760"/>
+            <a:ext cx="640080" cy="0"/>
+          </a:xfrm>
+          <a:prstGeom prst="line">
+            <a:avLst/>
+          </a:prstGeom>
+          <a:ln w="38100">
+            <a:solidFill>
+              <a:srgbClr val="EA161F"/>
+            </a:solidFill>
+          </a:ln>
+        </p:spPr>
+      </p:cxnSp>
+      <p:sp>
+        <p:nvSpPr>
+          <p:cNvPr id="1018" name="TextBox 1018"/>
+          <p:cNvSpPr txBox="1"/>
+          <p:nvPr/>
+        </p:nvSpPr>
+        <p:spPr>
+          <a:xfrm>
+            <a:off x="1664208" y="3566160"/>
+            <a:ext cx="5760720" cy="731520"/>
+          </a:xfrm>
+          <a:prstGeom prst="rect">
+            <a:avLst/>
+          </a:prstGeom>
+          <a:noFill/>
+        </p:spPr>
+        <p:txBody>
+          <a:bodyPr wrap="square" lIns="0" rIns="0" tIns="0" bIns="0" anchor="t">
+            <a:normAutofit/>
+          </a:bodyPr>
+          <a:lstStyle/>
+          <a:p>
+            <a:pPr algn="l">
+              <a:spcAft>
+                <a:spcPts val="200"/>
+              </a:spcAft>
+            </a:pPr>
+            <a:r>
+              <a:rPr lang="en-GB" sz="1500" b="1" i="0" dirty="0">
+                <a:solidFill>
+                  <a:srgbClr val="000000"/>
+                </a:solidFill>
+              </a:rPr>
+              <a:t>University of Bern · 14 more inventory sites</a:t>
+            </a:r>
+          </a:p>
+          <a:p>
+            <a:pPr algn="l">
+              <a:spcAft>
+                <a:spcPts val="200"/>
+              </a:spcAft>
+            </a:pPr>
+            <a:r>
+              <a:rPr lang="en-GB" sz="1300" b="0" i="0" dirty="0">
+                <a:solidFill>
+                  <a:srgbClr val="63737B"/>
+                </a:solidFill>
+              </a:rPr>
+              <a:t>life science and medtech, up to 200 pages each · 2,213 pages</a:t>
+            </a:r>
+          </a:p>
+        </p:txBody>
+      </p:sp>
+      <p:sp>
+        <p:nvSpPr>
+          <p:cNvPr id="1019" name="Rectangle 1019"/>
+          <p:cNvSpPr/>
+          <p:nvPr/>
+        </p:nvSpPr>
+        <p:spPr>
+          <a:xfrm>
+            <a:off x="841248" y="4526280"/>
+            <a:ext cx="6583680" cy="1417320"/>
+          </a:xfrm>
+          <a:prstGeom prst="rect">
+            <a:avLst/>
+          </a:prstGeom>
+          <a:solidFill>
+            <a:srgbClr val="EEF1F2"/>
+          </a:solidFill>
+          <a:ln>
+            <a:noFill/>
+          </a:ln>
+          <a:effectLst/>
+        </p:spPr>
+        <p:txBody>
+          <a:bodyPr rtlCol="0" anchor="ctr"/>
+          <a:lstStyle/>
+          <a:p/>
+        </p:txBody>
+      </p:sp>
+      <p:sp>
+        <p:nvSpPr>
+          <p:cNvPr id="1020" name="TextBox 1020"/>
+          <p:cNvSpPr txBox="1"/>
+          <p:nvPr/>
+        </p:nvSpPr>
+        <p:spPr>
+          <a:xfrm>
+            <a:off x="1024128" y="4617720"/>
+            <a:ext cx="6217920" cy="1234440"/>
+          </a:xfrm>
+          <a:prstGeom prst="rect">
+            <a:avLst/>
+          </a:prstGeom>
+          <a:noFill/>
+        </p:spPr>
+        <p:txBody>
+          <a:bodyPr wrap="square" lIns="0" rIns="0" tIns="0" bIns="0" anchor="ctr">
+            <a:normAutofit/>
+          </a:bodyPr>
+          <a:lstStyle/>
+          <a:p>
+            <a:pPr algn="l">
+              <a:spcAft>
+                <a:spcPts val="400"/>
+              </a:spcAft>
+            </a:pPr>
+            <a:r>
+              <a:rPr lang="en-GB" sz="1500" b="1" i="0" dirty="0">
+                <a:solidFill>
+                  <a:srgbClr val="000000"/>
+                </a:solidFill>
+              </a:rPr>
+              <a:t>3,026 pages → 5,666 chunks → 1,417 people, 335 units</a:t>
+            </a:r>
+          </a:p>
+          <a:p>
+            <a:pPr algn="l">
+              <a:spcAft>
+                <a:spcPts val="0"/>
+              </a:spcAft>
+            </a:pPr>
+            <a:r>
+              <a:rPr lang="en-GB" sz="1300" b="0" i="0" dirty="0">
+                <a:solidFill>
+                  <a:srgbClr val="63737B"/>
+                </a:solidFill>
+              </a:rPr>
+              <a:t>Apertus 8B extracted facts from 1,859 pages. The quote check kept 6,385 and dropped 4,318 (40%): that is the cost of nothing invented.</a:t>
+            </a:r>
+          </a:p>
+        </p:txBody>
+      </p:sp>
+      <p:cxnSp>
+        <p:nvCxnSpPr>
+          <p:cNvPr id="1021" name="Connector 1021"/>
+          <p:cNvCxnSpPr/>
+          <p:nvPr/>
+        </p:nvCxnSpPr>
+        <p:spPr>
+          <a:xfrm>
+            <a:off x="7818120" y="1920240"/>
+            <a:ext cx="0" cy="4297680"/>
+          </a:xfrm>
+          <a:prstGeom prst="line">
+            <a:avLst/>
+          </a:prstGeom>
+          <a:ln w="9525">
+            <a:solidFill>
+              <a:srgbClr val="B1B9BD"/>
+            </a:solidFill>
+          </a:ln>
+        </p:spPr>
+      </p:cxnSp>
+      <p:sp>
+        <p:nvSpPr>
+          <p:cNvPr id="1022" name="TextBox 1022"/>
+          <p:cNvSpPr txBox="1"/>
+          <p:nvPr/>
+        </p:nvSpPr>
+        <p:spPr>
+          <a:xfrm>
+            <a:off x="8183880" y="1920240"/>
+            <a:ext cx="3657600" cy="365760"/>
+          </a:xfrm>
+          <a:prstGeom prst="rect">
+            <a:avLst/>
+          </a:prstGeom>
+          <a:noFill/>
+        </p:spPr>
+        <p:txBody>
+          <a:bodyPr wrap="square" lIns="0" rIns="0" tIns="0" bIns="0" anchor="t">
+            <a:normAutofit/>
+          </a:bodyPr>
+          <a:lstStyle/>
+          <a:p>
+            <a:pPr algn="l">
+              <a:spcAft>
+                <a:spcPts val="600"/>
+              </a:spcAft>
+            </a:pPr>
+            <a:r>
+              <a:rPr lang="en-GB" sz="1600" b="1" i="0" dirty="0">
+                <a:solidFill>
+                  <a:srgbClr val="000000"/>
+                </a:solidFill>
+              </a:rPr>
+              <a:t>Our choice, not the case's limit</a:t>
+            </a:r>
+          </a:p>
+        </p:txBody>
+      </p:sp>
+      <p:sp>
+        <p:nvSpPr>
+          <p:cNvPr id="1023" name="TextBox 1023"/>
+          <p:cNvSpPr txBox="1"/>
+          <p:nvPr/>
+        </p:nvSpPr>
+        <p:spPr>
+          <a:xfrm>
+            <a:off x="8183880" y="2377440"/>
+            <a:ext cx="3657600" cy="1005840"/>
+          </a:xfrm>
+          <a:prstGeom prst="rect">
+            <a:avLst/>
+          </a:prstGeom>
+          <a:noFill/>
+        </p:spPr>
+        <p:txBody>
+          <a:bodyPr wrap="square" lIns="0" rIns="0" tIns="0" bIns="0" anchor="t">
+            <a:normAutofit/>
+          </a:bodyPr>
+          <a:lstStyle/>
+          <a:p>
+            <a:pPr algn="l">
+              <a:spcAft>
+                <a:spcPts val="600"/>
+              </a:spcAft>
+            </a:pPr>
+            <a:r>
+              <a:rPr lang="en-GB" sz="1300" b="0" i="0" dirty="0">
+                <a:solidFill>
+                  <a:srgbClr val="63737B"/>
+                </a:solidFill>
+              </a:rPr>
+              <a:t>The case covers the whole UniBE inventory. We went deep on life science and medtech first, where Bern bids for companies.</a:t>
+            </a:r>
+          </a:p>
+        </p:txBody>
+      </p:sp>
+      <p:sp>
+        <p:nvSpPr>
+          <p:cNvPr id="1024" name="TextBox 1024"/>
+          <p:cNvSpPr txBox="1"/>
+          <p:nvPr/>
+        </p:nvSpPr>
+        <p:spPr>
+          <a:xfrm>
+            <a:off x="8183880" y="3474720"/>
+            <a:ext cx="3657600" cy="822960"/>
+          </a:xfrm>
+          <a:prstGeom prst="rect">
+            <a:avLst/>
+          </a:prstGeom>
+          <a:noFill/>
+        </p:spPr>
+        <p:txBody>
+          <a:bodyPr wrap="square" lIns="0" rIns="0" tIns="0" bIns="0" anchor="ctr">
+            <a:normAutofit/>
+          </a:bodyPr>
+          <a:lstStyle/>
+          <a:p>
+            <a:pPr algn="l">
+              <a:spcAft>
+                <a:spcPts val="0"/>
+              </a:spcAft>
+            </a:pPr>
+            <a:r>
+              <a:rPr lang="en-GB" sz="4400" b="1" i="0" dirty="0">
+                <a:solidFill>
+                  <a:srgbClr val="EA161F"/>
+                </a:solidFill>
+              </a:rPr>
+              <a:t>1 line</a:t>
+            </a:r>
+            <a:r>
+              <a:rPr lang="en-GB" sz="1500" b="0" i="0" dirty="0">
+                <a:solidFill>
+                  <a:srgbClr val="000000"/>
+                </a:solidFill>
+              </a:rPr>
+              <a:t> per new site</a:t>
+            </a:r>
+          </a:p>
+        </p:txBody>
+      </p:sp>
+      <p:sp>
+        <p:nvSpPr>
+          <p:cNvPr id="1025" name="TextBox 1025"/>
+          <p:cNvSpPr txBox="1"/>
+          <p:nvPr/>
+        </p:nvSpPr>
+        <p:spPr>
+          <a:xfrm>
+            <a:off x="8183880" y="4297680"/>
+            <a:ext cx="3657600" cy="365760"/>
+          </a:xfrm>
+          <a:prstGeom prst="rect">
+            <a:avLst/>
+          </a:prstGeom>
+          <a:noFill/>
+        </p:spPr>
+        <p:txBody>
+          <a:bodyPr wrap="square" lIns="0" rIns="0" tIns="0" bIns="0" anchor="t">
+            <a:normAutofit/>
+          </a:bodyPr>
+          <a:lstStyle/>
+          <a:p>
+            <a:pPr algn="l">
+              <a:spcAft>
+                <a:spcPts val="600"/>
+              </a:spcAft>
+            </a:pPr>
+            <a:r>
+              <a:rPr lang="en-GB" sz="1300" b="0" i="0" dirty="0">
+                <a:solidFill>
+                  <a:srgbClr val="63737B"/>
+                </a:solidFill>
+              </a:rPr>
+              <a:t>then crawl, extract, verify, index</a:t>
+            </a:r>
+          </a:p>
+        </p:txBody>
+      </p:sp>
+      <p:cxnSp>
+        <p:nvCxnSpPr>
+          <p:cNvPr id="1026" name="Connector 1026"/>
+          <p:cNvCxnSpPr/>
+          <p:nvPr/>
+        </p:nvCxnSpPr>
+        <p:spPr>
+          <a:xfrm>
+            <a:off x="8183880" y="5074920"/>
+            <a:ext cx="640080" cy="0"/>
+          </a:xfrm>
+          <a:prstGeom prst="line">
+            <a:avLst/>
+          </a:prstGeom>
+          <a:ln w="38100">
+            <a:solidFill>
+              <a:srgbClr val="B1B9BD"/>
+            </a:solidFill>
+          </a:ln>
+        </p:spPr>
+      </p:cxnSp>
+      <p:sp>
+        <p:nvSpPr>
+          <p:cNvPr id="1027" name="TextBox 1027"/>
+          <p:cNvSpPr txBox="1"/>
+          <p:nvPr/>
+        </p:nvSpPr>
+        <p:spPr>
+          <a:xfrm>
+            <a:off x="9006840" y="4846320"/>
+            <a:ext cx="2834640" cy="731520"/>
+          </a:xfrm>
+          <a:prstGeom prst="rect">
+            <a:avLst/>
+          </a:prstGeom>
+          <a:noFill/>
+        </p:spPr>
+        <p:txBody>
+          <a:bodyPr wrap="square" lIns="0" rIns="0" tIns="0" bIns="0" anchor="t">
+            <a:normAutofit/>
+          </a:bodyPr>
+          <a:lstStyle/>
+          <a:p>
+            <a:pPr algn="l">
+              <a:spcAft>
+                <a:spcPts val="200"/>
+              </a:spcAft>
+            </a:pPr>
+            <a:r>
+              <a:rPr lang="en-GB" sz="1500" b="1" i="0" dirty="0">
+                <a:solidFill>
+                  <a:srgbClr val="000000"/>
+                </a:solidFill>
+              </a:rPr>
+              <a:t>26 sites ready to add</a:t>
+            </a:r>
+          </a:p>
+          <a:p>
+            <a:pPr algn="l">
+              <a:spcAft>
+                <a:spcPts val="200"/>
+              </a:spcAft>
+            </a:pPr>
+            <a:r>
+              <a:rPr lang="en-GB" sz="1300" b="0" i="0" dirty="0">
+                <a:solidFill>
+                  <a:srgbClr val="63737B"/>
+                </a:solidFill>
+              </a:rPr>
+              <a:t>listed in inventory/unibe_all.tsv</a:t>
+            </a:r>
+          </a:p>
+        </p:txBody>
+      </p:sp>
+      <p:cxnSp>
+        <p:nvCxnSpPr>
+          <p:cNvPr id="1028" name="Connector 1028"/>
+          <p:cNvCxnSpPr/>
+          <p:nvPr/>
+        </p:nvCxnSpPr>
+        <p:spPr>
+          <a:xfrm>
+            <a:off x="8183880" y="5760720"/>
+            <a:ext cx="640080" cy="0"/>
+          </a:xfrm>
+          <a:prstGeom prst="line">
+            <a:avLst/>
+          </a:prstGeom>
+          <a:ln w="38100">
+            <a:solidFill>
+              <a:srgbClr val="B1B9BD"/>
+            </a:solidFill>
+          </a:ln>
+        </p:spPr>
+      </p:cxnSp>
+      <p:sp>
+        <p:nvSpPr>
+          <p:cNvPr id="1029" name="TextBox 1029"/>
+          <p:cNvSpPr txBox="1"/>
+          <p:nvPr/>
+        </p:nvSpPr>
+        <p:spPr>
+          <a:xfrm>
+            <a:off x="9006840" y="5532120"/>
+            <a:ext cx="2834640" cy="731520"/>
+          </a:xfrm>
+          <a:prstGeom prst="rect">
+            <a:avLst/>
+          </a:prstGeom>
+          <a:noFill/>
+        </p:spPr>
+        <p:txBody>
+          <a:bodyPr wrap="square" lIns="0" rIns="0" tIns="0" bIns="0" anchor="t">
+            <a:normAutofit/>
+          </a:bodyPr>
+          <a:lstStyle/>
+          <a:p>
+            <a:pPr algn="l">
+              <a:spcAft>
+                <a:spcPts val="200"/>
+              </a:spcAft>
+            </a:pPr>
+            <a:r>
+              <a:rPr lang="en-GB" sz="1500" b="1" i="0" dirty="0">
+                <a:solidFill>
+                  <a:srgbClr val="000000"/>
+                </a:solidFill>
+              </a:rPr>
+              <a:t>All 42 still fit</a:t>
+            </a:r>
+          </a:p>
+          <a:p>
+            <a:pPr algn="l">
+              <a:spcAft>
+                <a:spcPts val="200"/>
+              </a:spcAft>
+            </a:pPr>
+            <a:r>
+              <a:rPr lang="en-GB" sz="1300" b="0" i="0" dirty="0">
+                <a:solidFill>
+                  <a:srgbClr val="63737B"/>
+                </a:solidFill>
+              </a:rPr>
+              <a:t>tens of thousands of chunks, still ms</a:t>
             </a:r>
           </a:p>
         </p:txBody>

</xml_diff>